<commit_message>
deck 2-4: movement 2 — what theory explains it (slides 11-18)
</commit_message>
<xml_diff>
--- a/course/lectures/act-2-delegation-and-control/04-failure-aware-engineering/2-4-Failure-Aware-Engineering.pptx
+++ b/course/lectures/act-2-delegation-and-control/04-failure-aware-engineering/2-4-Failure-Aware-Engineering.pptx
@@ -18,6 +18,14 @@
     <p:sldId id="263" r:id="rId14"/>
     <p:sldId id="264" r:id="rId15"/>
     <p:sldId id="265" r:id="rId16"/>
+    <p:sldId id="266" r:id="rId17"/>
+    <p:sldId id="267" r:id="rId18"/>
+    <p:sldId id="268" r:id="rId19"/>
+    <p:sldId id="269" r:id="rId20"/>
+    <p:sldId id="270" r:id="rId21"/>
+    <p:sldId id="271" r:id="rId22"/>
+    <p:sldId id="272" r:id="rId23"/>
+    <p:sldId id="273" r:id="rId24"/>
   </p:sldIdLst>
   <p:sldSz cx="9144000" cy="6858000" type="screen4x3"/>
   <p:notesSz cx="6858000" cy="9144000"/>
@@ -620,6 +628,641 @@
           <a:p>
             <a:r>
               <a:t>- ASK the footer question instead. It is genuinely difficult.</a:t>
+            </a:r>
+          </a:p>
+        </p:txBody>
+      </p:sp>
+      <p:sp>
+        <p:nvSpPr>
+          <p:cNvPr id="4" name="Slide Number Placeholder 3"/>
+          <p:cNvSpPr>
+            <a:spLocks noGrp="1"/>
+          </p:cNvSpPr>
+          <p:nvPr>
+            <p:ph type="sldNum" idx="5" sz="quarter"/>
+          </p:nvPr>
+        </p:nvSpPr>
+        <p:spPr/>
+      </p:sp>
+    </p:spTree>
+  </p:cSld>
+  <p:clrMapOvr>
+    <a:masterClrMapping/>
+  </p:clrMapOvr>
+</p:notes>
+</file>
+
+<file path=ppt/notesSlides/notesSlide11.xml><?xml version="1.0" encoding="utf-8"?>
+<p:notes xmlns:a="http://schemas.openxmlformats.org/drawingml/2006/main" xmlns:p="http://schemas.openxmlformats.org/presentationml/2006/main" xmlns:r="http://schemas.openxmlformats.org/officeDocument/2006/relationships">
+  <p:cSld>
+    <p:spTree>
+      <p:nvGrpSpPr>
+        <p:cNvPr id="1" name=""/>
+        <p:cNvGrpSpPr/>
+        <p:nvPr/>
+      </p:nvGrpSpPr>
+      <p:grpSpPr>
+        <a:xfrm>
+          <a:off x="0" y="0"/>
+          <a:ext cx="0" cy="0"/>
+          <a:chOff x="0" y="0"/>
+          <a:chExt cx="0" cy="0"/>
+        </a:xfrm>
+      </p:grpSpPr>
+      <p:sp>
+        <p:nvSpPr>
+          <p:cNvPr id="2" name="Slide Image Placeholder 1"/>
+          <p:cNvSpPr>
+            <a:spLocks noGrp="1"/>
+          </p:cNvSpPr>
+          <p:nvPr>
+            <p:ph type="sldImg" idx="2"/>
+          </p:nvPr>
+        </p:nvSpPr>
+        <p:spPr/>
+      </p:sp>
+      <p:sp>
+        <p:nvSpPr>
+          <p:cNvPr id="3" name="Notes Placeholder 2"/>
+          <p:cNvSpPr>
+            <a:spLocks noGrp="1"/>
+          </p:cNvSpPr>
+          <p:nvPr>
+            <p:ph type="body" idx="3" sz="quarter"/>
+          </p:nvPr>
+        </p:nvSpPr>
+        <p:spPr/>
+        <p:txBody>
+          <a:bodyPr/>
+          <a:lstStyle/>
+          <a:p>
+            <a:r>
+              <a:t>TIMING: &lt;1 minute</a:t>
+            </a:r>
+          </a:p>
+          <a:p>
+            <a:r>
+              <a:t>- Transition: the lecture now asks what theory explains what we just saw.</a:t>
+            </a:r>
+          </a:p>
+          <a:p>
+            <a:r>
+              <a:t>- Four causal models follow; each will be tested against the story.</a:t>
+            </a:r>
+          </a:p>
+        </p:txBody>
+      </p:sp>
+      <p:sp>
+        <p:nvSpPr>
+          <p:cNvPr id="4" name="Slide Number Placeholder 3"/>
+          <p:cNvSpPr>
+            <a:spLocks noGrp="1"/>
+          </p:cNvSpPr>
+          <p:nvPr>
+            <p:ph type="sldNum" idx="5" sz="quarter"/>
+          </p:nvPr>
+        </p:nvSpPr>
+        <p:spPr/>
+      </p:sp>
+    </p:spTree>
+  </p:cSld>
+  <p:clrMapOvr>
+    <a:masterClrMapping/>
+  </p:clrMapOvr>
+</p:notes>
+</file>
+
+<file path=ppt/notesSlides/notesSlide12.xml><?xml version="1.0" encoding="utf-8"?>
+<p:notes xmlns:a="http://schemas.openxmlformats.org/drawingml/2006/main" xmlns:p="http://schemas.openxmlformats.org/presentationml/2006/main" xmlns:r="http://schemas.openxmlformats.org/officeDocument/2006/relationships">
+  <p:cSld>
+    <p:spTree>
+      <p:nvGrpSpPr>
+        <p:cNvPr id="1" name=""/>
+        <p:cNvGrpSpPr/>
+        <p:nvPr/>
+      </p:nvGrpSpPr>
+      <p:grpSpPr>
+        <a:xfrm>
+          <a:off x="0" y="0"/>
+          <a:ext cx="0" cy="0"/>
+          <a:chOff x="0" y="0"/>
+          <a:chExt cx="0" cy="0"/>
+        </a:xfrm>
+      </p:grpSpPr>
+      <p:sp>
+        <p:nvSpPr>
+          <p:cNvPr id="2" name="Slide Image Placeholder 1"/>
+          <p:cNvSpPr>
+            <a:spLocks noGrp="1"/>
+          </p:cNvSpPr>
+          <p:nvPr>
+            <p:ph type="sldImg" idx="2"/>
+          </p:nvPr>
+        </p:nvSpPr>
+        <p:spPr/>
+      </p:sp>
+      <p:sp>
+        <p:nvSpPr>
+          <p:cNvPr id="3" name="Notes Placeholder 2"/>
+          <p:cNvSpPr>
+            <a:spLocks noGrp="1"/>
+          </p:cNvSpPr>
+          <p:nvPr>
+            <p:ph type="body" idx="3" sz="quarter"/>
+          </p:nvPr>
+        </p:nvSpPr>
+        <p:spPr/>
+        <p:txBody>
+          <a:bodyPr/>
+          <a:lstStyle/>
+          <a:p>
+            <a:r>
+              <a:t>TIMING: 2 minutes</a:t>
+            </a:r>
+          </a:p>
+          <a:p>
+            <a:r>
+              <a:t>- Put student answers on screen, verbatim, as they come.</a:t>
+            </a:r>
+          </a:p>
+          <a:p>
+            <a:r>
+              <a:t>- Keep the list visible; the next slides test candidate causal models against it.</a:t>
+            </a:r>
+          </a:p>
+        </p:txBody>
+      </p:sp>
+      <p:sp>
+        <p:nvSpPr>
+          <p:cNvPr id="4" name="Slide Number Placeholder 3"/>
+          <p:cNvSpPr>
+            <a:spLocks noGrp="1"/>
+          </p:cNvSpPr>
+          <p:nvPr>
+            <p:ph type="sldNum" idx="5" sz="quarter"/>
+          </p:nvPr>
+        </p:nvSpPr>
+        <p:spPr/>
+      </p:sp>
+    </p:spTree>
+  </p:cSld>
+  <p:clrMapOvr>
+    <a:masterClrMapping/>
+  </p:clrMapOvr>
+</p:notes>
+</file>
+
+<file path=ppt/notesSlides/notesSlide13.xml><?xml version="1.0" encoding="utf-8"?>
+<p:notes xmlns:a="http://schemas.openxmlformats.org/drawingml/2006/main" xmlns:p="http://schemas.openxmlformats.org/presentationml/2006/main" xmlns:r="http://schemas.openxmlformats.org/officeDocument/2006/relationships">
+  <p:cSld>
+    <p:spTree>
+      <p:nvGrpSpPr>
+        <p:cNvPr id="1" name=""/>
+        <p:cNvGrpSpPr/>
+        <p:nvPr/>
+      </p:nvGrpSpPr>
+      <p:grpSpPr>
+        <a:xfrm>
+          <a:off x="0" y="0"/>
+          <a:ext cx="0" cy="0"/>
+          <a:chOff x="0" y="0"/>
+          <a:chExt cx="0" cy="0"/>
+        </a:xfrm>
+      </p:grpSpPr>
+      <p:sp>
+        <p:nvSpPr>
+          <p:cNvPr id="2" name="Slide Image Placeholder 1"/>
+          <p:cNvSpPr>
+            <a:spLocks noGrp="1"/>
+          </p:cNvSpPr>
+          <p:nvPr>
+            <p:ph type="sldImg" idx="2"/>
+          </p:nvPr>
+        </p:nvSpPr>
+        <p:spPr/>
+      </p:sp>
+      <p:sp>
+        <p:nvSpPr>
+          <p:cNvPr id="3" name="Notes Placeholder 2"/>
+          <p:cNvSpPr>
+            <a:spLocks noGrp="1"/>
+          </p:cNvSpPr>
+          <p:nvPr>
+            <p:ph type="body" idx="3" sz="quarter"/>
+          </p:nvPr>
+        </p:nvSpPr>
+        <p:spPr/>
+        <p:txBody>
+          <a:bodyPr/>
+          <a:lstStyle/>
+          <a:p>
+            <a:r>
+              <a:t>TIMING: 1-2 minutes</a:t>
+            </a:r>
+          </a:p>
+          <a:p>
+            <a:r>
+              <a:t>- Test it against the story: objections, escalation, authorization, delegation to IAV, year-after-year certification. One individual does not account for that.</a:t>
+            </a:r>
+          </a:p>
+        </p:txBody>
+      </p:sp>
+      <p:sp>
+        <p:nvSpPr>
+          <p:cNvPr id="4" name="Slide Number Placeholder 3"/>
+          <p:cNvSpPr>
+            <a:spLocks noGrp="1"/>
+          </p:cNvSpPr>
+          <p:nvPr>
+            <p:ph type="sldNum" idx="5" sz="quarter"/>
+          </p:nvPr>
+        </p:nvSpPr>
+        <p:spPr/>
+      </p:sp>
+    </p:spTree>
+  </p:cSld>
+  <p:clrMapOvr>
+    <a:masterClrMapping/>
+  </p:clrMapOvr>
+</p:notes>
+</file>
+
+<file path=ppt/notesSlides/notesSlide14.xml><?xml version="1.0" encoding="utf-8"?>
+<p:notes xmlns:a="http://schemas.openxmlformats.org/drawingml/2006/main" xmlns:p="http://schemas.openxmlformats.org/presentationml/2006/main" xmlns:r="http://schemas.openxmlformats.org/officeDocument/2006/relationships">
+  <p:cSld>
+    <p:spTree>
+      <p:nvGrpSpPr>
+        <p:cNvPr id="1" name=""/>
+        <p:cNvGrpSpPr/>
+        <p:nvPr/>
+      </p:nvGrpSpPr>
+      <p:grpSpPr>
+        <a:xfrm>
+          <a:off x="0" y="0"/>
+          <a:ext cx="0" cy="0"/>
+          <a:chOff x="0" y="0"/>
+          <a:chExt cx="0" cy="0"/>
+        </a:xfrm>
+      </p:grpSpPr>
+      <p:sp>
+        <p:nvSpPr>
+          <p:cNvPr id="2" name="Slide Image Placeholder 1"/>
+          <p:cNvSpPr>
+            <a:spLocks noGrp="1"/>
+          </p:cNvSpPr>
+          <p:nvPr>
+            <p:ph type="sldImg" idx="2"/>
+          </p:nvPr>
+        </p:nvSpPr>
+        <p:spPr/>
+      </p:sp>
+      <p:sp>
+        <p:nvSpPr>
+          <p:cNvPr id="3" name="Notes Placeholder 2"/>
+          <p:cNvSpPr>
+            <a:spLocks noGrp="1"/>
+          </p:cNvSpPr>
+          <p:nvPr>
+            <p:ph type="body" idx="3" sz="quarter"/>
+          </p:nvPr>
+        </p:nvSpPr>
+        <p:spPr/>
+        <p:txBody>
+          <a:bodyPr/>
+          <a:lstStyle/>
+          <a:p>
+            <a:r>
+              <a:t>TIMING: 1-2 minutes</a:t>
+            </a:r>
+          </a:p>
+          <a:p>
+            <a:r>
+              <a:t>- Layered defenses, each imperfect; the accident traverses aligned holes.</a:t>
+            </a:r>
+          </a:p>
+          <a:p>
+            <a:r>
+              <a:t>- Test it against the story: which defenses existed, and where were the holes? The intervention unit becomes the defenses, not the individual.</a:t>
+            </a:r>
+          </a:p>
+        </p:txBody>
+      </p:sp>
+      <p:sp>
+        <p:nvSpPr>
+          <p:cNvPr id="4" name="Slide Number Placeholder 3"/>
+          <p:cNvSpPr>
+            <a:spLocks noGrp="1"/>
+          </p:cNvSpPr>
+          <p:nvPr>
+            <p:ph type="sldNum" idx="5" sz="quarter"/>
+          </p:nvPr>
+        </p:nvSpPr>
+        <p:spPr/>
+      </p:sp>
+    </p:spTree>
+  </p:cSld>
+  <p:clrMapOvr>
+    <a:masterClrMapping/>
+  </p:clrMapOvr>
+</p:notes>
+</file>
+
+<file path=ppt/notesSlides/notesSlide15.xml><?xml version="1.0" encoding="utf-8"?>
+<p:notes xmlns:a="http://schemas.openxmlformats.org/drawingml/2006/main" xmlns:p="http://schemas.openxmlformats.org/presentationml/2006/main" xmlns:r="http://schemas.openxmlformats.org/officeDocument/2006/relationships">
+  <p:cSld>
+    <p:spTree>
+      <p:nvGrpSpPr>
+        <p:cNvPr id="1" name=""/>
+        <p:cNvGrpSpPr/>
+        <p:nvPr/>
+      </p:nvGrpSpPr>
+      <p:grpSpPr>
+        <a:xfrm>
+          <a:off x="0" y="0"/>
+          <a:ext cx="0" cy="0"/>
+          <a:chOff x="0" y="0"/>
+          <a:chExt cx="0" cy="0"/>
+        </a:xfrm>
+      </p:grpSpPr>
+      <p:sp>
+        <p:nvSpPr>
+          <p:cNvPr id="2" name="Slide Image Placeholder 1"/>
+          <p:cNvSpPr>
+            <a:spLocks noGrp="1"/>
+          </p:cNvSpPr>
+          <p:nvPr>
+            <p:ph type="sldImg" idx="2"/>
+          </p:nvPr>
+        </p:nvSpPr>
+        <p:spPr/>
+      </p:sp>
+      <p:sp>
+        <p:nvSpPr>
+          <p:cNvPr id="3" name="Notes Placeholder 2"/>
+          <p:cNvSpPr>
+            <a:spLocks noGrp="1"/>
+          </p:cNvSpPr>
+          <p:nvPr>
+            <p:ph type="body" idx="3" sz="quarter"/>
+          </p:nvPr>
+        </p:nvSpPr>
+        <p:spPr/>
+        <p:txBody>
+          <a:bodyPr/>
+          <a:lstStyle/>
+          <a:p>
+            <a:r>
+              <a:t>TIMING: 1-2 minutes</a:t>
+            </a:r>
+          </a:p>
+          <a:p>
+            <a:r>
+              <a:t>- The causal story moves up a level: the conditions that shaped behavior, not the behavior alone.</a:t>
+            </a:r>
+          </a:p>
+          <a:p>
+            <a:r>
+              <a:t>- Test it against the story: what conditions sustained the same result model year after model year?</a:t>
+            </a:r>
+          </a:p>
+        </p:txBody>
+      </p:sp>
+      <p:sp>
+        <p:nvSpPr>
+          <p:cNvPr id="4" name="Slide Number Placeholder 3"/>
+          <p:cNvSpPr>
+            <a:spLocks noGrp="1"/>
+          </p:cNvSpPr>
+          <p:nvPr>
+            <p:ph type="sldNum" idx="5" sz="quarter"/>
+          </p:nvPr>
+        </p:nvSpPr>
+        <p:spPr/>
+      </p:sp>
+    </p:spTree>
+  </p:cSld>
+  <p:clrMapOvr>
+    <a:masterClrMapping/>
+  </p:clrMapOvr>
+</p:notes>
+</file>
+
+<file path=ppt/notesSlides/notesSlide16.xml><?xml version="1.0" encoding="utf-8"?>
+<p:notes xmlns:a="http://schemas.openxmlformats.org/drawingml/2006/main" xmlns:p="http://schemas.openxmlformats.org/presentationml/2006/main" xmlns:r="http://schemas.openxmlformats.org/officeDocument/2006/relationships">
+  <p:cSld>
+    <p:spTree>
+      <p:nvGrpSpPr>
+        <p:cNvPr id="1" name=""/>
+        <p:cNvGrpSpPr/>
+        <p:nvPr/>
+      </p:nvGrpSpPr>
+      <p:grpSpPr>
+        <a:xfrm>
+          <a:off x="0" y="0"/>
+          <a:ext cx="0" cy="0"/>
+          <a:chOff x="0" y="0"/>
+          <a:chExt cx="0" cy="0"/>
+        </a:xfrm>
+      </p:grpSpPr>
+      <p:sp>
+        <p:nvSpPr>
+          <p:cNvPr id="2" name="Slide Image Placeholder 1"/>
+          <p:cNvSpPr>
+            <a:spLocks noGrp="1"/>
+          </p:cNvSpPr>
+          <p:nvPr>
+            <p:ph type="sldImg" idx="2"/>
+          </p:nvPr>
+        </p:nvSpPr>
+        <p:spPr/>
+      </p:sp>
+      <p:sp>
+        <p:nvSpPr>
+          <p:cNvPr id="3" name="Notes Placeholder 2"/>
+          <p:cNvSpPr>
+            <a:spLocks noGrp="1"/>
+          </p:cNvSpPr>
+          <p:nvPr>
+            <p:ph type="body" idx="3" sz="quarter"/>
+          </p:nvPr>
+        </p:nvSpPr>
+        <p:spPr/>
+        <p:txBody>
+          <a:bodyPr/>
+          <a:lstStyle/>
+          <a:p>
+            <a:r>
+              <a:t>TIMING: 2 minutes</a:t>
+            </a:r>
+          </a:p>
+          <a:p>
+            <a:r>
+              <a:t>- [Author: the old slide-12 STAMP narration lands here.]</a:t>
+            </a:r>
+          </a:p>
+          <a:p>
+            <a:r>
+              <a:t>- A systems-theoretic account: include every level of control and feedback, from regulators down to the operating process.</a:t>
+            </a:r>
+          </a:p>
+        </p:txBody>
+      </p:sp>
+      <p:sp>
+        <p:nvSpPr>
+          <p:cNvPr id="4" name="Slide Number Placeholder 3"/>
+          <p:cNvSpPr>
+            <a:spLocks noGrp="1"/>
+          </p:cNvSpPr>
+          <p:nvPr>
+            <p:ph type="sldNum" idx="5" sz="quarter"/>
+          </p:nvPr>
+        </p:nvSpPr>
+        <p:spPr/>
+      </p:sp>
+    </p:spTree>
+  </p:cSld>
+  <p:clrMapOvr>
+    <a:masterClrMapping/>
+  </p:clrMapOvr>
+</p:notes>
+</file>
+
+<file path=ppt/notesSlides/notesSlide17.xml><?xml version="1.0" encoding="utf-8"?>
+<p:notes xmlns:a="http://schemas.openxmlformats.org/drawingml/2006/main" xmlns:p="http://schemas.openxmlformats.org/presentationml/2006/main" xmlns:r="http://schemas.openxmlformats.org/officeDocument/2006/relationships">
+  <p:cSld>
+    <p:spTree>
+      <p:nvGrpSpPr>
+        <p:cNvPr id="1" name=""/>
+        <p:cNvGrpSpPr/>
+        <p:nvPr/>
+      </p:nvGrpSpPr>
+      <p:grpSpPr>
+        <a:xfrm>
+          <a:off x="0" y="0"/>
+          <a:ext cx="0" cy="0"/>
+          <a:chOff x="0" y="0"/>
+          <a:chExt cx="0" cy="0"/>
+        </a:xfrm>
+      </p:grpSpPr>
+      <p:sp>
+        <p:nvSpPr>
+          <p:cNvPr id="2" name="Slide Image Placeholder 1"/>
+          <p:cNvSpPr>
+            <a:spLocks noGrp="1"/>
+          </p:cNvSpPr>
+          <p:nvPr>
+            <p:ph type="sldImg" idx="2"/>
+          </p:nvPr>
+        </p:nvSpPr>
+        <p:spPr/>
+      </p:sp>
+      <p:sp>
+        <p:nvSpPr>
+          <p:cNvPr id="3" name="Notes Placeholder 2"/>
+          <p:cNvSpPr>
+            <a:spLocks noGrp="1"/>
+          </p:cNvSpPr>
+          <p:nvPr>
+            <p:ph type="body" idx="3" sz="quarter"/>
+          </p:nvPr>
+        </p:nvSpPr>
+        <p:spPr/>
+        <p:txBody>
+          <a:bodyPr/>
+          <a:lstStyle/>
+          <a:p>
+            <a:r>
+              <a:t>TIMING: 1-2 minutes</a:t>
+            </a:r>
+          </a:p>
+          <a:p>
+            <a:r>
+              <a:t>- Each model includes more of the causal story than the last.</a:t>
+            </a:r>
+          </a:p>
+          <a:p>
+            <a:r>
+              <a:t>- But a more complete account is not automatically a more usable one: as the account widens, more of it lies outside what any one engineer or team can change.</a:t>
+            </a:r>
+          </a:p>
+        </p:txBody>
+      </p:sp>
+      <p:sp>
+        <p:nvSpPr>
+          <p:cNvPr id="4" name="Slide Number Placeholder 3"/>
+          <p:cNvSpPr>
+            <a:spLocks noGrp="1"/>
+          </p:cNvSpPr>
+          <p:nvPr>
+            <p:ph type="sldNum" idx="5" sz="quarter"/>
+          </p:nvPr>
+        </p:nvSpPr>
+        <p:spPr/>
+      </p:sp>
+    </p:spTree>
+  </p:cSld>
+  <p:clrMapOvr>
+    <a:masterClrMapping/>
+  </p:clrMapOvr>
+</p:notes>
+</file>
+
+<file path=ppt/notesSlides/notesSlide18.xml><?xml version="1.0" encoding="utf-8"?>
+<p:notes xmlns:a="http://schemas.openxmlformats.org/drawingml/2006/main" xmlns:p="http://schemas.openxmlformats.org/presentationml/2006/main" xmlns:r="http://schemas.openxmlformats.org/officeDocument/2006/relationships">
+  <p:cSld>
+    <p:spTree>
+      <p:nvGrpSpPr>
+        <p:cNvPr id="1" name=""/>
+        <p:cNvGrpSpPr/>
+        <p:nvPr/>
+      </p:nvGrpSpPr>
+      <p:grpSpPr>
+        <a:xfrm>
+          <a:off x="0" y="0"/>
+          <a:ext cx="0" cy="0"/>
+          <a:chOff x="0" y="0"/>
+          <a:chExt cx="0" cy="0"/>
+        </a:xfrm>
+      </p:grpSpPr>
+      <p:sp>
+        <p:nvSpPr>
+          <p:cNvPr id="2" name="Slide Image Placeholder 1"/>
+          <p:cNvSpPr>
+            <a:spLocks noGrp="1"/>
+          </p:cNvSpPr>
+          <p:nvPr>
+            <p:ph type="sldImg" idx="2"/>
+          </p:nvPr>
+        </p:nvSpPr>
+        <p:spPr/>
+      </p:sp>
+      <p:sp>
+        <p:nvSpPr>
+          <p:cNvPr id="3" name="Notes Placeholder 2"/>
+          <p:cNvSpPr>
+            <a:spLocks noGrp="1"/>
+          </p:cNvSpPr>
+          <p:nvPr>
+            <p:ph type="body" idx="3" sz="quarter"/>
+          </p:nvPr>
+        </p:nvSpPr>
+        <p:spPr/>
+        <p:txBody>
+          <a:bodyPr/>
+          <a:lstStyle/>
+          <a:p>
+            <a:r>
+              <a:t>TIMING: 2 minutes</a:t>
+            </a:r>
+          </a:p>
+          <a:p>
+            <a:r>
+              <a:t>- Now the line has concrete meaning rather than being abstract modeling doctrine.</a:t>
+            </a:r>
+          </a:p>
+          <a:p>
+            <a:r>
+              <a:t>- Connect back to the student answers from the opening slide of this section: each answer was implicitly one of these models.</a:t>
             </a:r>
           </a:p>
         </p:txBody>
@@ -4803,7 +5446,7 @@
           <a:bodyPr/>
           <a:lstStyle/>
           <a:p>
-            <a:fld id="{816E3789-B5D4-4D26-A238-A73BD05DD330}" type="slidenum">
+            <a:fld id="{F93E8548-BE24-4B73-8C45-416AEFC32254}" type="slidenum">
               <a:rPr lang="en-US" smtClean="0"/>
               <a:t>1</a:t>
             </a:fld>
@@ -4998,7 +5641,7 @@
           <a:bodyPr/>
           <a:lstStyle/>
           <a:p>
-            <a:fld id="{D272814A-38F1-4019-9F03-5F3DC73EAF22}" type="slidenum">
+            <a:fld id="{30A64256-7292-44E1-BB62-C6E0605EA3D2}" type="slidenum">
               <a:rPr lang="en-US" smtClean="0"/>
               <a:t>10</a:t>
             </a:fld>
@@ -5472,6 +6115,3277 @@
                 </a:solidFill>
               </a:rPr>
               <a:t>Where does responsibility lie in a failure produced and sustained by many people and mechanisms?</a:t>
+            </a:r>
+          </a:p>
+        </p:txBody>
+      </p:sp>
+    </p:spTree>
+  </p:cSld>
+  <p:clrMapOvr>
+    <a:masterClrMapping/>
+  </p:clrMapOvr>
+</p:sld>
+</file>
+
+<file path=ppt/slides/slide11.xml><?xml version="1.0" encoding="utf-8"?>
+<p:sld xmlns:a="http://schemas.openxmlformats.org/drawingml/2006/main" xmlns:p="http://schemas.openxmlformats.org/presentationml/2006/main" xmlns:r="http://schemas.openxmlformats.org/officeDocument/2006/relationships">
+  <p:cSld>
+    <p:spTree>
+      <p:nvGrpSpPr>
+        <p:cNvPr id="1" name=""/>
+        <p:cNvGrpSpPr/>
+        <p:nvPr/>
+      </p:nvGrpSpPr>
+      <p:grpSpPr/>
+      <p:sp>
+        <p:nvSpPr>
+          <p:cNvPr id="2" name="Title 1"/>
+          <p:cNvSpPr>
+            <a:spLocks noGrp="1"/>
+          </p:cNvSpPr>
+          <p:nvPr>
+            <p:ph type="title"/>
+          </p:nvPr>
+        </p:nvSpPr>
+        <p:spPr>
+          <a:xfrm>
+            <a:off x="685800" y="1700784"/>
+            <a:ext cx="7772400" cy="1005840"/>
+          </a:xfrm>
+        </p:spPr>
+        <p:txBody>
+          <a:bodyPr/>
+          <a:lstStyle/>
+          <a:p>
+            <a:pPr algn="ctr"/>
+            <a:r>
+              <a:rPr sz="4000" b="0" i="0">
+                <a:solidFill>
+                  <a:srgbClr val="000000"/>
+                </a:solidFill>
+              </a:rPr>
+              <a:t>What theory explains it?</a:t>
+            </a:r>
+          </a:p>
+        </p:txBody>
+      </p:sp>
+      <p:sp>
+        <p:nvSpPr>
+          <p:cNvPr id="900" name="Slide Number Placeholder 900"/>
+          <p:cNvSpPr>
+            <a:spLocks noGrp="1"/>
+          </p:cNvSpPr>
+          <p:nvPr>
+            <p:ph type="sldNum" sz="quarter" idx="4"/>
+          </p:nvPr>
+        </p:nvSpPr>
+        <p:spPr/>
+        <p:txBody>
+          <a:bodyPr/>
+          <a:lstStyle/>
+          <a:p>
+            <a:fld id="{2154B390-ECC6-49D6-9ED6-BE29D357C40A}" type="slidenum">
+              <a:rPr lang="en-US" smtClean="0"/>
+              <a:t>11</a:t>
+            </a:fld>
+            <a:endParaRPr lang="en-US"/>
+          </a:p>
+        </p:txBody>
+      </p:sp>
+      <p:sp>
+        <p:nvSpPr>
+          <p:cNvPr id="901" name="SectionLabel"/>
+          <p:cNvSpPr txBox="1"/>
+          <p:nvPr/>
+        </p:nvSpPr>
+        <p:spPr>
+          <a:xfrm>
+            <a:off x="685800" y="1243584"/>
+            <a:ext cx="7772400" cy="365760"/>
+          </a:xfrm>
+          <a:prstGeom prst="rect">
+            <a:avLst/>
+          </a:prstGeom>
+          <a:noFill/>
+        </p:spPr>
+        <p:txBody>
+          <a:bodyPr wrap="square" anchor="ctr" lIns="27432" rIns="27432" tIns="22860" bIns="22860">
+            <a:spAutoFit/>
+          </a:bodyPr>
+          <a:lstStyle/>
+          <a:p>
+            <a:pPr algn="ctr"/>
+            <a:r>
+              <a:rPr sz="2000" b="1" i="0">
+                <a:solidFill>
+                  <a:srgbClr val="8E6F3E"/>
+                </a:solidFill>
+              </a:rPr>
+              <a:t>SECTION 1</a:t>
+            </a:r>
+          </a:p>
+        </p:txBody>
+      </p:sp>
+      <p:sp>
+        <p:nvSpPr>
+          <p:cNvPr id="902" name="Question"/>
+          <p:cNvSpPr txBox="1"/>
+          <p:nvPr/>
+        </p:nvSpPr>
+        <p:spPr>
+          <a:xfrm>
+            <a:off x="685800" y="2816352"/>
+            <a:ext cx="7772400" cy="475488"/>
+          </a:xfrm>
+          <a:prstGeom prst="rect">
+            <a:avLst/>
+          </a:prstGeom>
+          <a:noFill/>
+        </p:spPr>
+        <p:txBody>
+          <a:bodyPr wrap="square" anchor="ctr" lIns="27432" rIns="27432" tIns="22860" bIns="22860">
+            <a:spAutoFit/>
+          </a:bodyPr>
+          <a:lstStyle/>
+          <a:p>
+            <a:pPr algn="ctr"/>
+            <a:r>
+              <a:rPr sz="2400" b="0" i="0">
+                <a:solidFill>
+                  <a:srgbClr val="5C4826"/>
+                </a:solidFill>
+              </a:rPr>
+              <a:t>And what does each theory let you change?</a:t>
+            </a:r>
+          </a:p>
+        </p:txBody>
+      </p:sp>
+      <p:sp>
+        <p:nvSpPr>
+          <p:cNvPr id="903" name="Rule"/>
+          <p:cNvSpPr/>
+          <p:nvPr/>
+        </p:nvSpPr>
+        <p:spPr>
+          <a:xfrm>
+            <a:off x="3429000" y="3602736"/>
+            <a:ext cx="2286000" cy="51206"/>
+          </a:xfrm>
+          <a:prstGeom prst="rect">
+            <a:avLst/>
+          </a:prstGeom>
+          <a:solidFill>
+            <a:srgbClr val="8E6F3E"/>
+          </a:solidFill>
+          <a:ln>
+            <a:noFill/>
+          </a:ln>
+          <a:effectLst/>
+        </p:spPr>
+        <p:style>
+          <a:lnRef idx="1">
+            <a:schemeClr val="accent1"/>
+          </a:lnRef>
+          <a:fillRef idx="3">
+            <a:schemeClr val="accent1"/>
+          </a:fillRef>
+          <a:effectRef idx="2">
+            <a:schemeClr val="accent1"/>
+          </a:effectRef>
+          <a:fontRef idx="minor">
+            <a:schemeClr val="lt1"/>
+          </a:fontRef>
+        </p:style>
+        <p:txBody>
+          <a:bodyPr rtlCol="0" anchor="ctr" wrap="square" lIns="27432" rIns="27432" tIns="22860" bIns="22860"/>
+          <a:lstStyle/>
+          <a:p>
+            <a:pPr algn="ctr"/>
+            <a:r>
+              <a:rPr sz="2000" b="0" i="0">
+                <a:solidFill>
+                  <a:srgbClr val="5C4826"/>
+                </a:solidFill>
+              </a:rPr>
+              <a:t/>
+            </a:r>
+          </a:p>
+        </p:txBody>
+      </p:sp>
+    </p:spTree>
+  </p:cSld>
+  <p:clrMapOvr>
+    <a:masterClrMapping/>
+  </p:clrMapOvr>
+</p:sld>
+</file>
+
+<file path=ppt/slides/slide12.xml><?xml version="1.0" encoding="utf-8"?>
+<p:sld xmlns:a="http://schemas.openxmlformats.org/drawingml/2006/main" xmlns:p="http://schemas.openxmlformats.org/presentationml/2006/main" xmlns:r="http://schemas.openxmlformats.org/officeDocument/2006/relationships">
+  <p:cSld>
+    <p:spTree>
+      <p:nvGrpSpPr>
+        <p:cNvPr id="1" name=""/>
+        <p:cNvGrpSpPr/>
+        <p:nvPr/>
+      </p:nvGrpSpPr>
+      <p:grpSpPr/>
+      <p:sp>
+        <p:nvSpPr>
+          <p:cNvPr id="3" name="Title 2"/>
+          <p:cNvSpPr>
+            <a:spLocks noGrp="1"/>
+          </p:cNvSpPr>
+          <p:nvPr>
+            <p:ph type="title"/>
+          </p:nvPr>
+        </p:nvSpPr>
+        <p:spPr/>
+        <p:txBody>
+          <a:bodyPr/>
+          <a:lstStyle/>
+          <a:p>
+            <a:r>
+              <a:rPr sz="2400" b="0" i="0">
+                <a:solidFill>
+                  <a:srgbClr val="000000"/>
+                </a:solidFill>
+              </a:rPr>
+              <a:t>What caused the Volkswagen failure?</a:t>
+            </a:r>
+          </a:p>
+        </p:txBody>
+      </p:sp>
+      <p:sp>
+        <p:nvSpPr>
+          <p:cNvPr id="900" name="Slide Number Placeholder 900"/>
+          <p:cNvSpPr>
+            <a:spLocks noGrp="1"/>
+          </p:cNvSpPr>
+          <p:nvPr>
+            <p:ph type="sldNum" sz="quarter" idx="4"/>
+          </p:nvPr>
+        </p:nvSpPr>
+        <p:spPr/>
+        <p:txBody>
+          <a:bodyPr/>
+          <a:lstStyle/>
+          <a:p>
+            <a:fld id="{EDA5A793-673B-41D4-9210-552A38A95064}" type="slidenum">
+              <a:rPr lang="en-US" smtClean="0"/>
+              <a:t>12</a:t>
+            </a:fld>
+            <a:endParaRPr lang="en-US"/>
+          </a:p>
+        </p:txBody>
+      </p:sp>
+      <p:sp>
+        <p:nvSpPr>
+          <p:cNvPr id="901" name="Card"/>
+          <p:cNvSpPr/>
+          <p:nvPr/>
+        </p:nvSpPr>
+        <p:spPr>
+          <a:xfrm>
+            <a:off x="914400" y="1188720"/>
+            <a:ext cx="7315200" cy="4297680"/>
+          </a:xfrm>
+          <a:prstGeom prst="rect">
+            <a:avLst/>
+          </a:prstGeom>
+          <a:solidFill>
+            <a:srgbClr val="F5F1E8"/>
+          </a:solidFill>
+          <a:ln w="12700">
+            <a:solidFill>
+              <a:srgbClr val="C9B991"/>
+            </a:solidFill>
+          </a:ln>
+          <a:effectLst/>
+        </p:spPr>
+        <p:style>
+          <a:lnRef idx="1">
+            <a:schemeClr val="accent1"/>
+          </a:lnRef>
+          <a:fillRef idx="3">
+            <a:schemeClr val="accent1"/>
+          </a:fillRef>
+          <a:effectRef idx="2">
+            <a:schemeClr val="accent1"/>
+          </a:effectRef>
+          <a:fontRef idx="minor">
+            <a:schemeClr val="lt1"/>
+          </a:fontRef>
+        </p:style>
+        <p:txBody>
+          <a:bodyPr rtlCol="0" anchor="t" wrap="square" lIns="27432" rIns="27432" tIns="22860" bIns="22860"/>
+          <a:lstStyle/>
+          <a:p>
+            <a:pPr algn="ctr"/>
+            <a:r>
+              <a:rPr sz="2000" b="1" i="0">
+                <a:solidFill>
+                  <a:srgbClr val="5C4826"/>
+                </a:solidFill>
+              </a:rPr>
+              <a:t>Your answers</a:t>
+            </a:r>
+          </a:p>
+          <a:p>
+            <a:pPr algn="ctr">
+              <a:spcBef>
+                <a:spcPts val="1000"/>
+              </a:spcBef>
+            </a:pPr>
+            <a:r>
+              <a:rPr sz="2000" b="0" i="1">
+                <a:solidFill>
+                  <a:srgbClr val="555960"/>
+                </a:solidFill>
+              </a:rPr>
+              <a:t>(collected live)</a:t>
+            </a:r>
+          </a:p>
+        </p:txBody>
+      </p:sp>
+    </p:spTree>
+  </p:cSld>
+  <p:clrMapOvr>
+    <a:masterClrMapping/>
+  </p:clrMapOvr>
+</p:sld>
+</file>
+
+<file path=ppt/slides/slide13.xml><?xml version="1.0" encoding="utf-8"?>
+<p:sld xmlns:a="http://schemas.openxmlformats.org/drawingml/2006/main" xmlns:p="http://schemas.openxmlformats.org/presentationml/2006/main" xmlns:r="http://schemas.openxmlformats.org/officeDocument/2006/relationships">
+  <p:cSld>
+    <p:spTree>
+      <p:nvGrpSpPr>
+        <p:cNvPr id="1" name=""/>
+        <p:cNvGrpSpPr/>
+        <p:nvPr/>
+      </p:nvGrpSpPr>
+      <p:grpSpPr/>
+      <p:sp>
+        <p:nvSpPr>
+          <p:cNvPr id="3" name="Title 2"/>
+          <p:cNvSpPr>
+            <a:spLocks noGrp="1"/>
+          </p:cNvSpPr>
+          <p:nvPr>
+            <p:ph type="title"/>
+          </p:nvPr>
+        </p:nvSpPr>
+        <p:spPr/>
+        <p:txBody>
+          <a:bodyPr/>
+          <a:lstStyle/>
+          <a:p>
+            <a:r>
+              <a:rPr sz="2400" b="0" i="0">
+                <a:solidFill>
+                  <a:srgbClr val="000000"/>
+                </a:solidFill>
+              </a:rPr>
+              <a:t>Human error</a:t>
+            </a:r>
+          </a:p>
+        </p:txBody>
+      </p:sp>
+      <p:sp>
+        <p:nvSpPr>
+          <p:cNvPr id="900" name="Slide Number Placeholder 900"/>
+          <p:cNvSpPr>
+            <a:spLocks noGrp="1"/>
+          </p:cNvSpPr>
+          <p:nvPr>
+            <p:ph type="sldNum" sz="quarter" idx="4"/>
+          </p:nvPr>
+        </p:nvSpPr>
+        <p:spPr/>
+        <p:txBody>
+          <a:bodyPr/>
+          <a:lstStyle/>
+          <a:p>
+            <a:fld id="{B66BA63C-C0C7-4744-A213-840C7C36C170}" type="slidenum">
+              <a:rPr lang="en-US" smtClean="0"/>
+              <a:t>13</a:t>
+            </a:fld>
+            <a:endParaRPr lang="en-US"/>
+          </a:p>
+        </p:txBody>
+      </p:sp>
+      <p:sp>
+        <p:nvSpPr>
+          <p:cNvPr id="901" name="Card"/>
+          <p:cNvSpPr/>
+          <p:nvPr/>
+        </p:nvSpPr>
+        <p:spPr>
+          <a:xfrm>
+            <a:off x="548640" y="1463040"/>
+            <a:ext cx="3749039" cy="2377440"/>
+          </a:xfrm>
+          <a:prstGeom prst="rect">
+            <a:avLst/>
+          </a:prstGeom>
+          <a:solidFill>
+            <a:srgbClr val="F5F1E8"/>
+          </a:solidFill>
+          <a:ln w="12700">
+            <a:solidFill>
+              <a:srgbClr val="C9B991"/>
+            </a:solidFill>
+          </a:ln>
+          <a:effectLst/>
+        </p:spPr>
+        <p:style>
+          <a:lnRef idx="1">
+            <a:schemeClr val="accent1"/>
+          </a:lnRef>
+          <a:fillRef idx="3">
+            <a:schemeClr val="accent1"/>
+          </a:fillRef>
+          <a:effectRef idx="2">
+            <a:schemeClr val="accent1"/>
+          </a:effectRef>
+          <a:fontRef idx="minor">
+            <a:schemeClr val="lt1"/>
+          </a:fontRef>
+        </p:style>
+        <p:txBody>
+          <a:bodyPr rtlCol="0" anchor="ctr" wrap="square" lIns="27432" rIns="27432" tIns="22860" bIns="22860"/>
+          <a:lstStyle/>
+          <a:p>
+            <a:pPr algn="ctr"/>
+            <a:r>
+              <a:rPr sz="2000" b="1" i="0">
+                <a:solidFill>
+                  <a:srgbClr val="5C4826"/>
+                </a:solidFill>
+              </a:rPr>
+              <a:t>CAUSAL MODEL</a:t>
+            </a:r>
+          </a:p>
+          <a:p>
+            <a:pPr algn="ctr">
+              <a:spcBef>
+                <a:spcPts val="1200"/>
+              </a:spcBef>
+            </a:pPr>
+            <a:r>
+              <a:rPr sz="2000" b="0" i="0">
+                <a:solidFill>
+                  <a:srgbClr val="555960"/>
+                </a:solidFill>
+              </a:rPr>
+              <a:t>An individual erred.</a:t>
+            </a:r>
+          </a:p>
+        </p:txBody>
+      </p:sp>
+      <p:cxnSp>
+        <p:nvCxnSpPr>
+          <p:cNvPr id="902" name="Connector 901"/>
+          <p:cNvCxnSpPr/>
+          <p:nvPr/>
+        </p:nvCxnSpPr>
+        <p:spPr>
+          <a:xfrm>
+            <a:off x="4389120" y="2651760"/>
+            <a:ext cx="548640" cy="0"/>
+          </a:xfrm>
+          <a:prstGeom prst="line">
+            <a:avLst/>
+          </a:prstGeom>
+          <a:ln w="28575">
+            <a:solidFill>
+              <a:srgbClr val="8E6F3E"/>
+            </a:solidFill>
+            <a:tailEnd type="triangle"/>
+          </a:ln>
+        </p:spPr>
+        <p:style>
+          <a:lnRef idx="2">
+            <a:schemeClr val="accent1"/>
+          </a:lnRef>
+          <a:fillRef idx="0">
+            <a:schemeClr val="accent1"/>
+          </a:fillRef>
+          <a:effectRef idx="1">
+            <a:schemeClr val="accent1"/>
+          </a:effectRef>
+          <a:fontRef idx="minor">
+            <a:schemeClr val="tx1"/>
+          </a:fontRef>
+        </p:style>
+      </p:cxnSp>
+      <p:sp>
+        <p:nvSpPr>
+          <p:cNvPr id="903" name="Block"/>
+          <p:cNvSpPr/>
+          <p:nvPr/>
+        </p:nvSpPr>
+        <p:spPr>
+          <a:xfrm>
+            <a:off x="5029200" y="1463040"/>
+            <a:ext cx="3566160" cy="2377440"/>
+          </a:xfrm>
+          <a:prstGeom prst="rect">
+            <a:avLst/>
+          </a:prstGeom>
+          <a:solidFill>
+            <a:srgbClr val="8E6F3E"/>
+          </a:solidFill>
+          <a:ln>
+            <a:noFill/>
+          </a:ln>
+          <a:effectLst/>
+        </p:spPr>
+        <p:style>
+          <a:lnRef idx="1">
+            <a:schemeClr val="accent1"/>
+          </a:lnRef>
+          <a:fillRef idx="3">
+            <a:schemeClr val="accent1"/>
+          </a:fillRef>
+          <a:effectRef idx="2">
+            <a:schemeClr val="accent1"/>
+          </a:effectRef>
+          <a:fontRef idx="minor">
+            <a:schemeClr val="lt1"/>
+          </a:fontRef>
+        </p:style>
+        <p:txBody>
+          <a:bodyPr rtlCol="0" anchor="ctr" wrap="square" lIns="27432" rIns="27432" tIns="22860" bIns="22860"/>
+          <a:lstStyle/>
+          <a:p>
+            <a:pPr algn="ctr"/>
+            <a:r>
+              <a:rPr sz="2000" b="1" i="0">
+                <a:solidFill>
+                  <a:srgbClr val="FFFFFF"/>
+                </a:solidFill>
+              </a:rPr>
+              <a:t>ONE INTERVENTION</a:t>
+            </a:r>
+          </a:p>
+          <a:p>
+            <a:pPr algn="ctr"/>
+            <a:r>
+              <a:rPr sz="2000" b="0" i="0">
+                <a:solidFill>
+                  <a:srgbClr val="FFFFFF"/>
+                </a:solidFill>
+              </a:rPr>
+              <a:t>change the individual</a:t>
+            </a:r>
+          </a:p>
+        </p:txBody>
+      </p:sp>
+      <p:sp>
+        <p:nvSpPr>
+          <p:cNvPr id="904" name="FooterBand"/>
+          <p:cNvSpPr/>
+          <p:nvPr/>
+        </p:nvSpPr>
+        <p:spPr>
+          <a:xfrm>
+            <a:off x="274320" y="5852159"/>
+            <a:ext cx="8595360" cy="566928"/>
+          </a:xfrm>
+          <a:prstGeom prst="rect">
+            <a:avLst/>
+          </a:prstGeom>
+          <a:solidFill>
+            <a:srgbClr val="8E6F3E"/>
+          </a:solidFill>
+          <a:ln>
+            <a:noFill/>
+          </a:ln>
+          <a:effectLst/>
+        </p:spPr>
+        <p:style>
+          <a:lnRef idx="1">
+            <a:schemeClr val="accent1"/>
+          </a:lnRef>
+          <a:fillRef idx="3">
+            <a:schemeClr val="accent1"/>
+          </a:fillRef>
+          <a:effectRef idx="2">
+            <a:schemeClr val="accent1"/>
+          </a:effectRef>
+          <a:fontRef idx="minor">
+            <a:schemeClr val="lt1"/>
+          </a:fontRef>
+        </p:style>
+        <p:txBody>
+          <a:bodyPr rtlCol="0" anchor="ctr" wrap="square" lIns="27432" rIns="27432" tIns="22860" bIns="22860"/>
+          <a:lstStyle/>
+          <a:p>
+            <a:pPr algn="ctr"/>
+            <a:r>
+              <a:rPr sz="2000" b="1" i="0">
+                <a:solidFill>
+                  <a:srgbClr val="FFFFFF"/>
+                </a:solidFill>
+              </a:rPr>
+              <a:t>Useful, but gives one intervention.</a:t>
+            </a:r>
+          </a:p>
+        </p:txBody>
+      </p:sp>
+    </p:spTree>
+  </p:cSld>
+  <p:clrMapOvr>
+    <a:masterClrMapping/>
+  </p:clrMapOvr>
+</p:sld>
+</file>
+
+<file path=ppt/slides/slide14.xml><?xml version="1.0" encoding="utf-8"?>
+<p:sld xmlns:a="http://schemas.openxmlformats.org/drawingml/2006/main" xmlns:p="http://schemas.openxmlformats.org/presentationml/2006/main" xmlns:r="http://schemas.openxmlformats.org/officeDocument/2006/relationships">
+  <p:cSld>
+    <p:spTree>
+      <p:nvGrpSpPr>
+        <p:cNvPr id="1" name=""/>
+        <p:cNvGrpSpPr/>
+        <p:nvPr/>
+      </p:nvGrpSpPr>
+      <p:grpSpPr/>
+      <p:sp>
+        <p:nvSpPr>
+          <p:cNvPr id="3" name="Title 2"/>
+          <p:cNvSpPr>
+            <a:spLocks noGrp="1"/>
+          </p:cNvSpPr>
+          <p:nvPr>
+            <p:ph type="title"/>
+          </p:nvPr>
+        </p:nvSpPr>
+        <p:spPr/>
+        <p:txBody>
+          <a:bodyPr/>
+          <a:lstStyle/>
+          <a:p>
+            <a:r>
+              <a:rPr sz="2400" b="0" i="0">
+                <a:solidFill>
+                  <a:srgbClr val="000000"/>
+                </a:solidFill>
+              </a:rPr>
+              <a:t>Swiss cheese</a:t>
+            </a:r>
+          </a:p>
+        </p:txBody>
+      </p:sp>
+      <p:sp>
+        <p:nvSpPr>
+          <p:cNvPr id="900" name="Slide Number Placeholder 900"/>
+          <p:cNvSpPr>
+            <a:spLocks noGrp="1"/>
+          </p:cNvSpPr>
+          <p:nvPr>
+            <p:ph type="sldNum" sz="quarter" idx="4"/>
+          </p:nvPr>
+        </p:nvSpPr>
+        <p:spPr/>
+        <p:txBody>
+          <a:bodyPr/>
+          <a:lstStyle/>
+          <a:p>
+            <a:fld id="{6501156A-E1E9-4402-8057-F65D8D28B12B}" type="slidenum">
+              <a:rPr lang="en-US" smtClean="0"/>
+              <a:t>14</a:t>
+            </a:fld>
+            <a:endParaRPr lang="en-US"/>
+          </a:p>
+        </p:txBody>
+      </p:sp>
+      <p:sp>
+        <p:nvSpPr>
+          <p:cNvPr id="901" name="Slab"/>
+          <p:cNvSpPr/>
+          <p:nvPr/>
+        </p:nvSpPr>
+        <p:spPr>
+          <a:xfrm>
+            <a:off x="1463040" y="1280160"/>
+            <a:ext cx="1005840" cy="3657600"/>
+          </a:xfrm>
+          <a:prstGeom prst="rect">
+            <a:avLst/>
+          </a:prstGeom>
+          <a:solidFill>
+            <a:srgbClr val="F5F1E8"/>
+          </a:solidFill>
+          <a:ln w="12700">
+            <a:solidFill>
+              <a:srgbClr val="C9B991"/>
+            </a:solidFill>
+          </a:ln>
+          <a:effectLst/>
+        </p:spPr>
+        <p:style>
+          <a:lnRef idx="1">
+            <a:schemeClr val="accent1"/>
+          </a:lnRef>
+          <a:fillRef idx="3">
+            <a:schemeClr val="accent1"/>
+          </a:fillRef>
+          <a:effectRef idx="2">
+            <a:schemeClr val="accent1"/>
+          </a:effectRef>
+          <a:fontRef idx="minor">
+            <a:schemeClr val="lt1"/>
+          </a:fontRef>
+        </p:style>
+        <p:txBody>
+          <a:bodyPr rtlCol="0" anchor="t" wrap="square" lIns="27432" rIns="27432" tIns="22860" bIns="22860"/>
+          <a:lstStyle/>
+          <a:p>
+            <a:pPr algn="ctr"/>
+            <a:r>
+              <a:rPr sz="2000" b="0" i="0">
+                <a:solidFill>
+                  <a:srgbClr val="5C4826"/>
+                </a:solidFill>
+              </a:rPr>
+              <a:t/>
+            </a:r>
+          </a:p>
+        </p:txBody>
+      </p:sp>
+      <p:sp>
+        <p:nvSpPr>
+          <p:cNvPr id="902" name="Hole"/>
+          <p:cNvSpPr/>
+          <p:nvPr/>
+        </p:nvSpPr>
+        <p:spPr>
+          <a:xfrm>
+            <a:off x="1764792" y="1920240"/>
+            <a:ext cx="402336" cy="402336"/>
+          </a:xfrm>
+          <a:prstGeom prst="ellipse">
+            <a:avLst/>
+          </a:prstGeom>
+          <a:solidFill>
+            <a:srgbClr val="FFFFFF"/>
+          </a:solidFill>
+          <a:ln w="12700">
+            <a:solidFill>
+              <a:srgbClr val="C9B991"/>
+            </a:solidFill>
+          </a:ln>
+          <a:effectLst/>
+        </p:spPr>
+        <p:style>
+          <a:lnRef idx="1">
+            <a:schemeClr val="accent1"/>
+          </a:lnRef>
+          <a:fillRef idx="3">
+            <a:schemeClr val="accent1"/>
+          </a:fillRef>
+          <a:effectRef idx="2">
+            <a:schemeClr val="accent1"/>
+          </a:effectRef>
+          <a:fontRef idx="minor">
+            <a:schemeClr val="lt1"/>
+          </a:fontRef>
+        </p:style>
+        <p:txBody>
+          <a:bodyPr rtlCol="0" anchor="ctr" wrap="square" lIns="27432" rIns="27432" tIns="22860" bIns="22860"/>
+          <a:lstStyle/>
+          <a:p>
+            <a:pPr algn="ctr"/>
+            <a:r>
+              <a:rPr sz="2000" b="0" i="0">
+                <a:solidFill>
+                  <a:srgbClr val="5C4826"/>
+                </a:solidFill>
+              </a:rPr>
+              <a:t/>
+            </a:r>
+          </a:p>
+        </p:txBody>
+      </p:sp>
+      <p:sp>
+        <p:nvSpPr>
+          <p:cNvPr id="903" name="Hole"/>
+          <p:cNvSpPr/>
+          <p:nvPr/>
+        </p:nvSpPr>
+        <p:spPr>
+          <a:xfrm>
+            <a:off x="1764792" y="2788920"/>
+            <a:ext cx="402336" cy="402336"/>
+          </a:xfrm>
+          <a:prstGeom prst="ellipse">
+            <a:avLst/>
+          </a:prstGeom>
+          <a:solidFill>
+            <a:srgbClr val="FFFFFF"/>
+          </a:solidFill>
+          <a:ln w="12700">
+            <a:solidFill>
+              <a:srgbClr val="C9B991"/>
+            </a:solidFill>
+          </a:ln>
+          <a:effectLst/>
+        </p:spPr>
+        <p:style>
+          <a:lnRef idx="1">
+            <a:schemeClr val="accent1"/>
+          </a:lnRef>
+          <a:fillRef idx="3">
+            <a:schemeClr val="accent1"/>
+          </a:fillRef>
+          <a:effectRef idx="2">
+            <a:schemeClr val="accent1"/>
+          </a:effectRef>
+          <a:fontRef idx="minor">
+            <a:schemeClr val="lt1"/>
+          </a:fontRef>
+        </p:style>
+        <p:txBody>
+          <a:bodyPr rtlCol="0" anchor="ctr" wrap="square" lIns="27432" rIns="27432" tIns="22860" bIns="22860"/>
+          <a:lstStyle/>
+          <a:p>
+            <a:pPr algn="ctr"/>
+            <a:r>
+              <a:rPr sz="2000" b="0" i="0">
+                <a:solidFill>
+                  <a:srgbClr val="5C4826"/>
+                </a:solidFill>
+              </a:rPr>
+              <a:t/>
+            </a:r>
+          </a:p>
+        </p:txBody>
+      </p:sp>
+      <p:sp>
+        <p:nvSpPr>
+          <p:cNvPr id="904" name="Hole"/>
+          <p:cNvSpPr/>
+          <p:nvPr/>
+        </p:nvSpPr>
+        <p:spPr>
+          <a:xfrm>
+            <a:off x="1764792" y="3931920"/>
+            <a:ext cx="402336" cy="402336"/>
+          </a:xfrm>
+          <a:prstGeom prst="ellipse">
+            <a:avLst/>
+          </a:prstGeom>
+          <a:solidFill>
+            <a:srgbClr val="FFFFFF"/>
+          </a:solidFill>
+          <a:ln w="12700">
+            <a:solidFill>
+              <a:srgbClr val="C9B991"/>
+            </a:solidFill>
+          </a:ln>
+          <a:effectLst/>
+        </p:spPr>
+        <p:style>
+          <a:lnRef idx="1">
+            <a:schemeClr val="accent1"/>
+          </a:lnRef>
+          <a:fillRef idx="3">
+            <a:schemeClr val="accent1"/>
+          </a:fillRef>
+          <a:effectRef idx="2">
+            <a:schemeClr val="accent1"/>
+          </a:effectRef>
+          <a:fontRef idx="minor">
+            <a:schemeClr val="lt1"/>
+          </a:fontRef>
+        </p:style>
+        <p:txBody>
+          <a:bodyPr rtlCol="0" anchor="ctr" wrap="square" lIns="27432" rIns="27432" tIns="22860" bIns="22860"/>
+          <a:lstStyle/>
+          <a:p>
+            <a:pPr algn="ctr"/>
+            <a:r>
+              <a:rPr sz="2000" b="0" i="0">
+                <a:solidFill>
+                  <a:srgbClr val="5C4826"/>
+                </a:solidFill>
+              </a:rPr>
+              <a:t/>
+            </a:r>
+          </a:p>
+        </p:txBody>
+      </p:sp>
+      <p:sp>
+        <p:nvSpPr>
+          <p:cNvPr id="905" name="Slab"/>
+          <p:cNvSpPr/>
+          <p:nvPr/>
+        </p:nvSpPr>
+        <p:spPr>
+          <a:xfrm>
+            <a:off x="3108960" y="1280160"/>
+            <a:ext cx="1005840" cy="3657600"/>
+          </a:xfrm>
+          <a:prstGeom prst="rect">
+            <a:avLst/>
+          </a:prstGeom>
+          <a:solidFill>
+            <a:srgbClr val="F5F1E8"/>
+          </a:solidFill>
+          <a:ln w="12700">
+            <a:solidFill>
+              <a:srgbClr val="C9B991"/>
+            </a:solidFill>
+          </a:ln>
+          <a:effectLst/>
+        </p:spPr>
+        <p:style>
+          <a:lnRef idx="1">
+            <a:schemeClr val="accent1"/>
+          </a:lnRef>
+          <a:fillRef idx="3">
+            <a:schemeClr val="accent1"/>
+          </a:fillRef>
+          <a:effectRef idx="2">
+            <a:schemeClr val="accent1"/>
+          </a:effectRef>
+          <a:fontRef idx="minor">
+            <a:schemeClr val="lt1"/>
+          </a:fontRef>
+        </p:style>
+        <p:txBody>
+          <a:bodyPr rtlCol="0" anchor="t" wrap="square" lIns="27432" rIns="27432" tIns="22860" bIns="22860"/>
+          <a:lstStyle/>
+          <a:p>
+            <a:pPr algn="ctr"/>
+            <a:r>
+              <a:rPr sz="2000" b="0" i="0">
+                <a:solidFill>
+                  <a:srgbClr val="5C4826"/>
+                </a:solidFill>
+              </a:rPr>
+              <a:t/>
+            </a:r>
+          </a:p>
+        </p:txBody>
+      </p:sp>
+      <p:sp>
+        <p:nvSpPr>
+          <p:cNvPr id="906" name="Hole"/>
+          <p:cNvSpPr/>
+          <p:nvPr/>
+        </p:nvSpPr>
+        <p:spPr>
+          <a:xfrm>
+            <a:off x="3410712" y="1737360"/>
+            <a:ext cx="402336" cy="402336"/>
+          </a:xfrm>
+          <a:prstGeom prst="ellipse">
+            <a:avLst/>
+          </a:prstGeom>
+          <a:solidFill>
+            <a:srgbClr val="FFFFFF"/>
+          </a:solidFill>
+          <a:ln w="12700">
+            <a:solidFill>
+              <a:srgbClr val="C9B991"/>
+            </a:solidFill>
+          </a:ln>
+          <a:effectLst/>
+        </p:spPr>
+        <p:style>
+          <a:lnRef idx="1">
+            <a:schemeClr val="accent1"/>
+          </a:lnRef>
+          <a:fillRef idx="3">
+            <a:schemeClr val="accent1"/>
+          </a:fillRef>
+          <a:effectRef idx="2">
+            <a:schemeClr val="accent1"/>
+          </a:effectRef>
+          <a:fontRef idx="minor">
+            <a:schemeClr val="lt1"/>
+          </a:fontRef>
+        </p:style>
+        <p:txBody>
+          <a:bodyPr rtlCol="0" anchor="ctr" wrap="square" lIns="27432" rIns="27432" tIns="22860" bIns="22860"/>
+          <a:lstStyle/>
+          <a:p>
+            <a:pPr algn="ctr"/>
+            <a:r>
+              <a:rPr sz="2000" b="0" i="0">
+                <a:solidFill>
+                  <a:srgbClr val="5C4826"/>
+                </a:solidFill>
+              </a:rPr>
+              <a:t/>
+            </a:r>
+          </a:p>
+        </p:txBody>
+      </p:sp>
+      <p:sp>
+        <p:nvSpPr>
+          <p:cNvPr id="907" name="Hole"/>
+          <p:cNvSpPr/>
+          <p:nvPr/>
+        </p:nvSpPr>
+        <p:spPr>
+          <a:xfrm>
+            <a:off x="3410712" y="2788920"/>
+            <a:ext cx="402336" cy="402336"/>
+          </a:xfrm>
+          <a:prstGeom prst="ellipse">
+            <a:avLst/>
+          </a:prstGeom>
+          <a:solidFill>
+            <a:srgbClr val="FFFFFF"/>
+          </a:solidFill>
+          <a:ln w="12700">
+            <a:solidFill>
+              <a:srgbClr val="C9B991"/>
+            </a:solidFill>
+          </a:ln>
+          <a:effectLst/>
+        </p:spPr>
+        <p:style>
+          <a:lnRef idx="1">
+            <a:schemeClr val="accent1"/>
+          </a:lnRef>
+          <a:fillRef idx="3">
+            <a:schemeClr val="accent1"/>
+          </a:fillRef>
+          <a:effectRef idx="2">
+            <a:schemeClr val="accent1"/>
+          </a:effectRef>
+          <a:fontRef idx="minor">
+            <a:schemeClr val="lt1"/>
+          </a:fontRef>
+        </p:style>
+        <p:txBody>
+          <a:bodyPr rtlCol="0" anchor="ctr" wrap="square" lIns="27432" rIns="27432" tIns="22860" bIns="22860"/>
+          <a:lstStyle/>
+          <a:p>
+            <a:pPr algn="ctr"/>
+            <a:r>
+              <a:rPr sz="2000" b="0" i="0">
+                <a:solidFill>
+                  <a:srgbClr val="5C4826"/>
+                </a:solidFill>
+              </a:rPr>
+              <a:t/>
+            </a:r>
+          </a:p>
+        </p:txBody>
+      </p:sp>
+      <p:sp>
+        <p:nvSpPr>
+          <p:cNvPr id="908" name="Hole"/>
+          <p:cNvSpPr/>
+          <p:nvPr/>
+        </p:nvSpPr>
+        <p:spPr>
+          <a:xfrm>
+            <a:off x="3410712" y="4297680"/>
+            <a:ext cx="402336" cy="402336"/>
+          </a:xfrm>
+          <a:prstGeom prst="ellipse">
+            <a:avLst/>
+          </a:prstGeom>
+          <a:solidFill>
+            <a:srgbClr val="FFFFFF"/>
+          </a:solidFill>
+          <a:ln w="12700">
+            <a:solidFill>
+              <a:srgbClr val="C9B991"/>
+            </a:solidFill>
+          </a:ln>
+          <a:effectLst/>
+        </p:spPr>
+        <p:style>
+          <a:lnRef idx="1">
+            <a:schemeClr val="accent1"/>
+          </a:lnRef>
+          <a:fillRef idx="3">
+            <a:schemeClr val="accent1"/>
+          </a:fillRef>
+          <a:effectRef idx="2">
+            <a:schemeClr val="accent1"/>
+          </a:effectRef>
+          <a:fontRef idx="minor">
+            <a:schemeClr val="lt1"/>
+          </a:fontRef>
+        </p:style>
+        <p:txBody>
+          <a:bodyPr rtlCol="0" anchor="ctr" wrap="square" lIns="27432" rIns="27432" tIns="22860" bIns="22860"/>
+          <a:lstStyle/>
+          <a:p>
+            <a:pPr algn="ctr"/>
+            <a:r>
+              <a:rPr sz="2000" b="0" i="0">
+                <a:solidFill>
+                  <a:srgbClr val="5C4826"/>
+                </a:solidFill>
+              </a:rPr>
+              <a:t/>
+            </a:r>
+          </a:p>
+        </p:txBody>
+      </p:sp>
+      <p:sp>
+        <p:nvSpPr>
+          <p:cNvPr id="909" name="Slab"/>
+          <p:cNvSpPr/>
+          <p:nvPr/>
+        </p:nvSpPr>
+        <p:spPr>
+          <a:xfrm>
+            <a:off x="4754880" y="1280160"/>
+            <a:ext cx="1005840" cy="3657600"/>
+          </a:xfrm>
+          <a:prstGeom prst="rect">
+            <a:avLst/>
+          </a:prstGeom>
+          <a:solidFill>
+            <a:srgbClr val="F5F1E8"/>
+          </a:solidFill>
+          <a:ln w="12700">
+            <a:solidFill>
+              <a:srgbClr val="C9B991"/>
+            </a:solidFill>
+          </a:ln>
+          <a:effectLst/>
+        </p:spPr>
+        <p:style>
+          <a:lnRef idx="1">
+            <a:schemeClr val="accent1"/>
+          </a:lnRef>
+          <a:fillRef idx="3">
+            <a:schemeClr val="accent1"/>
+          </a:fillRef>
+          <a:effectRef idx="2">
+            <a:schemeClr val="accent1"/>
+          </a:effectRef>
+          <a:fontRef idx="minor">
+            <a:schemeClr val="lt1"/>
+          </a:fontRef>
+        </p:style>
+        <p:txBody>
+          <a:bodyPr rtlCol="0" anchor="t" wrap="square" lIns="27432" rIns="27432" tIns="22860" bIns="22860"/>
+          <a:lstStyle/>
+          <a:p>
+            <a:pPr algn="ctr"/>
+            <a:r>
+              <a:rPr sz="2000" b="0" i="0">
+                <a:solidFill>
+                  <a:srgbClr val="5C4826"/>
+                </a:solidFill>
+              </a:rPr>
+              <a:t/>
+            </a:r>
+          </a:p>
+        </p:txBody>
+      </p:sp>
+      <p:sp>
+        <p:nvSpPr>
+          <p:cNvPr id="910" name="Hole"/>
+          <p:cNvSpPr/>
+          <p:nvPr/>
+        </p:nvSpPr>
+        <p:spPr>
+          <a:xfrm>
+            <a:off x="5056632" y="1783080"/>
+            <a:ext cx="402336" cy="402336"/>
+          </a:xfrm>
+          <a:prstGeom prst="ellipse">
+            <a:avLst/>
+          </a:prstGeom>
+          <a:solidFill>
+            <a:srgbClr val="FFFFFF"/>
+          </a:solidFill>
+          <a:ln w="12700">
+            <a:solidFill>
+              <a:srgbClr val="C9B991"/>
+            </a:solidFill>
+          </a:ln>
+          <a:effectLst/>
+        </p:spPr>
+        <p:style>
+          <a:lnRef idx="1">
+            <a:schemeClr val="accent1"/>
+          </a:lnRef>
+          <a:fillRef idx="3">
+            <a:schemeClr val="accent1"/>
+          </a:fillRef>
+          <a:effectRef idx="2">
+            <a:schemeClr val="accent1"/>
+          </a:effectRef>
+          <a:fontRef idx="minor">
+            <a:schemeClr val="lt1"/>
+          </a:fontRef>
+        </p:style>
+        <p:txBody>
+          <a:bodyPr rtlCol="0" anchor="ctr" wrap="square" lIns="27432" rIns="27432" tIns="22860" bIns="22860"/>
+          <a:lstStyle/>
+          <a:p>
+            <a:pPr algn="ctr"/>
+            <a:r>
+              <a:rPr sz="2000" b="0" i="0">
+                <a:solidFill>
+                  <a:srgbClr val="5C4826"/>
+                </a:solidFill>
+              </a:rPr>
+              <a:t/>
+            </a:r>
+          </a:p>
+        </p:txBody>
+      </p:sp>
+      <p:sp>
+        <p:nvSpPr>
+          <p:cNvPr id="911" name="Hole"/>
+          <p:cNvSpPr/>
+          <p:nvPr/>
+        </p:nvSpPr>
+        <p:spPr>
+          <a:xfrm>
+            <a:off x="5056632" y="2788920"/>
+            <a:ext cx="402336" cy="402336"/>
+          </a:xfrm>
+          <a:prstGeom prst="ellipse">
+            <a:avLst/>
+          </a:prstGeom>
+          <a:solidFill>
+            <a:srgbClr val="FFFFFF"/>
+          </a:solidFill>
+          <a:ln w="12700">
+            <a:solidFill>
+              <a:srgbClr val="C9B991"/>
+            </a:solidFill>
+          </a:ln>
+          <a:effectLst/>
+        </p:spPr>
+        <p:style>
+          <a:lnRef idx="1">
+            <a:schemeClr val="accent1"/>
+          </a:lnRef>
+          <a:fillRef idx="3">
+            <a:schemeClr val="accent1"/>
+          </a:fillRef>
+          <a:effectRef idx="2">
+            <a:schemeClr val="accent1"/>
+          </a:effectRef>
+          <a:fontRef idx="minor">
+            <a:schemeClr val="lt1"/>
+          </a:fontRef>
+        </p:style>
+        <p:txBody>
+          <a:bodyPr rtlCol="0" anchor="ctr" wrap="square" lIns="27432" rIns="27432" tIns="22860" bIns="22860"/>
+          <a:lstStyle/>
+          <a:p>
+            <a:pPr algn="ctr"/>
+            <a:r>
+              <a:rPr sz="2000" b="0" i="0">
+                <a:solidFill>
+                  <a:srgbClr val="5C4826"/>
+                </a:solidFill>
+              </a:rPr>
+              <a:t/>
+            </a:r>
+          </a:p>
+        </p:txBody>
+      </p:sp>
+      <p:sp>
+        <p:nvSpPr>
+          <p:cNvPr id="912" name="Hole"/>
+          <p:cNvSpPr/>
+          <p:nvPr/>
+        </p:nvSpPr>
+        <p:spPr>
+          <a:xfrm>
+            <a:off x="5056632" y="3794760"/>
+            <a:ext cx="402336" cy="402336"/>
+          </a:xfrm>
+          <a:prstGeom prst="ellipse">
+            <a:avLst/>
+          </a:prstGeom>
+          <a:solidFill>
+            <a:srgbClr val="FFFFFF"/>
+          </a:solidFill>
+          <a:ln w="12700">
+            <a:solidFill>
+              <a:srgbClr val="C9B991"/>
+            </a:solidFill>
+          </a:ln>
+          <a:effectLst/>
+        </p:spPr>
+        <p:style>
+          <a:lnRef idx="1">
+            <a:schemeClr val="accent1"/>
+          </a:lnRef>
+          <a:fillRef idx="3">
+            <a:schemeClr val="accent1"/>
+          </a:fillRef>
+          <a:effectRef idx="2">
+            <a:schemeClr val="accent1"/>
+          </a:effectRef>
+          <a:fontRef idx="minor">
+            <a:schemeClr val="lt1"/>
+          </a:fontRef>
+        </p:style>
+        <p:txBody>
+          <a:bodyPr rtlCol="0" anchor="ctr" wrap="square" lIns="27432" rIns="27432" tIns="22860" bIns="22860"/>
+          <a:lstStyle/>
+          <a:p>
+            <a:pPr algn="ctr"/>
+            <a:r>
+              <a:rPr sz="2000" b="0" i="0">
+                <a:solidFill>
+                  <a:srgbClr val="5C4826"/>
+                </a:solidFill>
+              </a:rPr>
+              <a:t/>
+            </a:r>
+          </a:p>
+        </p:txBody>
+      </p:sp>
+      <p:sp>
+        <p:nvSpPr>
+          <p:cNvPr id="913" name="Slab"/>
+          <p:cNvSpPr/>
+          <p:nvPr/>
+        </p:nvSpPr>
+        <p:spPr>
+          <a:xfrm>
+            <a:off x="6400800" y="1280160"/>
+            <a:ext cx="1005840" cy="3657600"/>
+          </a:xfrm>
+          <a:prstGeom prst="rect">
+            <a:avLst/>
+          </a:prstGeom>
+          <a:solidFill>
+            <a:srgbClr val="F5F1E8"/>
+          </a:solidFill>
+          <a:ln w="12700">
+            <a:solidFill>
+              <a:srgbClr val="C9B991"/>
+            </a:solidFill>
+          </a:ln>
+          <a:effectLst/>
+        </p:spPr>
+        <p:style>
+          <a:lnRef idx="1">
+            <a:schemeClr val="accent1"/>
+          </a:lnRef>
+          <a:fillRef idx="3">
+            <a:schemeClr val="accent1"/>
+          </a:fillRef>
+          <a:effectRef idx="2">
+            <a:schemeClr val="accent1"/>
+          </a:effectRef>
+          <a:fontRef idx="minor">
+            <a:schemeClr val="lt1"/>
+          </a:fontRef>
+        </p:style>
+        <p:txBody>
+          <a:bodyPr rtlCol="0" anchor="t" wrap="square" lIns="27432" rIns="27432" tIns="22860" bIns="22860"/>
+          <a:lstStyle/>
+          <a:p>
+            <a:pPr algn="ctr"/>
+            <a:r>
+              <a:rPr sz="2000" b="0" i="0">
+                <a:solidFill>
+                  <a:srgbClr val="5C4826"/>
+                </a:solidFill>
+              </a:rPr>
+              <a:t/>
+            </a:r>
+          </a:p>
+        </p:txBody>
+      </p:sp>
+      <p:sp>
+        <p:nvSpPr>
+          <p:cNvPr id="914" name="Hole"/>
+          <p:cNvSpPr/>
+          <p:nvPr/>
+        </p:nvSpPr>
+        <p:spPr>
+          <a:xfrm>
+            <a:off x="6702552" y="2240280"/>
+            <a:ext cx="402336" cy="402336"/>
+          </a:xfrm>
+          <a:prstGeom prst="ellipse">
+            <a:avLst/>
+          </a:prstGeom>
+          <a:solidFill>
+            <a:srgbClr val="FFFFFF"/>
+          </a:solidFill>
+          <a:ln w="12700">
+            <a:solidFill>
+              <a:srgbClr val="C9B991"/>
+            </a:solidFill>
+          </a:ln>
+          <a:effectLst/>
+        </p:spPr>
+        <p:style>
+          <a:lnRef idx="1">
+            <a:schemeClr val="accent1"/>
+          </a:lnRef>
+          <a:fillRef idx="3">
+            <a:schemeClr val="accent1"/>
+          </a:fillRef>
+          <a:effectRef idx="2">
+            <a:schemeClr val="accent1"/>
+          </a:effectRef>
+          <a:fontRef idx="minor">
+            <a:schemeClr val="lt1"/>
+          </a:fontRef>
+        </p:style>
+        <p:txBody>
+          <a:bodyPr rtlCol="0" anchor="ctr" wrap="square" lIns="27432" rIns="27432" tIns="22860" bIns="22860"/>
+          <a:lstStyle/>
+          <a:p>
+            <a:pPr algn="ctr"/>
+            <a:r>
+              <a:rPr sz="2000" b="0" i="0">
+                <a:solidFill>
+                  <a:srgbClr val="5C4826"/>
+                </a:solidFill>
+              </a:rPr>
+              <a:t/>
+            </a:r>
+          </a:p>
+        </p:txBody>
+      </p:sp>
+      <p:sp>
+        <p:nvSpPr>
+          <p:cNvPr id="915" name="Hole"/>
+          <p:cNvSpPr/>
+          <p:nvPr/>
+        </p:nvSpPr>
+        <p:spPr>
+          <a:xfrm>
+            <a:off x="6702552" y="2788920"/>
+            <a:ext cx="402336" cy="402336"/>
+          </a:xfrm>
+          <a:prstGeom prst="ellipse">
+            <a:avLst/>
+          </a:prstGeom>
+          <a:solidFill>
+            <a:srgbClr val="FFFFFF"/>
+          </a:solidFill>
+          <a:ln w="12700">
+            <a:solidFill>
+              <a:srgbClr val="C9B991"/>
+            </a:solidFill>
+          </a:ln>
+          <a:effectLst/>
+        </p:spPr>
+        <p:style>
+          <a:lnRef idx="1">
+            <a:schemeClr val="accent1"/>
+          </a:lnRef>
+          <a:fillRef idx="3">
+            <a:schemeClr val="accent1"/>
+          </a:fillRef>
+          <a:effectRef idx="2">
+            <a:schemeClr val="accent1"/>
+          </a:effectRef>
+          <a:fontRef idx="minor">
+            <a:schemeClr val="lt1"/>
+          </a:fontRef>
+        </p:style>
+        <p:txBody>
+          <a:bodyPr rtlCol="0" anchor="ctr" wrap="square" lIns="27432" rIns="27432" tIns="22860" bIns="22860"/>
+          <a:lstStyle/>
+          <a:p>
+            <a:pPr algn="ctr"/>
+            <a:r>
+              <a:rPr sz="2000" b="0" i="0">
+                <a:solidFill>
+                  <a:srgbClr val="5C4826"/>
+                </a:solidFill>
+              </a:rPr>
+              <a:t/>
+            </a:r>
+          </a:p>
+        </p:txBody>
+      </p:sp>
+      <p:sp>
+        <p:nvSpPr>
+          <p:cNvPr id="916" name="Hole"/>
+          <p:cNvSpPr/>
+          <p:nvPr/>
+        </p:nvSpPr>
+        <p:spPr>
+          <a:xfrm>
+            <a:off x="6702552" y="4160520"/>
+            <a:ext cx="402336" cy="402336"/>
+          </a:xfrm>
+          <a:prstGeom prst="ellipse">
+            <a:avLst/>
+          </a:prstGeom>
+          <a:solidFill>
+            <a:srgbClr val="FFFFFF"/>
+          </a:solidFill>
+          <a:ln w="12700">
+            <a:solidFill>
+              <a:srgbClr val="C9B991"/>
+            </a:solidFill>
+          </a:ln>
+          <a:effectLst/>
+        </p:spPr>
+        <p:style>
+          <a:lnRef idx="1">
+            <a:schemeClr val="accent1"/>
+          </a:lnRef>
+          <a:fillRef idx="3">
+            <a:schemeClr val="accent1"/>
+          </a:fillRef>
+          <a:effectRef idx="2">
+            <a:schemeClr val="accent1"/>
+          </a:effectRef>
+          <a:fontRef idx="minor">
+            <a:schemeClr val="lt1"/>
+          </a:fontRef>
+        </p:style>
+        <p:txBody>
+          <a:bodyPr rtlCol="0" anchor="ctr" wrap="square" lIns="27432" rIns="27432" tIns="22860" bIns="22860"/>
+          <a:lstStyle/>
+          <a:p>
+            <a:pPr algn="ctr"/>
+            <a:r>
+              <a:rPr sz="2000" b="0" i="0">
+                <a:solidFill>
+                  <a:srgbClr val="5C4826"/>
+                </a:solidFill>
+              </a:rPr>
+              <a:t/>
+            </a:r>
+          </a:p>
+        </p:txBody>
+      </p:sp>
+      <p:cxnSp>
+        <p:nvCxnSpPr>
+          <p:cNvPr id="917" name="Connector 916"/>
+          <p:cNvCxnSpPr/>
+          <p:nvPr/>
+        </p:nvCxnSpPr>
+        <p:spPr>
+          <a:xfrm>
+            <a:off x="548640" y="2990088"/>
+            <a:ext cx="7589520" cy="0"/>
+          </a:xfrm>
+          <a:prstGeom prst="line">
+            <a:avLst/>
+          </a:prstGeom>
+          <a:ln w="31750">
+            <a:solidFill>
+              <a:srgbClr val="9A3F12"/>
+            </a:solidFill>
+            <a:tailEnd type="triangle"/>
+          </a:ln>
+        </p:spPr>
+        <p:style>
+          <a:lnRef idx="2">
+            <a:schemeClr val="accent1"/>
+          </a:lnRef>
+          <a:fillRef idx="0">
+            <a:schemeClr val="accent1"/>
+          </a:fillRef>
+          <a:effectRef idx="1">
+            <a:schemeClr val="accent1"/>
+          </a:effectRef>
+          <a:fontRef idx="minor">
+            <a:schemeClr val="tx1"/>
+          </a:fontRef>
+        </p:style>
+      </p:cxnSp>
+      <p:sp>
+        <p:nvSpPr>
+          <p:cNvPr id="918" name="Label"/>
+          <p:cNvSpPr txBox="1"/>
+          <p:nvPr/>
+        </p:nvSpPr>
+        <p:spPr>
+          <a:xfrm>
+            <a:off x="548640" y="5212080"/>
+            <a:ext cx="8046720" cy="457200"/>
+          </a:xfrm>
+          <a:prstGeom prst="rect">
+            <a:avLst/>
+          </a:prstGeom>
+          <a:noFill/>
+        </p:spPr>
+        <p:txBody>
+          <a:bodyPr wrap="square" anchor="t" lIns="27432" rIns="27432" tIns="22860" bIns="22860">
+            <a:spAutoFit/>
+          </a:bodyPr>
+          <a:lstStyle/>
+          <a:p>
+            <a:pPr algn="ctr"/>
+            <a:r>
+              <a:rPr sz="2200" b="0" i="0">
+                <a:solidFill>
+                  <a:srgbClr val="5C4826"/>
+                </a:solidFill>
+              </a:rPr>
+              <a:t>Now defenses and their holes matter.</a:t>
+            </a:r>
+          </a:p>
+        </p:txBody>
+      </p:sp>
+    </p:spTree>
+  </p:cSld>
+  <p:clrMapOvr>
+    <a:masterClrMapping/>
+  </p:clrMapOvr>
+</p:sld>
+</file>
+
+<file path=ppt/slides/slide15.xml><?xml version="1.0" encoding="utf-8"?>
+<p:sld xmlns:a="http://schemas.openxmlformats.org/drawingml/2006/main" xmlns:p="http://schemas.openxmlformats.org/presentationml/2006/main" xmlns:r="http://schemas.openxmlformats.org/officeDocument/2006/relationships">
+  <p:cSld>
+    <p:spTree>
+      <p:nvGrpSpPr>
+        <p:cNvPr id="1" name=""/>
+        <p:cNvGrpSpPr/>
+        <p:nvPr/>
+      </p:nvGrpSpPr>
+      <p:grpSpPr/>
+      <p:sp>
+        <p:nvSpPr>
+          <p:cNvPr id="3" name="Title 2"/>
+          <p:cNvSpPr>
+            <a:spLocks noGrp="1"/>
+          </p:cNvSpPr>
+          <p:nvPr>
+            <p:ph type="title"/>
+          </p:nvPr>
+        </p:nvSpPr>
+        <p:spPr/>
+        <p:txBody>
+          <a:bodyPr/>
+          <a:lstStyle/>
+          <a:p>
+            <a:r>
+              <a:rPr sz="2400" b="0" i="0">
+                <a:solidFill>
+                  <a:srgbClr val="000000"/>
+                </a:solidFill>
+              </a:rPr>
+              <a:t>Organizational causation</a:t>
+            </a:r>
+          </a:p>
+        </p:txBody>
+      </p:sp>
+      <p:sp>
+        <p:nvSpPr>
+          <p:cNvPr id="900" name="Slide Number Placeholder 900"/>
+          <p:cNvSpPr>
+            <a:spLocks noGrp="1"/>
+          </p:cNvSpPr>
+          <p:nvPr>
+            <p:ph type="sldNum" sz="quarter" idx="4"/>
+          </p:nvPr>
+        </p:nvSpPr>
+        <p:spPr/>
+        <p:txBody>
+          <a:bodyPr/>
+          <a:lstStyle/>
+          <a:p>
+            <a:fld id="{05417E77-5F02-4D92-BA7F-030D59DFDABE}" type="slidenum">
+              <a:rPr lang="en-US" smtClean="0"/>
+              <a:t>15</a:t>
+            </a:fld>
+            <a:endParaRPr lang="en-US"/>
+          </a:p>
+        </p:txBody>
+      </p:sp>
+      <p:sp>
+        <p:nvSpPr>
+          <p:cNvPr id="901" name="Block"/>
+          <p:cNvSpPr/>
+          <p:nvPr/>
+        </p:nvSpPr>
+        <p:spPr>
+          <a:xfrm>
+            <a:off x="548640" y="2377440"/>
+            <a:ext cx="2468880" cy="731520"/>
+          </a:xfrm>
+          <a:prstGeom prst="rect">
+            <a:avLst/>
+          </a:prstGeom>
+          <a:solidFill>
+            <a:srgbClr val="8E6F3E"/>
+          </a:solidFill>
+          <a:ln>
+            <a:noFill/>
+          </a:ln>
+          <a:effectLst/>
+        </p:spPr>
+        <p:style>
+          <a:lnRef idx="1">
+            <a:schemeClr val="accent1"/>
+          </a:lnRef>
+          <a:fillRef idx="3">
+            <a:schemeClr val="accent1"/>
+          </a:fillRef>
+          <a:effectRef idx="2">
+            <a:schemeClr val="accent1"/>
+          </a:effectRef>
+          <a:fontRef idx="minor">
+            <a:schemeClr val="lt1"/>
+          </a:fontRef>
+        </p:style>
+        <p:txBody>
+          <a:bodyPr rtlCol="0" anchor="ctr" wrap="square" lIns="27432" rIns="27432" tIns="22860" bIns="22860"/>
+          <a:lstStyle/>
+          <a:p>
+            <a:pPr algn="ctr"/>
+            <a:r>
+              <a:rPr sz="2000" b="1" i="0">
+                <a:solidFill>
+                  <a:srgbClr val="FFFFFF"/>
+                </a:solidFill>
+              </a:rPr>
+              <a:t>CONDITIONS</a:t>
+            </a:r>
+          </a:p>
+        </p:txBody>
+      </p:sp>
+      <p:cxnSp>
+        <p:nvCxnSpPr>
+          <p:cNvPr id="902" name="Connector 901"/>
+          <p:cNvCxnSpPr/>
+          <p:nvPr/>
+        </p:nvCxnSpPr>
+        <p:spPr>
+          <a:xfrm>
+            <a:off x="3017520" y="2743200"/>
+            <a:ext cx="548640" cy="0"/>
+          </a:xfrm>
+          <a:prstGeom prst="line">
+            <a:avLst/>
+          </a:prstGeom>
+          <a:ln w="28575">
+            <a:solidFill>
+              <a:srgbClr val="8E6F3E"/>
+            </a:solidFill>
+            <a:tailEnd type="triangle"/>
+          </a:ln>
+        </p:spPr>
+        <p:style>
+          <a:lnRef idx="2">
+            <a:schemeClr val="accent1"/>
+          </a:lnRef>
+          <a:fillRef idx="0">
+            <a:schemeClr val="accent1"/>
+          </a:fillRef>
+          <a:effectRef idx="1">
+            <a:schemeClr val="accent1"/>
+          </a:effectRef>
+          <a:fontRef idx="minor">
+            <a:schemeClr val="tx1"/>
+          </a:fontRef>
+        </p:style>
+      </p:cxnSp>
+      <p:sp>
+        <p:nvSpPr>
+          <p:cNvPr id="903" name="Card"/>
+          <p:cNvSpPr/>
+          <p:nvPr/>
+        </p:nvSpPr>
+        <p:spPr>
+          <a:xfrm>
+            <a:off x="3566160" y="2377440"/>
+            <a:ext cx="2468880" cy="731520"/>
+          </a:xfrm>
+          <a:prstGeom prst="rect">
+            <a:avLst/>
+          </a:prstGeom>
+          <a:solidFill>
+            <a:srgbClr val="F5F1E8"/>
+          </a:solidFill>
+          <a:ln w="12700">
+            <a:solidFill>
+              <a:srgbClr val="C9B991"/>
+            </a:solidFill>
+          </a:ln>
+          <a:effectLst/>
+        </p:spPr>
+        <p:style>
+          <a:lnRef idx="1">
+            <a:schemeClr val="accent1"/>
+          </a:lnRef>
+          <a:fillRef idx="3">
+            <a:schemeClr val="accent1"/>
+          </a:fillRef>
+          <a:effectRef idx="2">
+            <a:schemeClr val="accent1"/>
+          </a:effectRef>
+          <a:fontRef idx="minor">
+            <a:schemeClr val="lt1"/>
+          </a:fontRef>
+        </p:style>
+        <p:txBody>
+          <a:bodyPr rtlCol="0" anchor="ctr" wrap="square" lIns="27432" rIns="27432" tIns="22860" bIns="22860"/>
+          <a:lstStyle/>
+          <a:p>
+            <a:pPr algn="ctr"/>
+            <a:r>
+              <a:rPr sz="2000" b="1" i="0">
+                <a:solidFill>
+                  <a:srgbClr val="5C4826"/>
+                </a:solidFill>
+              </a:rPr>
+              <a:t>behavior</a:t>
+            </a:r>
+          </a:p>
+        </p:txBody>
+      </p:sp>
+      <p:cxnSp>
+        <p:nvCxnSpPr>
+          <p:cNvPr id="904" name="Connector 903"/>
+          <p:cNvCxnSpPr/>
+          <p:nvPr/>
+        </p:nvCxnSpPr>
+        <p:spPr>
+          <a:xfrm>
+            <a:off x="6035040" y="2743200"/>
+            <a:ext cx="548640" cy="0"/>
+          </a:xfrm>
+          <a:prstGeom prst="line">
+            <a:avLst/>
+          </a:prstGeom>
+          <a:ln w="28575">
+            <a:solidFill>
+              <a:srgbClr val="8E6F3E"/>
+            </a:solidFill>
+            <a:tailEnd type="triangle"/>
+          </a:ln>
+        </p:spPr>
+        <p:style>
+          <a:lnRef idx="2">
+            <a:schemeClr val="accent1"/>
+          </a:lnRef>
+          <a:fillRef idx="0">
+            <a:schemeClr val="accent1"/>
+          </a:fillRef>
+          <a:effectRef idx="1">
+            <a:schemeClr val="accent1"/>
+          </a:effectRef>
+          <a:fontRef idx="minor">
+            <a:schemeClr val="tx1"/>
+          </a:fontRef>
+        </p:style>
+      </p:cxnSp>
+      <p:sp>
+        <p:nvSpPr>
+          <p:cNvPr id="905" name="Card"/>
+          <p:cNvSpPr/>
+          <p:nvPr/>
+        </p:nvSpPr>
+        <p:spPr>
+          <a:xfrm>
+            <a:off x="6583680" y="2377440"/>
+            <a:ext cx="2011680" cy="731520"/>
+          </a:xfrm>
+          <a:prstGeom prst="rect">
+            <a:avLst/>
+          </a:prstGeom>
+          <a:solidFill>
+            <a:srgbClr val="F5F1E8"/>
+          </a:solidFill>
+          <a:ln w="12700">
+            <a:solidFill>
+              <a:srgbClr val="C9B991"/>
+            </a:solidFill>
+          </a:ln>
+          <a:effectLst/>
+        </p:spPr>
+        <p:style>
+          <a:lnRef idx="1">
+            <a:schemeClr val="accent1"/>
+          </a:lnRef>
+          <a:fillRef idx="3">
+            <a:schemeClr val="accent1"/>
+          </a:fillRef>
+          <a:effectRef idx="2">
+            <a:schemeClr val="accent1"/>
+          </a:effectRef>
+          <a:fontRef idx="minor">
+            <a:schemeClr val="lt1"/>
+          </a:fontRef>
+        </p:style>
+        <p:txBody>
+          <a:bodyPr rtlCol="0" anchor="ctr" wrap="square" lIns="27432" rIns="27432" tIns="22860" bIns="22860"/>
+          <a:lstStyle/>
+          <a:p>
+            <a:pPr algn="ctr"/>
+            <a:r>
+              <a:rPr sz="2000" b="1" i="0">
+                <a:solidFill>
+                  <a:srgbClr val="5C4826"/>
+                </a:solidFill>
+              </a:rPr>
+              <a:t>outcome</a:t>
+            </a:r>
+          </a:p>
+        </p:txBody>
+      </p:sp>
+      <p:sp>
+        <p:nvSpPr>
+          <p:cNvPr id="906" name="Label"/>
+          <p:cNvSpPr txBox="1"/>
+          <p:nvPr/>
+        </p:nvSpPr>
+        <p:spPr>
+          <a:xfrm>
+            <a:off x="548640" y="3840480"/>
+            <a:ext cx="8046720" cy="457200"/>
+          </a:xfrm>
+          <a:prstGeom prst="rect">
+            <a:avLst/>
+          </a:prstGeom>
+          <a:noFill/>
+        </p:spPr>
+        <p:txBody>
+          <a:bodyPr wrap="square" anchor="t" lIns="27432" rIns="27432" tIns="22860" bIns="22860">
+            <a:spAutoFit/>
+          </a:bodyPr>
+          <a:lstStyle/>
+          <a:p>
+            <a:pPr algn="ctr"/>
+            <a:r>
+              <a:rPr sz="2200" b="0" i="0">
+                <a:solidFill>
+                  <a:srgbClr val="5C4826"/>
+                </a:solidFill>
+              </a:rPr>
+              <a:t>Now conditions shaping behavior matter.</a:t>
+            </a:r>
+          </a:p>
+        </p:txBody>
+      </p:sp>
+    </p:spTree>
+  </p:cSld>
+  <p:clrMapOvr>
+    <a:masterClrMapping/>
+  </p:clrMapOvr>
+</p:sld>
+</file>
+
+<file path=ppt/slides/slide16.xml><?xml version="1.0" encoding="utf-8"?>
+<p:sld xmlns:a="http://schemas.openxmlformats.org/drawingml/2006/main" xmlns:p="http://schemas.openxmlformats.org/presentationml/2006/main" xmlns:r="http://schemas.openxmlformats.org/officeDocument/2006/relationships">
+  <p:cSld>
+    <p:spTree>
+      <p:nvGrpSpPr>
+        <p:cNvPr id="1" name=""/>
+        <p:cNvGrpSpPr/>
+        <p:nvPr/>
+      </p:nvGrpSpPr>
+      <p:grpSpPr/>
+      <p:sp>
+        <p:nvSpPr>
+          <p:cNvPr id="3" name="Title 2"/>
+          <p:cNvSpPr>
+            <a:spLocks noGrp="1"/>
+          </p:cNvSpPr>
+          <p:nvPr>
+            <p:ph type="title"/>
+          </p:nvPr>
+        </p:nvSpPr>
+        <p:spPr/>
+        <p:txBody>
+          <a:bodyPr/>
+          <a:lstStyle/>
+          <a:p>
+            <a:r>
+              <a:rPr sz="2400" b="0" i="0">
+                <a:solidFill>
+                  <a:srgbClr val="000000"/>
+                </a:solidFill>
+              </a:rPr>
+              <a:t>STAMP: Fine, include everything</a:t>
+            </a:r>
+          </a:p>
+        </p:txBody>
+      </p:sp>
+      <p:sp>
+        <p:nvSpPr>
+          <p:cNvPr id="900" name="Slide Number Placeholder 900"/>
+          <p:cNvSpPr>
+            <a:spLocks noGrp="1"/>
+          </p:cNvSpPr>
+          <p:nvPr>
+            <p:ph type="sldNum" sz="quarter" idx="4"/>
+          </p:nvPr>
+        </p:nvSpPr>
+        <p:spPr/>
+        <p:txBody>
+          <a:bodyPr/>
+          <a:lstStyle/>
+          <a:p>
+            <a:fld id="{3EE8B33F-6F55-4310-8556-A7B692D2A075}" type="slidenum">
+              <a:rPr lang="en-US" smtClean="0"/>
+              <a:t>16</a:t>
+            </a:fld>
+            <a:endParaRPr lang="en-US"/>
+          </a:p>
+        </p:txBody>
+      </p:sp>
+      <p:sp>
+        <p:nvSpPr>
+          <p:cNvPr id="901" name="Block"/>
+          <p:cNvSpPr/>
+          <p:nvPr/>
+        </p:nvSpPr>
+        <p:spPr>
+          <a:xfrm>
+            <a:off x="2926080" y="1188720"/>
+            <a:ext cx="3291840" cy="640080"/>
+          </a:xfrm>
+          <a:prstGeom prst="rect">
+            <a:avLst/>
+          </a:prstGeom>
+          <a:solidFill>
+            <a:srgbClr val="8E6F3E"/>
+          </a:solidFill>
+          <a:ln>
+            <a:noFill/>
+          </a:ln>
+          <a:effectLst/>
+        </p:spPr>
+        <p:style>
+          <a:lnRef idx="1">
+            <a:schemeClr val="accent1"/>
+          </a:lnRef>
+          <a:fillRef idx="3">
+            <a:schemeClr val="accent1"/>
+          </a:fillRef>
+          <a:effectRef idx="2">
+            <a:schemeClr val="accent1"/>
+          </a:effectRef>
+          <a:fontRef idx="minor">
+            <a:schemeClr val="lt1"/>
+          </a:fontRef>
+        </p:style>
+        <p:txBody>
+          <a:bodyPr rtlCol="0" anchor="ctr" wrap="square" lIns="27432" rIns="27432" tIns="22860" bIns="22860"/>
+          <a:lstStyle/>
+          <a:p>
+            <a:pPr algn="ctr"/>
+            <a:r>
+              <a:rPr sz="2000" b="1" i="0">
+                <a:solidFill>
+                  <a:srgbClr val="FFFFFF"/>
+                </a:solidFill>
+              </a:rPr>
+              <a:t>REGULATORS</a:t>
+            </a:r>
+          </a:p>
+        </p:txBody>
+      </p:sp>
+      <p:cxnSp>
+        <p:nvCxnSpPr>
+          <p:cNvPr id="902" name="Connector 901"/>
+          <p:cNvCxnSpPr/>
+          <p:nvPr/>
+        </p:nvCxnSpPr>
+        <p:spPr>
+          <a:xfrm>
+            <a:off x="4023360" y="1828800"/>
+            <a:ext cx="0" cy="365760"/>
+          </a:xfrm>
+          <a:prstGeom prst="line">
+            <a:avLst/>
+          </a:prstGeom>
+          <a:ln w="19050">
+            <a:solidFill>
+              <a:srgbClr val="8E6F3E"/>
+            </a:solidFill>
+            <a:tailEnd type="triangle"/>
+          </a:ln>
+        </p:spPr>
+        <p:style>
+          <a:lnRef idx="2">
+            <a:schemeClr val="accent1"/>
+          </a:lnRef>
+          <a:fillRef idx="0">
+            <a:schemeClr val="accent1"/>
+          </a:fillRef>
+          <a:effectRef idx="1">
+            <a:schemeClr val="accent1"/>
+          </a:effectRef>
+          <a:fontRef idx="minor">
+            <a:schemeClr val="tx1"/>
+          </a:fontRef>
+        </p:style>
+      </p:cxnSp>
+      <p:cxnSp>
+        <p:nvCxnSpPr>
+          <p:cNvPr id="903" name="Connector 902"/>
+          <p:cNvCxnSpPr/>
+          <p:nvPr/>
+        </p:nvCxnSpPr>
+        <p:spPr>
+          <a:xfrm flipV="1">
+            <a:off x="5120640" y="1828800"/>
+            <a:ext cx="0" cy="365760"/>
+          </a:xfrm>
+          <a:prstGeom prst="line">
+            <a:avLst/>
+          </a:prstGeom>
+          <a:ln w="19050">
+            <a:solidFill>
+              <a:srgbClr val="8E6F3E"/>
+            </a:solidFill>
+            <a:tailEnd type="triangle"/>
+          </a:ln>
+        </p:spPr>
+        <p:style>
+          <a:lnRef idx="2">
+            <a:schemeClr val="accent1"/>
+          </a:lnRef>
+          <a:fillRef idx="0">
+            <a:schemeClr val="accent1"/>
+          </a:fillRef>
+          <a:effectRef idx="1">
+            <a:schemeClr val="accent1"/>
+          </a:effectRef>
+          <a:fontRef idx="minor">
+            <a:schemeClr val="tx1"/>
+          </a:fontRef>
+        </p:style>
+      </p:cxnSp>
+      <p:sp>
+        <p:nvSpPr>
+          <p:cNvPr id="904" name="Block"/>
+          <p:cNvSpPr/>
+          <p:nvPr/>
+        </p:nvSpPr>
+        <p:spPr>
+          <a:xfrm>
+            <a:off x="2926080" y="2194560"/>
+            <a:ext cx="3291840" cy="640080"/>
+          </a:xfrm>
+          <a:prstGeom prst="rect">
+            <a:avLst/>
+          </a:prstGeom>
+          <a:solidFill>
+            <a:srgbClr val="8E6F3E"/>
+          </a:solidFill>
+          <a:ln>
+            <a:noFill/>
+          </a:ln>
+          <a:effectLst/>
+        </p:spPr>
+        <p:style>
+          <a:lnRef idx="1">
+            <a:schemeClr val="accent1"/>
+          </a:lnRef>
+          <a:fillRef idx="3">
+            <a:schemeClr val="accent1"/>
+          </a:fillRef>
+          <a:effectRef idx="2">
+            <a:schemeClr val="accent1"/>
+          </a:effectRef>
+          <a:fontRef idx="minor">
+            <a:schemeClr val="lt1"/>
+          </a:fontRef>
+        </p:style>
+        <p:txBody>
+          <a:bodyPr rtlCol="0" anchor="ctr" wrap="square" lIns="27432" rIns="27432" tIns="22860" bIns="22860"/>
+          <a:lstStyle/>
+          <a:p>
+            <a:pPr algn="ctr"/>
+            <a:r>
+              <a:rPr sz="2000" b="1" i="0">
+                <a:solidFill>
+                  <a:srgbClr val="FFFFFF"/>
+                </a:solidFill>
+              </a:rPr>
+              <a:t>ORGANIZATION</a:t>
+            </a:r>
+          </a:p>
+        </p:txBody>
+      </p:sp>
+      <p:cxnSp>
+        <p:nvCxnSpPr>
+          <p:cNvPr id="905" name="Connector 904"/>
+          <p:cNvCxnSpPr/>
+          <p:nvPr/>
+        </p:nvCxnSpPr>
+        <p:spPr>
+          <a:xfrm>
+            <a:off x="4023360" y="2834640"/>
+            <a:ext cx="0" cy="365760"/>
+          </a:xfrm>
+          <a:prstGeom prst="line">
+            <a:avLst/>
+          </a:prstGeom>
+          <a:ln w="19050">
+            <a:solidFill>
+              <a:srgbClr val="8E6F3E"/>
+            </a:solidFill>
+            <a:tailEnd type="triangle"/>
+          </a:ln>
+        </p:spPr>
+        <p:style>
+          <a:lnRef idx="2">
+            <a:schemeClr val="accent1"/>
+          </a:lnRef>
+          <a:fillRef idx="0">
+            <a:schemeClr val="accent1"/>
+          </a:fillRef>
+          <a:effectRef idx="1">
+            <a:schemeClr val="accent1"/>
+          </a:effectRef>
+          <a:fontRef idx="minor">
+            <a:schemeClr val="tx1"/>
+          </a:fontRef>
+        </p:style>
+      </p:cxnSp>
+      <p:cxnSp>
+        <p:nvCxnSpPr>
+          <p:cNvPr id="906" name="Connector 905"/>
+          <p:cNvCxnSpPr/>
+          <p:nvPr/>
+        </p:nvCxnSpPr>
+        <p:spPr>
+          <a:xfrm flipV="1">
+            <a:off x="5120640" y="2834640"/>
+            <a:ext cx="0" cy="365760"/>
+          </a:xfrm>
+          <a:prstGeom prst="line">
+            <a:avLst/>
+          </a:prstGeom>
+          <a:ln w="19050">
+            <a:solidFill>
+              <a:srgbClr val="8E6F3E"/>
+            </a:solidFill>
+            <a:tailEnd type="triangle"/>
+          </a:ln>
+        </p:spPr>
+        <p:style>
+          <a:lnRef idx="2">
+            <a:schemeClr val="accent1"/>
+          </a:lnRef>
+          <a:fillRef idx="0">
+            <a:schemeClr val="accent1"/>
+          </a:fillRef>
+          <a:effectRef idx="1">
+            <a:schemeClr val="accent1"/>
+          </a:effectRef>
+          <a:fontRef idx="minor">
+            <a:schemeClr val="tx1"/>
+          </a:fontRef>
+        </p:style>
+      </p:cxnSp>
+      <p:sp>
+        <p:nvSpPr>
+          <p:cNvPr id="907" name="Block"/>
+          <p:cNvSpPr/>
+          <p:nvPr/>
+        </p:nvSpPr>
+        <p:spPr>
+          <a:xfrm>
+            <a:off x="2926080" y="3200400"/>
+            <a:ext cx="3291840" cy="640080"/>
+          </a:xfrm>
+          <a:prstGeom prst="rect">
+            <a:avLst/>
+          </a:prstGeom>
+          <a:solidFill>
+            <a:srgbClr val="8E6F3E"/>
+          </a:solidFill>
+          <a:ln>
+            <a:noFill/>
+          </a:ln>
+          <a:effectLst/>
+        </p:spPr>
+        <p:style>
+          <a:lnRef idx="1">
+            <a:schemeClr val="accent1"/>
+          </a:lnRef>
+          <a:fillRef idx="3">
+            <a:schemeClr val="accent1"/>
+          </a:fillRef>
+          <a:effectRef idx="2">
+            <a:schemeClr val="accent1"/>
+          </a:effectRef>
+          <a:fontRef idx="minor">
+            <a:schemeClr val="lt1"/>
+          </a:fontRef>
+        </p:style>
+        <p:txBody>
+          <a:bodyPr rtlCol="0" anchor="ctr" wrap="square" lIns="27432" rIns="27432" tIns="22860" bIns="22860"/>
+          <a:lstStyle/>
+          <a:p>
+            <a:pPr algn="ctr"/>
+            <a:r>
+              <a:rPr sz="2000" b="1" i="0">
+                <a:solidFill>
+                  <a:srgbClr val="FFFFFF"/>
+                </a:solidFill>
+              </a:rPr>
+              <a:t>ENGINEERING</a:t>
+            </a:r>
+          </a:p>
+        </p:txBody>
+      </p:sp>
+      <p:cxnSp>
+        <p:nvCxnSpPr>
+          <p:cNvPr id="908" name="Connector 907"/>
+          <p:cNvCxnSpPr/>
+          <p:nvPr/>
+        </p:nvCxnSpPr>
+        <p:spPr>
+          <a:xfrm>
+            <a:off x="4023360" y="3840480"/>
+            <a:ext cx="0" cy="365760"/>
+          </a:xfrm>
+          <a:prstGeom prst="line">
+            <a:avLst/>
+          </a:prstGeom>
+          <a:ln w="19050">
+            <a:solidFill>
+              <a:srgbClr val="8E6F3E"/>
+            </a:solidFill>
+            <a:tailEnd type="triangle"/>
+          </a:ln>
+        </p:spPr>
+        <p:style>
+          <a:lnRef idx="2">
+            <a:schemeClr val="accent1"/>
+          </a:lnRef>
+          <a:fillRef idx="0">
+            <a:schemeClr val="accent1"/>
+          </a:fillRef>
+          <a:effectRef idx="1">
+            <a:schemeClr val="accent1"/>
+          </a:effectRef>
+          <a:fontRef idx="minor">
+            <a:schemeClr val="tx1"/>
+          </a:fontRef>
+        </p:style>
+      </p:cxnSp>
+      <p:cxnSp>
+        <p:nvCxnSpPr>
+          <p:cNvPr id="909" name="Connector 908"/>
+          <p:cNvCxnSpPr/>
+          <p:nvPr/>
+        </p:nvCxnSpPr>
+        <p:spPr>
+          <a:xfrm flipV="1">
+            <a:off x="5120640" y="3840480"/>
+            <a:ext cx="0" cy="365760"/>
+          </a:xfrm>
+          <a:prstGeom prst="line">
+            <a:avLst/>
+          </a:prstGeom>
+          <a:ln w="19050">
+            <a:solidFill>
+              <a:srgbClr val="8E6F3E"/>
+            </a:solidFill>
+            <a:tailEnd type="triangle"/>
+          </a:ln>
+        </p:spPr>
+        <p:style>
+          <a:lnRef idx="2">
+            <a:schemeClr val="accent1"/>
+          </a:lnRef>
+          <a:fillRef idx="0">
+            <a:schemeClr val="accent1"/>
+          </a:fillRef>
+          <a:effectRef idx="1">
+            <a:schemeClr val="accent1"/>
+          </a:effectRef>
+          <a:fontRef idx="minor">
+            <a:schemeClr val="tx1"/>
+          </a:fontRef>
+        </p:style>
+      </p:cxnSp>
+      <p:sp>
+        <p:nvSpPr>
+          <p:cNvPr id="910" name="Block"/>
+          <p:cNvSpPr/>
+          <p:nvPr/>
+        </p:nvSpPr>
+        <p:spPr>
+          <a:xfrm>
+            <a:off x="2926080" y="4206240"/>
+            <a:ext cx="3291840" cy="640080"/>
+          </a:xfrm>
+          <a:prstGeom prst="rect">
+            <a:avLst/>
+          </a:prstGeom>
+          <a:solidFill>
+            <a:srgbClr val="8E6F3E"/>
+          </a:solidFill>
+          <a:ln>
+            <a:noFill/>
+          </a:ln>
+          <a:effectLst/>
+        </p:spPr>
+        <p:style>
+          <a:lnRef idx="1">
+            <a:schemeClr val="accent1"/>
+          </a:lnRef>
+          <a:fillRef idx="3">
+            <a:schemeClr val="accent1"/>
+          </a:fillRef>
+          <a:effectRef idx="2">
+            <a:schemeClr val="accent1"/>
+          </a:effectRef>
+          <a:fontRef idx="minor">
+            <a:schemeClr val="lt1"/>
+          </a:fontRef>
+        </p:style>
+        <p:txBody>
+          <a:bodyPr rtlCol="0" anchor="ctr" wrap="square" lIns="27432" rIns="27432" tIns="22860" bIns="22860"/>
+          <a:lstStyle/>
+          <a:p>
+            <a:pPr algn="ctr"/>
+            <a:r>
+              <a:rPr sz="2000" b="1" i="0">
+                <a:solidFill>
+                  <a:srgbClr val="FFFFFF"/>
+                </a:solidFill>
+              </a:rPr>
+              <a:t>OPERATING PROCESS</a:t>
+            </a:r>
+          </a:p>
+        </p:txBody>
+      </p:sp>
+      <p:sp>
+        <p:nvSpPr>
+          <p:cNvPr id="911" name="Label"/>
+          <p:cNvSpPr txBox="1"/>
+          <p:nvPr/>
+        </p:nvSpPr>
+        <p:spPr>
+          <a:xfrm>
+            <a:off x="411480" y="2377440"/>
+            <a:ext cx="2331720" cy="731520"/>
+          </a:xfrm>
+          <a:prstGeom prst="rect">
+            <a:avLst/>
+          </a:prstGeom>
+          <a:noFill/>
+        </p:spPr>
+        <p:txBody>
+          <a:bodyPr wrap="square" anchor="t" lIns="27432" rIns="27432" tIns="22860" bIns="22860">
+            <a:spAutoFit/>
+          </a:bodyPr>
+          <a:lstStyle/>
+          <a:p>
+            <a:pPr algn="r"/>
+            <a:r>
+              <a:rPr sz="2000" b="0" i="0">
+                <a:solidFill>
+                  <a:srgbClr val="555960"/>
+                </a:solidFill>
+              </a:rPr>
+              <a:t>control ↓</a:t>
+            </a:r>
+          </a:p>
+        </p:txBody>
+      </p:sp>
+      <p:sp>
+        <p:nvSpPr>
+          <p:cNvPr id="912" name="Label"/>
+          <p:cNvSpPr txBox="1"/>
+          <p:nvPr/>
+        </p:nvSpPr>
+        <p:spPr>
+          <a:xfrm>
+            <a:off x="6400800" y="2377440"/>
+            <a:ext cx="2103120" cy="731520"/>
+          </a:xfrm>
+          <a:prstGeom prst="rect">
+            <a:avLst/>
+          </a:prstGeom>
+          <a:noFill/>
+        </p:spPr>
+        <p:txBody>
+          <a:bodyPr wrap="square" anchor="t" lIns="27432" rIns="27432" tIns="22860" bIns="22860">
+            <a:spAutoFit/>
+          </a:bodyPr>
+          <a:lstStyle/>
+          <a:p>
+            <a:pPr algn="l"/>
+            <a:r>
+              <a:rPr sz="2000" b="0" i="0">
+                <a:solidFill>
+                  <a:srgbClr val="555960"/>
+                </a:solidFill>
+              </a:rPr>
+              <a:t>↑ feedback</a:t>
+            </a:r>
+          </a:p>
+        </p:txBody>
+      </p:sp>
+      <p:sp>
+        <p:nvSpPr>
+          <p:cNvPr id="913" name="Label"/>
+          <p:cNvSpPr txBox="1"/>
+          <p:nvPr/>
+        </p:nvSpPr>
+        <p:spPr>
+          <a:xfrm>
+            <a:off x="548640" y="5303520"/>
+            <a:ext cx="8046720" cy="457200"/>
+          </a:xfrm>
+          <a:prstGeom prst="rect">
+            <a:avLst/>
+          </a:prstGeom>
+          <a:noFill/>
+        </p:spPr>
+        <p:txBody>
+          <a:bodyPr wrap="square" anchor="t" lIns="27432" rIns="27432" tIns="22860" bIns="22860">
+            <a:spAutoFit/>
+          </a:bodyPr>
+          <a:lstStyle/>
+          <a:p>
+            <a:pPr algn="ctr"/>
+            <a:r>
+              <a:rPr sz="2200" b="0" i="0">
+                <a:solidFill>
+                  <a:srgbClr val="5C4826"/>
+                </a:solidFill>
+              </a:rPr>
+              <a:t>Model the entire control structure — every level, every loop.</a:t>
+            </a:r>
+          </a:p>
+        </p:txBody>
+      </p:sp>
+    </p:spTree>
+  </p:cSld>
+  <p:clrMapOvr>
+    <a:masterClrMapping/>
+  </p:clrMapOvr>
+</p:sld>
+</file>
+
+<file path=ppt/slides/slide17.xml><?xml version="1.0" encoding="utf-8"?>
+<p:sld xmlns:a="http://schemas.openxmlformats.org/drawingml/2006/main" xmlns:p="http://schemas.openxmlformats.org/presentationml/2006/main" xmlns:r="http://schemas.openxmlformats.org/officeDocument/2006/relationships">
+  <p:cSld>
+    <p:spTree>
+      <p:nvGrpSpPr>
+        <p:cNvPr id="1" name=""/>
+        <p:cNvGrpSpPr/>
+        <p:nvPr/>
+      </p:nvGrpSpPr>
+      <p:grpSpPr/>
+      <p:sp>
+        <p:nvSpPr>
+          <p:cNvPr id="3" name="Title 2"/>
+          <p:cNvSpPr>
+            <a:spLocks noGrp="1"/>
+          </p:cNvSpPr>
+          <p:nvPr>
+            <p:ph type="title"/>
+          </p:nvPr>
+        </p:nvSpPr>
+        <p:spPr/>
+        <p:txBody>
+          <a:bodyPr/>
+          <a:lstStyle/>
+          <a:p>
+            <a:r>
+              <a:rPr sz="2400" b="0" i="0">
+                <a:solidFill>
+                  <a:srgbClr val="000000"/>
+                </a:solidFill>
+              </a:rPr>
+              <a:t>More complete can become less actionable</a:t>
+            </a:r>
+          </a:p>
+        </p:txBody>
+      </p:sp>
+      <p:sp>
+        <p:nvSpPr>
+          <p:cNvPr id="900" name="Slide Number Placeholder 900"/>
+          <p:cNvSpPr>
+            <a:spLocks noGrp="1"/>
+          </p:cNvSpPr>
+          <p:nvPr>
+            <p:ph type="sldNum" sz="quarter" idx="4"/>
+          </p:nvPr>
+        </p:nvSpPr>
+        <p:spPr/>
+        <p:txBody>
+          <a:bodyPr/>
+          <a:lstStyle/>
+          <a:p>
+            <a:fld id="{C081D2A1-8AAE-4C69-B798-CC856F26A35C}" type="slidenum">
+              <a:rPr lang="en-US" smtClean="0"/>
+              <a:t>17</a:t>
+            </a:fld>
+            <a:endParaRPr lang="en-US"/>
+          </a:p>
+        </p:txBody>
+      </p:sp>
+      <p:sp>
+        <p:nvSpPr>
+          <p:cNvPr id="901" name="Card"/>
+          <p:cNvSpPr/>
+          <p:nvPr/>
+        </p:nvSpPr>
+        <p:spPr>
+          <a:xfrm>
+            <a:off x="548640" y="2103120"/>
+            <a:ext cx="1828800" cy="822960"/>
+          </a:xfrm>
+          <a:prstGeom prst="rect">
+            <a:avLst/>
+          </a:prstGeom>
+          <a:solidFill>
+            <a:srgbClr val="F5F1E8"/>
+          </a:solidFill>
+          <a:ln w="12700">
+            <a:solidFill>
+              <a:srgbClr val="C9B991"/>
+            </a:solidFill>
+          </a:ln>
+          <a:effectLst/>
+        </p:spPr>
+        <p:style>
+          <a:lnRef idx="1">
+            <a:schemeClr val="accent1"/>
+          </a:lnRef>
+          <a:fillRef idx="3">
+            <a:schemeClr val="accent1"/>
+          </a:fillRef>
+          <a:effectRef idx="2">
+            <a:schemeClr val="accent1"/>
+          </a:effectRef>
+          <a:fontRef idx="minor">
+            <a:schemeClr val="lt1"/>
+          </a:fontRef>
+        </p:style>
+        <p:txBody>
+          <a:bodyPr rtlCol="0" anchor="ctr" wrap="square" lIns="27432" rIns="27432" tIns="22860" bIns="22860"/>
+          <a:lstStyle/>
+          <a:p>
+            <a:pPr algn="ctr"/>
+            <a:r>
+              <a:rPr sz="2000" b="1" i="0">
+                <a:solidFill>
+                  <a:srgbClr val="5C4826"/>
+                </a:solidFill>
+              </a:rPr>
+              <a:t>Human error</a:t>
+            </a:r>
+          </a:p>
+        </p:txBody>
+      </p:sp>
+      <p:sp>
+        <p:nvSpPr>
+          <p:cNvPr id="902" name="Card"/>
+          <p:cNvSpPr/>
+          <p:nvPr/>
+        </p:nvSpPr>
+        <p:spPr>
+          <a:xfrm>
+            <a:off x="2624328" y="2103120"/>
+            <a:ext cx="1828800" cy="822960"/>
+          </a:xfrm>
+          <a:prstGeom prst="rect">
+            <a:avLst/>
+          </a:prstGeom>
+          <a:solidFill>
+            <a:srgbClr val="F5F1E8"/>
+          </a:solidFill>
+          <a:ln w="12700">
+            <a:solidFill>
+              <a:srgbClr val="C9B991"/>
+            </a:solidFill>
+          </a:ln>
+          <a:effectLst/>
+        </p:spPr>
+        <p:style>
+          <a:lnRef idx="1">
+            <a:schemeClr val="accent1"/>
+          </a:lnRef>
+          <a:fillRef idx="3">
+            <a:schemeClr val="accent1"/>
+          </a:fillRef>
+          <a:effectRef idx="2">
+            <a:schemeClr val="accent1"/>
+          </a:effectRef>
+          <a:fontRef idx="minor">
+            <a:schemeClr val="lt1"/>
+          </a:fontRef>
+        </p:style>
+        <p:txBody>
+          <a:bodyPr rtlCol="0" anchor="ctr" wrap="square" lIns="27432" rIns="27432" tIns="22860" bIns="22860"/>
+          <a:lstStyle/>
+          <a:p>
+            <a:pPr algn="ctr"/>
+            <a:r>
+              <a:rPr sz="2000" b="1" i="0">
+                <a:solidFill>
+                  <a:srgbClr val="5C4826"/>
+                </a:solidFill>
+              </a:rPr>
+              <a:t>Swiss cheese</a:t>
+            </a:r>
+          </a:p>
+        </p:txBody>
+      </p:sp>
+      <p:sp>
+        <p:nvSpPr>
+          <p:cNvPr id="903" name="Card"/>
+          <p:cNvSpPr/>
+          <p:nvPr/>
+        </p:nvSpPr>
+        <p:spPr>
+          <a:xfrm>
+            <a:off x="4700016" y="2103120"/>
+            <a:ext cx="1828800" cy="822960"/>
+          </a:xfrm>
+          <a:prstGeom prst="rect">
+            <a:avLst/>
+          </a:prstGeom>
+          <a:solidFill>
+            <a:srgbClr val="F5F1E8"/>
+          </a:solidFill>
+          <a:ln w="12700">
+            <a:solidFill>
+              <a:srgbClr val="C9B991"/>
+            </a:solidFill>
+          </a:ln>
+          <a:effectLst/>
+        </p:spPr>
+        <p:style>
+          <a:lnRef idx="1">
+            <a:schemeClr val="accent1"/>
+          </a:lnRef>
+          <a:fillRef idx="3">
+            <a:schemeClr val="accent1"/>
+          </a:fillRef>
+          <a:effectRef idx="2">
+            <a:schemeClr val="accent1"/>
+          </a:effectRef>
+          <a:fontRef idx="minor">
+            <a:schemeClr val="lt1"/>
+          </a:fontRef>
+        </p:style>
+        <p:txBody>
+          <a:bodyPr rtlCol="0" anchor="ctr" wrap="square" lIns="27432" rIns="27432" tIns="22860" bIns="22860"/>
+          <a:lstStyle/>
+          <a:p>
+            <a:pPr algn="ctr"/>
+            <a:r>
+              <a:rPr sz="2000" b="1" i="0">
+                <a:solidFill>
+                  <a:srgbClr val="5C4826"/>
+                </a:solidFill>
+              </a:rPr>
+              <a:t>Organizational</a:t>
+            </a:r>
+          </a:p>
+        </p:txBody>
+      </p:sp>
+      <p:sp>
+        <p:nvSpPr>
+          <p:cNvPr id="904" name="Card"/>
+          <p:cNvSpPr/>
+          <p:nvPr/>
+        </p:nvSpPr>
+        <p:spPr>
+          <a:xfrm>
+            <a:off x="6775704" y="2103120"/>
+            <a:ext cx="1828800" cy="822960"/>
+          </a:xfrm>
+          <a:prstGeom prst="rect">
+            <a:avLst/>
+          </a:prstGeom>
+          <a:solidFill>
+            <a:srgbClr val="F5F1E8"/>
+          </a:solidFill>
+          <a:ln w="12700">
+            <a:solidFill>
+              <a:srgbClr val="C9B991"/>
+            </a:solidFill>
+          </a:ln>
+          <a:effectLst/>
+        </p:spPr>
+        <p:style>
+          <a:lnRef idx="1">
+            <a:schemeClr val="accent1"/>
+          </a:lnRef>
+          <a:fillRef idx="3">
+            <a:schemeClr val="accent1"/>
+          </a:fillRef>
+          <a:effectRef idx="2">
+            <a:schemeClr val="accent1"/>
+          </a:effectRef>
+          <a:fontRef idx="minor">
+            <a:schemeClr val="lt1"/>
+          </a:fontRef>
+        </p:style>
+        <p:txBody>
+          <a:bodyPr rtlCol="0" anchor="ctr" wrap="square" lIns="27432" rIns="27432" tIns="22860" bIns="22860"/>
+          <a:lstStyle/>
+          <a:p>
+            <a:pPr algn="ctr"/>
+            <a:r>
+              <a:rPr sz="2000" b="1" i="0">
+                <a:solidFill>
+                  <a:srgbClr val="5C4826"/>
+                </a:solidFill>
+              </a:rPr>
+              <a:t>STAMP</a:t>
+            </a:r>
+          </a:p>
+        </p:txBody>
+      </p:sp>
+      <p:cxnSp>
+        <p:nvCxnSpPr>
+          <p:cNvPr id="905" name="Connector 904"/>
+          <p:cNvCxnSpPr/>
+          <p:nvPr/>
+        </p:nvCxnSpPr>
+        <p:spPr>
+          <a:xfrm>
+            <a:off x="548640" y="3383280"/>
+            <a:ext cx="8001000" cy="0"/>
+          </a:xfrm>
+          <a:prstGeom prst="line">
+            <a:avLst/>
+          </a:prstGeom>
+          <a:ln w="28575">
+            <a:solidFill>
+              <a:srgbClr val="8E6F3E"/>
+            </a:solidFill>
+            <a:tailEnd type="triangle"/>
+          </a:ln>
+        </p:spPr>
+        <p:style>
+          <a:lnRef idx="2">
+            <a:schemeClr val="accent1"/>
+          </a:lnRef>
+          <a:fillRef idx="0">
+            <a:schemeClr val="accent1"/>
+          </a:fillRef>
+          <a:effectRef idx="1">
+            <a:schemeClr val="accent1"/>
+          </a:effectRef>
+          <a:fontRef idx="minor">
+            <a:schemeClr val="tx1"/>
+          </a:fontRef>
+        </p:style>
+      </p:cxnSp>
+      <p:sp>
+        <p:nvSpPr>
+          <p:cNvPr id="906" name="Label"/>
+          <p:cNvSpPr txBox="1"/>
+          <p:nvPr/>
+        </p:nvSpPr>
+        <p:spPr>
+          <a:xfrm>
+            <a:off x="548640" y="3520440"/>
+            <a:ext cx="8046720" cy="411480"/>
+          </a:xfrm>
+          <a:prstGeom prst="rect">
+            <a:avLst/>
+          </a:prstGeom>
+          <a:noFill/>
+        </p:spPr>
+        <p:txBody>
+          <a:bodyPr wrap="square" anchor="t" lIns="27432" rIns="27432" tIns="22860" bIns="22860">
+            <a:spAutoFit/>
+          </a:bodyPr>
+          <a:lstStyle/>
+          <a:p>
+            <a:pPr algn="ctr"/>
+            <a:r>
+              <a:rPr sz="2000" b="1" i="0">
+                <a:solidFill>
+                  <a:srgbClr val="8E6F3E"/>
+                </a:solidFill>
+              </a:rPr>
+              <a:t>more complete →</a:t>
+            </a:r>
+          </a:p>
+        </p:txBody>
+      </p:sp>
+    </p:spTree>
+  </p:cSld>
+  <p:clrMapOvr>
+    <a:masterClrMapping/>
+  </p:clrMapOvr>
+</p:sld>
+</file>
+
+<file path=ppt/slides/slide18.xml><?xml version="1.0" encoding="utf-8"?>
+<p:sld xmlns:a="http://schemas.openxmlformats.org/drawingml/2006/main" xmlns:p="http://schemas.openxmlformats.org/presentationml/2006/main" xmlns:r="http://schemas.openxmlformats.org/officeDocument/2006/relationships">
+  <p:cSld>
+    <p:spTree>
+      <p:nvGrpSpPr>
+        <p:cNvPr id="1" name=""/>
+        <p:cNvGrpSpPr/>
+        <p:nvPr/>
+      </p:nvGrpSpPr>
+      <p:grpSpPr/>
+      <p:sp>
+        <p:nvSpPr>
+          <p:cNvPr id="3" name="Title 2"/>
+          <p:cNvSpPr>
+            <a:spLocks noGrp="1"/>
+          </p:cNvSpPr>
+          <p:nvPr>
+            <p:ph type="title"/>
+          </p:nvPr>
+        </p:nvSpPr>
+        <p:spPr/>
+        <p:txBody>
+          <a:bodyPr/>
+          <a:lstStyle/>
+          <a:p>
+            <a:r>
+              <a:rPr sz="2400" b="0" i="0">
+                <a:solidFill>
+                  <a:srgbClr val="000000"/>
+                </a:solidFill>
+              </a:rPr>
+              <a:t>Match the causal model to the locus of control</a:t>
+            </a:r>
+          </a:p>
+        </p:txBody>
+      </p:sp>
+      <p:sp>
+        <p:nvSpPr>
+          <p:cNvPr id="900" name="Slide Number Placeholder 900"/>
+          <p:cNvSpPr>
+            <a:spLocks noGrp="1"/>
+          </p:cNvSpPr>
+          <p:nvPr>
+            <p:ph type="sldNum" sz="quarter" idx="4"/>
+          </p:nvPr>
+        </p:nvSpPr>
+        <p:spPr/>
+        <p:txBody>
+          <a:bodyPr/>
+          <a:lstStyle/>
+          <a:p>
+            <a:fld id="{2B19A40B-0D44-4B8E-9931-7BD3CA1819BF}" type="slidenum">
+              <a:rPr lang="en-US" smtClean="0"/>
+              <a:t>18</a:t>
+            </a:fld>
+            <a:endParaRPr lang="en-US"/>
+          </a:p>
+        </p:txBody>
+      </p:sp>
+      <p:graphicFrame>
+        <p:nvGraphicFramePr>
+          <p:cNvPr id="901" name="Table 900"/>
+          <p:cNvGraphicFramePr>
+            <a:graphicFrameLocks noGrp="1"/>
+          </p:cNvGraphicFramePr>
+          <p:nvPr/>
+        </p:nvGraphicFramePr>
+        <p:xfrm>
+          <a:off x="731520" y="1280160"/>
+          <a:ext cx="7680960" cy="3291840"/>
+        </p:xfrm>
+        <a:graphic>
+          <a:graphicData uri="http://schemas.openxmlformats.org/drawingml/2006/table">
+            <a:tbl>
+              <a:tblPr firstRow="1" bandRow="1">
+                <a:tableStyleId>{5C22544A-7EE6-4342-B048-85BDC9FD1C3A}</a:tableStyleId>
+              </a:tblPr>
+              <a:tblGrid>
+                <a:gridCol w="2651760"/>
+                <a:gridCol w="5029200"/>
+              </a:tblGrid>
+              <a:tr h="658368">
+                <a:tc>
+                  <a:txBody>
+                    <a:bodyPr/>
+                    <a:lstStyle/>
+                    <a:p>
+                      <a:pPr algn="l"/>
+                      <a:r>
+                        <a:rPr sz="2000" b="1" i="0">
+                          <a:solidFill>
+                            <a:srgbClr val="FFFFFF"/>
+                          </a:solidFill>
+                        </a:rPr>
+                        <a:t>CAUSAL MODEL</a:t>
+                      </a:r>
+                    </a:p>
+                  </a:txBody>
+                  <a:tcPr anchor="ctr" marL="54864">
+                    <a:solidFill>
+                      <a:srgbClr val="8E6F3E"/>
+                    </a:solidFill>
+                  </a:tcPr>
+                </a:tc>
+                <a:tc>
+                  <a:txBody>
+                    <a:bodyPr/>
+                    <a:lstStyle/>
+                    <a:p>
+                      <a:pPr algn="l"/>
+                      <a:r>
+                        <a:rPr sz="2000" b="1" i="0">
+                          <a:solidFill>
+                            <a:srgbClr val="FFFFFF"/>
+                          </a:solidFill>
+                        </a:rPr>
+                        <a:t>THE LEVER IT HANDS YOU</a:t>
+                      </a:r>
+                    </a:p>
+                  </a:txBody>
+                  <a:tcPr anchor="ctr" marL="54864">
+                    <a:solidFill>
+                      <a:srgbClr val="8E6F3E"/>
+                    </a:solidFill>
+                  </a:tcPr>
+                </a:tc>
+              </a:tr>
+              <a:tr h="658368">
+                <a:tc>
+                  <a:txBody>
+                    <a:bodyPr/>
+                    <a:lstStyle/>
+                    <a:p>
+                      <a:pPr algn="l"/>
+                      <a:r>
+                        <a:rPr sz="2000" b="1" i="0">
+                          <a:solidFill>
+                            <a:srgbClr val="5C4826"/>
+                          </a:solidFill>
+                        </a:rPr>
+                        <a:t>Human error</a:t>
+                      </a:r>
+                    </a:p>
+                  </a:txBody>
+                  <a:tcPr anchor="ctr" marL="54864">
+                    <a:solidFill>
+                      <a:srgbClr val="F5F1E8"/>
+                    </a:solidFill>
+                  </a:tcPr>
+                </a:tc>
+                <a:tc>
+                  <a:txBody>
+                    <a:bodyPr/>
+                    <a:lstStyle/>
+                    <a:p>
+                      <a:pPr algn="l"/>
+                      <a:r>
+                        <a:rPr sz="2000" b="0" i="0">
+                          <a:solidFill>
+                            <a:srgbClr val="5C4826"/>
+                          </a:solidFill>
+                        </a:rPr>
+                        <a:t>an individual's behavior</a:t>
+                      </a:r>
+                    </a:p>
+                  </a:txBody>
+                  <a:tcPr anchor="ctr" marL="54864">
+                    <a:solidFill>
+                      <a:srgbClr val="F5F1E8"/>
+                    </a:solidFill>
+                  </a:tcPr>
+                </a:tc>
+              </a:tr>
+              <a:tr h="658368">
+                <a:tc>
+                  <a:txBody>
+                    <a:bodyPr/>
+                    <a:lstStyle/>
+                    <a:p>
+                      <a:pPr algn="l"/>
+                      <a:r>
+                        <a:rPr sz="2000" b="1" i="0">
+                          <a:solidFill>
+                            <a:srgbClr val="5C4826"/>
+                          </a:solidFill>
+                        </a:rPr>
+                        <a:t>Swiss cheese</a:t>
+                      </a:r>
+                    </a:p>
+                  </a:txBody>
+                  <a:tcPr anchor="ctr" marL="54864">
+                    <a:solidFill>
+                      <a:srgbClr val="FBF8F2"/>
+                    </a:solidFill>
+                  </a:tcPr>
+                </a:tc>
+                <a:tc>
+                  <a:txBody>
+                    <a:bodyPr/>
+                    <a:lstStyle/>
+                    <a:p>
+                      <a:pPr algn="l"/>
+                      <a:r>
+                        <a:rPr sz="2000" b="0" i="0">
+                          <a:solidFill>
+                            <a:srgbClr val="5C4826"/>
+                          </a:solidFill>
+                        </a:rPr>
+                        <a:t>the set of defenses</a:t>
+                      </a:r>
+                    </a:p>
+                  </a:txBody>
+                  <a:tcPr anchor="ctr" marL="54864">
+                    <a:solidFill>
+                      <a:srgbClr val="FBF8F2"/>
+                    </a:solidFill>
+                  </a:tcPr>
+                </a:tc>
+              </a:tr>
+              <a:tr h="658368">
+                <a:tc>
+                  <a:txBody>
+                    <a:bodyPr/>
+                    <a:lstStyle/>
+                    <a:p>
+                      <a:pPr algn="l"/>
+                      <a:r>
+                        <a:rPr sz="2000" b="1" i="0">
+                          <a:solidFill>
+                            <a:srgbClr val="5C4826"/>
+                          </a:solidFill>
+                        </a:rPr>
+                        <a:t>Organizational</a:t>
+                      </a:r>
+                    </a:p>
+                  </a:txBody>
+                  <a:tcPr anchor="ctr" marL="54864">
+                    <a:solidFill>
+                      <a:srgbClr val="F5F1E8"/>
+                    </a:solidFill>
+                  </a:tcPr>
+                </a:tc>
+                <a:tc>
+                  <a:txBody>
+                    <a:bodyPr/>
+                    <a:lstStyle/>
+                    <a:p>
+                      <a:pPr algn="l"/>
+                      <a:r>
+                        <a:rPr sz="2000" b="0" i="0">
+                          <a:solidFill>
+                            <a:srgbClr val="5C4826"/>
+                          </a:solidFill>
+                        </a:rPr>
+                        <a:t>the conditions that shape behavior</a:t>
+                      </a:r>
+                    </a:p>
+                  </a:txBody>
+                  <a:tcPr anchor="ctr" marL="54864">
+                    <a:solidFill>
+                      <a:srgbClr val="F5F1E8"/>
+                    </a:solidFill>
+                  </a:tcPr>
+                </a:tc>
+              </a:tr>
+              <a:tr h="658368">
+                <a:tc>
+                  <a:txBody>
+                    <a:bodyPr/>
+                    <a:lstStyle/>
+                    <a:p>
+                      <a:pPr algn="l"/>
+                      <a:r>
+                        <a:rPr sz="2000" b="1" i="0">
+                          <a:solidFill>
+                            <a:srgbClr val="5C4826"/>
+                          </a:solidFill>
+                        </a:rPr>
+                        <a:t>STAMP</a:t>
+                      </a:r>
+                    </a:p>
+                  </a:txBody>
+                  <a:tcPr anchor="ctr" marL="54864">
+                    <a:solidFill>
+                      <a:srgbClr val="FBF8F2"/>
+                    </a:solidFill>
+                  </a:tcPr>
+                </a:tc>
+                <a:tc>
+                  <a:txBody>
+                    <a:bodyPr/>
+                    <a:lstStyle/>
+                    <a:p>
+                      <a:pPr algn="l"/>
+                      <a:r>
+                        <a:rPr sz="2000" b="0" i="0">
+                          <a:solidFill>
+                            <a:srgbClr val="5C4826"/>
+                          </a:solidFill>
+                        </a:rPr>
+                        <a:t>the whole control structure</a:t>
+                      </a:r>
+                    </a:p>
+                  </a:txBody>
+                  <a:tcPr anchor="ctr" marL="54864">
+                    <a:solidFill>
+                      <a:srgbClr val="FBF8F2"/>
+                    </a:solidFill>
+                  </a:tcPr>
+                </a:tc>
+              </a:tr>
+            </a:tbl>
+          </a:graphicData>
+        </a:graphic>
+      </p:graphicFrame>
+      <p:sp>
+        <p:nvSpPr>
+          <p:cNvPr id="902" name="FooterBand"/>
+          <p:cNvSpPr/>
+          <p:nvPr/>
+        </p:nvSpPr>
+        <p:spPr>
+          <a:xfrm>
+            <a:off x="274320" y="5852159"/>
+            <a:ext cx="8595360" cy="566928"/>
+          </a:xfrm>
+          <a:prstGeom prst="rect">
+            <a:avLst/>
+          </a:prstGeom>
+          <a:solidFill>
+            <a:srgbClr val="8E6F3E"/>
+          </a:solidFill>
+          <a:ln>
+            <a:noFill/>
+          </a:ln>
+          <a:effectLst/>
+        </p:spPr>
+        <p:style>
+          <a:lnRef idx="1">
+            <a:schemeClr val="accent1"/>
+          </a:lnRef>
+          <a:fillRef idx="3">
+            <a:schemeClr val="accent1"/>
+          </a:fillRef>
+          <a:effectRef idx="2">
+            <a:schemeClr val="accent1"/>
+          </a:effectRef>
+          <a:fontRef idx="minor">
+            <a:schemeClr val="lt1"/>
+          </a:fontRef>
+        </p:style>
+        <p:txBody>
+          <a:bodyPr rtlCol="0" anchor="ctr" wrap="square" lIns="27432" rIns="27432" tIns="22860" bIns="22860"/>
+          <a:lstStyle/>
+          <a:p>
+            <a:pPr algn="ctr"/>
+            <a:r>
+              <a:rPr sz="2000" b="1" i="0">
+                <a:solidFill>
+                  <a:srgbClr val="FFFFFF"/>
+                </a:solidFill>
+              </a:rPr>
+              <a:t>Choose the model whose levers you actually hold.</a:t>
             </a:r>
           </a:p>
         </p:txBody>
@@ -5535,7 +9449,7 @@
           <a:bodyPr/>
           <a:lstStyle/>
           <a:p>
-            <a:fld id="{155AE75C-AB6C-4125-BFE9-406CA83A7CFB}" type="slidenum">
+            <a:fld id="{6B89A994-9FE4-4018-8D0C-C44F8B0CB085}" type="slidenum">
               <a:rPr lang="en-US" smtClean="0"/>
               <a:t>2</a:t>
             </a:fld>
@@ -5898,7 +9812,7 @@
           <a:bodyPr/>
           <a:lstStyle/>
           <a:p>
-            <a:fld id="{01BDC517-05B0-4E8B-A3B4-B370FFB86ED8}" type="slidenum">
+            <a:fld id="{0E283878-7FEA-4811-B90C-385DB6556BF2}" type="slidenum">
               <a:rPr lang="en-US" smtClean="0"/>
               <a:t>3</a:t>
             </a:fld>
@@ -6381,7 +10295,7 @@
           <a:bodyPr/>
           <a:lstStyle/>
           <a:p>
-            <a:fld id="{FA37DE62-963E-48C9-8611-6D485901781C}" type="slidenum">
+            <a:fld id="{0C1F7B64-CBB4-464E-AB41-FA37D38811D8}" type="slidenum">
               <a:rPr lang="en-US" smtClean="0"/>
               <a:t>4</a:t>
             </a:fld>
@@ -7124,7 +11038,7 @@
           <a:bodyPr/>
           <a:lstStyle/>
           <a:p>
-            <a:fld id="{0804328E-D302-45E8-A742-60DF59624496}" type="slidenum">
+            <a:fld id="{B2F585DF-8792-4B44-A55D-46AF45B931D7}" type="slidenum">
               <a:rPr lang="en-US" smtClean="0"/>
               <a:t>5</a:t>
             </a:fld>
@@ -7471,7 +11385,7 @@
           <a:bodyPr/>
           <a:lstStyle/>
           <a:p>
-            <a:fld id="{343BFF32-1C9F-4A02-9534-4892B77E7903}" type="slidenum">
+            <a:fld id="{2A4C8AD4-B258-43AE-BB11-07B720D492DE}" type="slidenum">
               <a:rPr lang="en-US" smtClean="0"/>
               <a:t>6</a:t>
             </a:fld>
@@ -7714,7 +11628,7 @@
           <a:bodyPr/>
           <a:lstStyle/>
           <a:p>
-            <a:fld id="{0C380F64-5589-4881-9E79-1E838A302942}" type="slidenum">
+            <a:fld id="{B63FC52C-085A-44CD-88FF-F0B89574F0D7}" type="slidenum">
               <a:rPr lang="en-US" smtClean="0"/>
               <a:t>7</a:t>
             </a:fld>
@@ -7966,7 +11880,7 @@
           <a:bodyPr/>
           <a:lstStyle/>
           <a:p>
-            <a:fld id="{32CCAD70-5FE6-481C-AFBB-4BE502F26105}" type="slidenum">
+            <a:fld id="{EB2254B0-2847-446D-A99B-3B146C8B0742}" type="slidenum">
               <a:rPr lang="en-US" smtClean="0"/>
               <a:t>8</a:t>
             </a:fld>
@@ -8760,7 +12674,7 @@
           <a:bodyPr/>
           <a:lstStyle/>
           <a:p>
-            <a:fld id="{90B43C42-9F52-4E8B-B110-4C9922864C05}" type="slidenum">
+            <a:fld id="{1AD63376-E242-4330-85AB-CDFE7346944A}" type="slidenum">
               <a:rPr lang="en-US" smtClean="0"/>
               <a:t>9</a:t>
             </a:fld>

</xml_diff>

<commit_message>
deck 2-4 section 1: expanding causal boundary, not a completeness ladder
Human error gets the INDIVIDUAL->action->outcome chain ('Useful, but narrow.');
Swiss cheese slabs labelled DEFENSE; Organizational gains the condition examples;
STAMP retitled 'Model the control structure'; the comparison slide becomes 'A
broader model is not automatically a better model' with a structure-represented
axis; the table slide becomes 'Match causal breadth to the decision' with the
outside-your-authority qualification carried in notes.
</commit_message>
<xml_diff>
--- a/course/lectures/act-2-delegation-and-control/04-failure-aware-engineering/2-4-Failure-Aware-Engineering.pptx
+++ b/course/lectures/act-2-delegation-and-control/04-failure-aware-engineering/2-4-Failure-Aware-Engineering.pptx
@@ -803,12 +803,12 @@
           </a:p>
           <a:p>
             <a:r>
-              <a:t>- Put student answers on screen, verbatim, as they come.</a:t>
-            </a:r>
-          </a:p>
-          <a:p>
-            <a:r>
-              <a:t>- Keep the list visible; the next slides test candidate causal models against it.</a:t>
+              <a:t>- The LAST open-ended Volkswagen diagnosis. Put student answers on screen, verbatim, as they come.</a:t>
+            </a:r>
+          </a:p>
+          <a:p>
+            <a:r>
+              <a:t>- Do not classify the answers yet - just collect. Keep the list visible through the four causal-model slides if the room setup allows; each model will claim some of the answers.</a:t>
             </a:r>
           </a:p>
         </p:txBody>
@@ -878,12 +878,22 @@
           <a:lstStyle/>
           <a:p>
             <a:r>
-              <a:t>TIMING: 1-2 minutes</a:t>
+              <a:t>TIMING: 1 minute - keep this fast (30-45 seconds of talk).</a:t>
+            </a:r>
+          </a:p>
+          <a:p>
+            <a:r>
+              <a:t>- The narrowest causal boundary: an individual acted, the action produced the outcome.</a:t>
             </a:r>
           </a:p>
           <a:p>
             <a:r>
               <a:t>- Test it against the story: objections, escalation, authorization, delegation to IAV, year-after-year certification. One individual does not account for that.</a:t>
+            </a:r>
+          </a:p>
+          <a:p>
+            <a:r>
+              <a:t>- "Narrow" is not "useless": there can be several interventions at this level, but they all address the individual.</a:t>
             </a:r>
           </a:p>
         </p:txBody>
@@ -953,7 +963,7 @@
           <a:lstStyle/>
           <a:p>
             <a:r>
-              <a:t>TIMING: 1-2 minutes</a:t>
+              <a:t>TIMING: 1 minute - keep this fast (30-45 seconds of talk).</a:t>
             </a:r>
           </a:p>
           <a:p>
@@ -963,7 +973,7 @@
           </a:p>
           <a:p>
             <a:r>
-              <a:t>- Test it against the story: which defenses existed, and where were the holes? The intervention unit becomes the defenses, not the individual.</a:t>
+              <a:t>- The causal boundary widens: not just the act, but the state of every defense it passed through. Test against the story: which defenses existed, and where were the holes?</a:t>
             </a:r>
           </a:p>
         </p:txBody>
@@ -1033,17 +1043,17 @@
           <a:lstStyle/>
           <a:p>
             <a:r>
-              <a:t>TIMING: 1-2 minutes</a:t>
-            </a:r>
-          </a:p>
-          <a:p>
-            <a:r>
-              <a:t>- The causal story moves up a level: the conditions that shaped behavior, not the behavior alone.</a:t>
-            </a:r>
-          </a:p>
-          <a:p>
-            <a:r>
-              <a:t>- Test it against the story: what conditions sustained the same result model year after model year?</a:t>
+              <a:t>TIMING: 1 minute - keep this fast (30-45 seconds of talk).</a:t>
+            </a:r>
+          </a:p>
+          <a:p>
+            <a:r>
+              <a:t>- The causal story moves up a level: conditions -&gt; behavior -&gt; outcome.</a:t>
+            </a:r>
+          </a:p>
+          <a:p>
+            <a:r>
+              <a:t>- Test against the story: what conditions (authority, incentives, schedule, ownership) sustained the same result model year after model year?</a:t>
             </a:r>
           </a:p>
         </p:txBody>
@@ -1118,12 +1128,12 @@
           </a:p>
           <a:p>
             <a:r>
-              <a:t>- [Author: the old slide-12 STAMP narration lands here.]</a:t>
-            </a:r>
-          </a:p>
-          <a:p>
-            <a:r>
-              <a:t>- A systems-theoretic account: include every level of control and feedback, from regulators down to the operating process.</a:t>
+              <a:t>- A systems-theoretic account: constraints flow down, feedback flows up, from regulators through the organization and engineering to the operating process.</a:t>
+            </a:r>
+          </a:p>
+          <a:p>
+            <a:r>
+              <a:t>- Present it seriously - it is a modeling discipline, not a punchline. The cost arrives on the next slide: breadth demands evidence and authority.</a:t>
             </a:r>
           </a:p>
         </p:txBody>
@@ -1198,12 +1208,12 @@
           </a:p>
           <a:p>
             <a:r>
-              <a:t>- Each model includes more of the causal story than the last.</a:t>
-            </a:r>
-          </a:p>
-          <a:p>
-            <a:r>
-              <a:t>- But a more complete account is not automatically a more usable one: as the account widens, more of it lies outside what any one engineer or team can change.</a:t>
+              <a:t>- The axis is causal boundary, not completeness: each model REPRESENTS more structure than the last; none is automatically better.</a:t>
+            </a:r>
+          </a:p>
+          <a:p>
+            <a:r>
+              <a:t>- Broader models expose more relationships - and demand more evidence and more authority to act on what they expose.</a:t>
             </a:r>
           </a:p>
         </p:txBody>
@@ -1278,12 +1288,17 @@
           </a:p>
           <a:p>
             <a:r>
-              <a:t>- Now the line has concrete meaning rather than being abstract modeling doctrine.</a:t>
-            </a:r>
-          </a:p>
-          <a:p>
-            <a:r>
-              <a:t>- Connect back to the student answers from the opening slide of this section: each answer was implicitly one of these models.</a:t>
+              <a:t>- The locus of control is the criterion, not the goal: model far enough to reach the decisions that can change the outcome.</a:t>
+            </a:r>
+          </a:p>
+          <a:p>
+            <a:r>
+              <a:t>- QUALIFICATION (carry this verbally): a relevant cause can lie outside your authority. Do not erase it - escalate it, compensate for it, or identify it as the reason a local fix is insufficient.</a:t>
+            </a:r>
+          </a:p>
+          <a:p>
+            <a:r>
+              <a:t>- Connect back to the student answers from the opening of this section: each answer was implicitly one of these models.</a:t>
             </a:r>
           </a:p>
         </p:txBody>
@@ -8855,14 +8870,154 @@
       </p:sp>
       <p:sp>
         <p:nvSpPr>
-          <p:cNvPr id="901" name="Card"/>
+          <p:cNvPr id="904" name="FooterBand"/>
           <p:cNvSpPr/>
           <p:nvPr/>
         </p:nvSpPr>
         <p:spPr>
           <a:xfrm>
-            <a:off x="548640" y="1463040"/>
-            <a:ext cx="3749039" cy="2377440"/>
+            <a:off x="274320" y="5852159"/>
+            <a:ext cx="8595360" cy="566928"/>
+          </a:xfrm>
+          <a:prstGeom prst="rect">
+            <a:avLst/>
+          </a:prstGeom>
+          <a:solidFill>
+            <a:srgbClr val="8E6F3E"/>
+          </a:solidFill>
+          <a:ln>
+            <a:noFill/>
+          </a:ln>
+          <a:effectLst/>
+        </p:spPr>
+        <p:style>
+          <a:lnRef idx="1">
+            <a:schemeClr val="accent1"/>
+          </a:lnRef>
+          <a:fillRef idx="3">
+            <a:schemeClr val="accent1"/>
+          </a:fillRef>
+          <a:effectRef idx="2">
+            <a:schemeClr val="accent1"/>
+          </a:effectRef>
+          <a:fontRef idx="minor">
+            <a:schemeClr val="lt1"/>
+          </a:fontRef>
+        </p:style>
+        <p:txBody>
+          <a:bodyPr rtlCol="0" anchor="ctr" wrap="square" lIns="27432" rIns="27432" tIns="22860" bIns="22860"/>
+          <a:lstStyle/>
+          <a:p>
+            <a:pPr algn="ctr"/>
+            <a:r>
+              <a:rPr sz="2000" b="1" i="0">
+                <a:solidFill>
+                  <a:srgbClr val="FFFFFF"/>
+                </a:solidFill>
+              </a:rPr>
+              <a:t>Useful, but narrow.</a:t>
+            </a:r>
+          </a:p>
+        </p:txBody>
+      </p:sp>
+      <p:sp>
+        <p:nvSpPr>
+          <p:cNvPr id="910" name="Block"/>
+          <p:cNvSpPr/>
+          <p:nvPr/>
+        </p:nvSpPr>
+        <p:spPr>
+          <a:xfrm>
+            <a:off x="822960" y="2103120"/>
+            <a:ext cx="2194560" cy="731520"/>
+          </a:xfrm>
+          <a:prstGeom prst="rect">
+            <a:avLst/>
+          </a:prstGeom>
+          <a:solidFill>
+            <a:srgbClr val="8E6F3E"/>
+          </a:solidFill>
+          <a:ln>
+            <a:noFill/>
+          </a:ln>
+          <a:effectLst/>
+        </p:spPr>
+        <p:style>
+          <a:lnRef idx="1">
+            <a:schemeClr val="accent1"/>
+          </a:lnRef>
+          <a:fillRef idx="3">
+            <a:schemeClr val="accent1"/>
+          </a:fillRef>
+          <a:effectRef idx="2">
+            <a:schemeClr val="accent1"/>
+          </a:effectRef>
+          <a:fontRef idx="minor">
+            <a:schemeClr val="lt1"/>
+          </a:fontRef>
+        </p:style>
+        <p:txBody>
+          <a:bodyPr rtlCol="0" anchor="ctr" wrap="square" lIns="27432" rIns="27432" tIns="22860" bIns="22860"/>
+          <a:lstStyle/>
+          <a:p>
+            <a:pPr algn="ctr"/>
+            <a:r>
+              <a:rPr sz="2000" b="1" i="0">
+                <a:solidFill>
+                  <a:srgbClr val="FFFFFF"/>
+                </a:solidFill>
+              </a:rPr>
+              <a:t>INDIVIDUAL</a:t>
+            </a:r>
+          </a:p>
+        </p:txBody>
+      </p:sp>
+      <p:cxnSp>
+        <p:nvCxnSpPr>
+          <p:cNvPr id="911" name="Connector 911"/>
+          <p:cNvCxnSpPr/>
+          <p:nvPr/>
+        </p:nvCxnSpPr>
+        <p:spPr>
+          <a:xfrm>
+            <a:off x="3017520" y="2468880"/>
+            <a:ext cx="548640" cy="0"/>
+          </a:xfrm>
+          <a:prstGeom prst="line">
+            <a:avLst/>
+          </a:prstGeom>
+          <a:ln w="28575">
+            <a:solidFill>
+              <a:srgbClr val="8E6F3E"/>
+            </a:solidFill>
+            <a:tailEnd type="triangle"/>
+          </a:ln>
+        </p:spPr>
+        <p:style>
+          <a:lnRef idx="2">
+            <a:schemeClr val="accent1"/>
+          </a:lnRef>
+          <a:fillRef idx="0">
+            <a:schemeClr val="accent1"/>
+          </a:fillRef>
+          <a:effectRef idx="1">
+            <a:schemeClr val="accent1"/>
+          </a:effectRef>
+          <a:fontRef idx="minor">
+            <a:schemeClr val="tx1"/>
+          </a:fontRef>
+        </p:style>
+      </p:cxnSp>
+      <p:sp>
+        <p:nvSpPr>
+          <p:cNvPr id="912" name="Card"/>
+          <p:cNvSpPr/>
+          <p:nvPr/>
+        </p:nvSpPr>
+        <p:spPr>
+          <a:xfrm>
+            <a:off x="3566160" y="2103120"/>
+            <a:ext cx="2011680" cy="731520"/>
           </a:xfrm>
           <a:prstGeom prst="rect">
             <a:avLst/>
@@ -8902,35 +9057,20 @@
                   <a:srgbClr val="5C4826"/>
                 </a:solidFill>
               </a:rPr>
-              <a:t>CAUSAL MODEL</a:t>
-            </a:r>
-          </a:p>
-          <a:p>
-            <a:pPr algn="ctr">
-              <a:spcBef>
-                <a:spcPts val="1200"/>
-              </a:spcBef>
-            </a:pPr>
-            <a:r>
-              <a:rPr sz="2000" b="0" i="0">
-                <a:solidFill>
-                  <a:srgbClr val="555960"/>
-                </a:solidFill>
-              </a:rPr>
-              <a:t>An individual erred.</a:t>
+              <a:t>action</a:t>
             </a:r>
           </a:p>
         </p:txBody>
       </p:sp>
       <p:cxnSp>
         <p:nvCxnSpPr>
-          <p:cNvPr id="902" name="Connector 901"/>
+          <p:cNvPr id="913" name="Connector 913"/>
           <p:cNvCxnSpPr/>
           <p:nvPr/>
         </p:nvCxnSpPr>
         <p:spPr>
           <a:xfrm>
-            <a:off x="4389120" y="2651760"/>
+            <a:off x="5577840" y="2468880"/>
             <a:ext cx="548640" cy="0"/>
           </a:xfrm>
           <a:prstGeom prst="line">
@@ -8960,23 +9100,25 @@
       </p:cxnSp>
       <p:sp>
         <p:nvSpPr>
-          <p:cNvPr id="903" name="Block"/>
+          <p:cNvPr id="914" name="Card"/>
           <p:cNvSpPr/>
           <p:nvPr/>
         </p:nvSpPr>
         <p:spPr>
           <a:xfrm>
-            <a:off x="5029200" y="1463040"/>
-            <a:ext cx="3566160" cy="2377440"/>
+            <a:off x="6126480" y="2103120"/>
+            <a:ext cx="2011680" cy="731520"/>
           </a:xfrm>
           <a:prstGeom prst="rect">
             <a:avLst/>
           </a:prstGeom>
           <a:solidFill>
-            <a:srgbClr val="8E6F3E"/>
+            <a:srgbClr val="F5F1E8"/>
           </a:solidFill>
-          <a:ln>
-            <a:noFill/>
+          <a:ln w="12700">
+            <a:solidFill>
+              <a:srgbClr val="C9B991"/>
+            </a:solidFill>
           </a:ln>
           <a:effectLst/>
         </p:spPr>
@@ -9002,73 +9144,68 @@
             <a:r>
               <a:rPr sz="2000" b="1" i="0">
                 <a:solidFill>
-                  <a:srgbClr val="FFFFFF"/>
-                </a:solidFill>
-              </a:rPr>
-              <a:t>ONE INTERVENTION</a:t>
-            </a:r>
-          </a:p>
+                  <a:srgbClr val="5C4826"/>
+                </a:solidFill>
+              </a:rPr>
+              <a:t>outcome</a:t>
+            </a:r>
+          </a:p>
+        </p:txBody>
+      </p:sp>
+      <p:sp>
+        <p:nvSpPr>
+          <p:cNvPr id="915" name="Label"/>
+          <p:cNvSpPr txBox="1"/>
+          <p:nvPr/>
+        </p:nvSpPr>
+        <p:spPr>
+          <a:xfrm>
+            <a:off x="548640" y="3474720"/>
+            <a:ext cx="8046720" cy="457200"/>
+          </a:xfrm>
+          <a:prstGeom prst="rect">
+            <a:avLst/>
+          </a:prstGeom>
+          <a:noFill/>
+        </p:spPr>
+        <p:txBody>
+          <a:bodyPr wrap="square" anchor="t" lIns="27432" rIns="27432" tIns="22860" bIns="22860">
+            <a:spAutoFit/>
+          </a:bodyPr>
+          <a:lstStyle/>
           <a:p>
             <a:pPr algn="ctr"/>
             <a:r>
+              <a:rPr sz="2000" b="1" i="0">
+                <a:solidFill>
+                  <a:srgbClr val="5C4826"/>
+                </a:solidFill>
+              </a:rPr>
+              <a:t>Model: </a:t>
+            </a:r>
+            <a:r>
               <a:rPr sz="2000" b="0" i="0">
                 <a:solidFill>
-                  <a:srgbClr val="FFFFFF"/>
-                </a:solidFill>
-              </a:rPr>
-              <a:t>change the individual</a:t>
-            </a:r>
-          </a:p>
-        </p:txBody>
-      </p:sp>
-      <p:sp>
-        <p:nvSpPr>
-          <p:cNvPr id="904" name="FooterBand"/>
-          <p:cNvSpPr/>
-          <p:nvPr/>
-        </p:nvSpPr>
-        <p:spPr>
-          <a:xfrm>
-            <a:off x="274320" y="5852159"/>
-            <a:ext cx="8595360" cy="566928"/>
-          </a:xfrm>
-          <a:prstGeom prst="rect">
-            <a:avLst/>
-          </a:prstGeom>
-          <a:solidFill>
-            <a:srgbClr val="8E6F3E"/>
-          </a:solidFill>
-          <a:ln>
-            <a:noFill/>
-          </a:ln>
-          <a:effectLst/>
-        </p:spPr>
-        <p:style>
-          <a:lnRef idx="1">
-            <a:schemeClr val="accent1"/>
-          </a:lnRef>
-          <a:fillRef idx="3">
-            <a:schemeClr val="accent1"/>
-          </a:fillRef>
-          <a:effectRef idx="2">
-            <a:schemeClr val="accent1"/>
-          </a:effectRef>
-          <a:fontRef idx="minor">
-            <a:schemeClr val="lt1"/>
-          </a:fontRef>
-        </p:style>
-        <p:txBody>
-          <a:bodyPr rtlCol="0" anchor="ctr" wrap="square" lIns="27432" rIns="27432" tIns="22860" bIns="22860"/>
-          <a:lstStyle/>
-          <a:p>
-            <a:pPr algn="ctr"/>
+                  <a:srgbClr val="555960"/>
+                </a:solidFill>
+              </a:rPr>
+              <a:t>an individual erred.   </a:t>
+            </a:r>
             <a:r>
               <a:rPr sz="2000" b="1" i="0">
                 <a:solidFill>
-                  <a:srgbClr val="FFFFFF"/>
-                </a:solidFill>
-              </a:rPr>
-              <a:t>Useful, but gives one intervention.</a:t>
+                  <a:srgbClr val="5C4826"/>
+                </a:solidFill>
+              </a:rPr>
+              <a:t>Intervention: </a:t>
+            </a:r>
+            <a:r>
+              <a:rPr sz="2000" b="0" i="0">
+                <a:solidFill>
+                  <a:srgbClr val="555960"/>
+                </a:solidFill>
+              </a:rPr>
+              <a:t>change the individual.</a:t>
             </a:r>
           </a:p>
         </p:txBody>
@@ -10069,7 +10206,143 @@
                   <a:srgbClr val="5C4826"/>
                 </a:solidFill>
               </a:rPr>
-              <a:t>Now defenses and their holes matter.</a:t>
+              <a:t>Now the condition of the defenses matters.</a:t>
+            </a:r>
+          </a:p>
+        </p:txBody>
+      </p:sp>
+      <p:sp>
+        <p:nvSpPr>
+          <p:cNvPr id="930" name="Label"/>
+          <p:cNvSpPr txBox="1"/>
+          <p:nvPr/>
+        </p:nvSpPr>
+        <p:spPr>
+          <a:xfrm>
+            <a:off x="1234440" y="896112"/>
+            <a:ext cx="1463040" cy="320040"/>
+          </a:xfrm>
+          <a:prstGeom prst="rect">
+            <a:avLst/>
+          </a:prstGeom>
+          <a:noFill/>
+        </p:spPr>
+        <p:txBody>
+          <a:bodyPr wrap="square" anchor="t" lIns="27432" rIns="27432" tIns="22860" bIns="22860">
+            <a:spAutoFit/>
+          </a:bodyPr>
+          <a:lstStyle/>
+          <a:p>
+            <a:pPr algn="ctr"/>
+            <a:r>
+              <a:rPr sz="2000" b="1" i="0">
+                <a:solidFill>
+                  <a:srgbClr val="8E6F3E"/>
+                </a:solidFill>
+              </a:rPr>
+              <a:t>DEFENSE</a:t>
+            </a:r>
+          </a:p>
+        </p:txBody>
+      </p:sp>
+      <p:sp>
+        <p:nvSpPr>
+          <p:cNvPr id="931" name="Label"/>
+          <p:cNvSpPr txBox="1"/>
+          <p:nvPr/>
+        </p:nvSpPr>
+        <p:spPr>
+          <a:xfrm>
+            <a:off x="2880360" y="896112"/>
+            <a:ext cx="1463040" cy="320040"/>
+          </a:xfrm>
+          <a:prstGeom prst="rect">
+            <a:avLst/>
+          </a:prstGeom>
+          <a:noFill/>
+        </p:spPr>
+        <p:txBody>
+          <a:bodyPr wrap="square" anchor="t" lIns="27432" rIns="27432" tIns="22860" bIns="22860">
+            <a:spAutoFit/>
+          </a:bodyPr>
+          <a:lstStyle/>
+          <a:p>
+            <a:pPr algn="ctr"/>
+            <a:r>
+              <a:rPr sz="2000" b="1" i="0">
+                <a:solidFill>
+                  <a:srgbClr val="8E6F3E"/>
+                </a:solidFill>
+              </a:rPr>
+              <a:t>DEFENSE</a:t>
+            </a:r>
+          </a:p>
+        </p:txBody>
+      </p:sp>
+      <p:sp>
+        <p:nvSpPr>
+          <p:cNvPr id="932" name="Label"/>
+          <p:cNvSpPr txBox="1"/>
+          <p:nvPr/>
+        </p:nvSpPr>
+        <p:spPr>
+          <a:xfrm>
+            <a:off x="4526280" y="896112"/>
+            <a:ext cx="1463040" cy="320040"/>
+          </a:xfrm>
+          <a:prstGeom prst="rect">
+            <a:avLst/>
+          </a:prstGeom>
+          <a:noFill/>
+        </p:spPr>
+        <p:txBody>
+          <a:bodyPr wrap="square" anchor="t" lIns="27432" rIns="27432" tIns="22860" bIns="22860">
+            <a:spAutoFit/>
+          </a:bodyPr>
+          <a:lstStyle/>
+          <a:p>
+            <a:pPr algn="ctr"/>
+            <a:r>
+              <a:rPr sz="2000" b="1" i="0">
+                <a:solidFill>
+                  <a:srgbClr val="8E6F3E"/>
+                </a:solidFill>
+              </a:rPr>
+              <a:t>DEFENSE</a:t>
+            </a:r>
+          </a:p>
+        </p:txBody>
+      </p:sp>
+      <p:sp>
+        <p:nvSpPr>
+          <p:cNvPr id="933" name="Label"/>
+          <p:cNvSpPr txBox="1"/>
+          <p:nvPr/>
+        </p:nvSpPr>
+        <p:spPr>
+          <a:xfrm>
+            <a:off x="6172200" y="896112"/>
+            <a:ext cx="1463040" cy="320040"/>
+          </a:xfrm>
+          <a:prstGeom prst="rect">
+            <a:avLst/>
+          </a:prstGeom>
+          <a:noFill/>
+        </p:spPr>
+        <p:txBody>
+          <a:bodyPr wrap="square" anchor="t" lIns="27432" rIns="27432" tIns="22860" bIns="22860">
+            <a:spAutoFit/>
+          </a:bodyPr>
+          <a:lstStyle/>
+          <a:p>
+            <a:pPr algn="ctr"/>
+            <a:r>
+              <a:rPr sz="2000" b="1" i="0">
+                <a:solidFill>
+                  <a:srgbClr val="8E6F3E"/>
+                </a:solidFill>
+              </a:rPr>
+              <a:t>DEFENSE</a:t>
             </a:r>
           </a:p>
         </p:txBody>
@@ -10381,7 +10654,7 @@
         </p:nvSpPr>
         <p:spPr>
           <a:xfrm>
-            <a:off x="548640" y="3840480"/>
+            <a:off x="548640" y="4160520"/>
             <a:ext cx="8046720" cy="457200"/>
           </a:xfrm>
           <a:prstGeom prst="rect">
@@ -10402,7 +10675,41 @@
                   <a:srgbClr val="5C4826"/>
                 </a:solidFill>
               </a:rPr>
-              <a:t>Now conditions shaping behavior matter.</a:t>
+              <a:t>Now the conditions shaping behavior matter.</a:t>
+            </a:r>
+          </a:p>
+        </p:txBody>
+      </p:sp>
+      <p:sp>
+        <p:nvSpPr>
+          <p:cNvPr id="920" name="Label"/>
+          <p:cNvSpPr txBox="1"/>
+          <p:nvPr/>
+        </p:nvSpPr>
+        <p:spPr>
+          <a:xfrm>
+            <a:off x="274320" y="3200400"/>
+            <a:ext cx="3017520" cy="365760"/>
+          </a:xfrm>
+          <a:prstGeom prst="rect">
+            <a:avLst/>
+          </a:prstGeom>
+          <a:noFill/>
+        </p:spPr>
+        <p:txBody>
+          <a:bodyPr wrap="square" anchor="t" lIns="27432" rIns="27432" tIns="22860" bIns="22860">
+            <a:spAutoFit/>
+          </a:bodyPr>
+          <a:lstStyle/>
+          <a:p>
+            <a:pPr algn="ctr"/>
+            <a:r>
+              <a:rPr sz="2000" b="0" i="0">
+                <a:solidFill>
+                  <a:srgbClr val="555960"/>
+                </a:solidFill>
+              </a:rPr>
+              <a:t>authority · incentives · schedule · ownership</a:t>
             </a:r>
           </a:p>
         </p:txBody>
@@ -10446,7 +10753,7 @@
                   <a:srgbClr val="000000"/>
                 </a:solidFill>
               </a:rPr>
-              <a:t>STAMP: Fine, include everything</a:t>
+              <a:t>STAMP: Model the control structure</a:t>
             </a:r>
           </a:p>
         </p:txBody>
@@ -10995,7 +11302,7 @@
                   <a:srgbClr val="5C4826"/>
                 </a:solidFill>
               </a:rPr>
-              <a:t>Model the entire control structure — every level, every loop.</a:t>
+              <a:t>Now control and feedback across the system matter.</a:t>
             </a:r>
           </a:p>
         </p:txBody>
@@ -11039,7 +11346,7 @@
                   <a:srgbClr val="000000"/>
                 </a:solidFill>
               </a:rPr>
-              <a:t>More complete can become less actionable</a:t>
+              <a:t>A broader model is not automatically a better model</a:t>
             </a:r>
           </a:p>
         </p:txBody>
@@ -11291,7 +11598,7 @@
         </p:nvCxnSpPr>
         <p:spPr>
           <a:xfrm>
-            <a:off x="548640" y="3383280"/>
+            <a:off x="548640" y="4114800"/>
             <a:ext cx="8001000" cy="0"/>
           </a:xfrm>
           <a:prstGeom prst="line">
@@ -11321,14 +11628,14 @@
       </p:cxnSp>
       <p:sp>
         <p:nvSpPr>
-          <p:cNvPr id="906" name="Label"/>
+          <p:cNvPr id="920" name="Label"/>
           <p:cNvSpPr txBox="1"/>
           <p:nvPr/>
         </p:nvSpPr>
         <p:spPr>
           <a:xfrm>
-            <a:off x="548640" y="3520440"/>
-            <a:ext cx="8046720" cy="411480"/>
+            <a:off x="457200" y="2971800"/>
+            <a:ext cx="2011680" cy="548640"/>
           </a:xfrm>
           <a:prstGeom prst="rect">
             <a:avLst/>
@@ -11343,12 +11650,261 @@
           <a:p>
             <a:pPr algn="ctr"/>
             <a:r>
+              <a:rPr sz="2000" b="0" i="0">
+                <a:solidFill>
+                  <a:srgbClr val="555960"/>
+                </a:solidFill>
+              </a:rPr>
+              <a:t>the individual act</a:t>
+            </a:r>
+          </a:p>
+        </p:txBody>
+      </p:sp>
+      <p:sp>
+        <p:nvSpPr>
+          <p:cNvPr id="921" name="Label"/>
+          <p:cNvSpPr txBox="1"/>
+          <p:nvPr/>
+        </p:nvSpPr>
+        <p:spPr>
+          <a:xfrm>
+            <a:off x="2532888" y="2971800"/>
+            <a:ext cx="2011680" cy="548640"/>
+          </a:xfrm>
+          <a:prstGeom prst="rect">
+            <a:avLst/>
+          </a:prstGeom>
+          <a:noFill/>
+        </p:spPr>
+        <p:txBody>
+          <a:bodyPr wrap="square" anchor="t" lIns="27432" rIns="27432" tIns="22860" bIns="22860">
+            <a:spAutoFit/>
+          </a:bodyPr>
+          <a:lstStyle/>
+          <a:p>
+            <a:pPr algn="ctr"/>
+            <a:r>
+              <a:rPr sz="2000" b="0" i="0">
+                <a:solidFill>
+                  <a:srgbClr val="555960"/>
+                </a:solidFill>
+              </a:rPr>
+              <a:t>the state of the defenses</a:t>
+            </a:r>
+          </a:p>
+        </p:txBody>
+      </p:sp>
+      <p:sp>
+        <p:nvSpPr>
+          <p:cNvPr id="922" name="Label"/>
+          <p:cNvSpPr txBox="1"/>
+          <p:nvPr/>
+        </p:nvSpPr>
+        <p:spPr>
+          <a:xfrm>
+            <a:off x="4608576" y="2971800"/>
+            <a:ext cx="2011680" cy="548640"/>
+          </a:xfrm>
+          <a:prstGeom prst="rect">
+            <a:avLst/>
+          </a:prstGeom>
+          <a:noFill/>
+        </p:spPr>
+        <p:txBody>
+          <a:bodyPr wrap="square" anchor="t" lIns="27432" rIns="27432" tIns="22860" bIns="22860">
+            <a:spAutoFit/>
+          </a:bodyPr>
+          <a:lstStyle/>
+          <a:p>
+            <a:pPr algn="ctr"/>
+            <a:r>
+              <a:rPr sz="2000" b="0" i="0">
+                <a:solidFill>
+                  <a:srgbClr val="555960"/>
+                </a:solidFill>
+              </a:rPr>
+              <a:t>the shaping conditions</a:t>
+            </a:r>
+          </a:p>
+        </p:txBody>
+      </p:sp>
+      <p:sp>
+        <p:nvSpPr>
+          <p:cNvPr id="923" name="Label"/>
+          <p:cNvSpPr txBox="1"/>
+          <p:nvPr/>
+        </p:nvSpPr>
+        <p:spPr>
+          <a:xfrm>
+            <a:off x="6684264" y="2971800"/>
+            <a:ext cx="2011680" cy="548640"/>
+          </a:xfrm>
+          <a:prstGeom prst="rect">
+            <a:avLst/>
+          </a:prstGeom>
+          <a:noFill/>
+        </p:spPr>
+        <p:txBody>
+          <a:bodyPr wrap="square" anchor="t" lIns="27432" rIns="27432" tIns="22860" bIns="22860">
+            <a:spAutoFit/>
+          </a:bodyPr>
+          <a:lstStyle/>
+          <a:p>
+            <a:pPr algn="ctr"/>
+            <a:r>
+              <a:rPr sz="2000" b="0" i="0">
+                <a:solidFill>
+                  <a:srgbClr val="555960"/>
+                </a:solidFill>
+              </a:rPr>
+              <a:t>control and feedback loops</a:t>
+            </a:r>
+          </a:p>
+        </p:txBody>
+      </p:sp>
+      <p:sp>
+        <p:nvSpPr>
+          <p:cNvPr id="924" name="Label"/>
+          <p:cNvSpPr txBox="1"/>
+          <p:nvPr/>
+        </p:nvSpPr>
+        <p:spPr>
+          <a:xfrm>
+            <a:off x="548640" y="3749040"/>
+            <a:ext cx="3474720" cy="320040"/>
+          </a:xfrm>
+          <a:prstGeom prst="rect">
+            <a:avLst/>
+          </a:prstGeom>
+          <a:noFill/>
+        </p:spPr>
+        <p:txBody>
+          <a:bodyPr wrap="square" anchor="t" lIns="27432" rIns="27432" tIns="22860" bIns="22860">
+            <a:spAutoFit/>
+          </a:bodyPr>
+          <a:lstStyle/>
+          <a:p>
+            <a:pPr algn="l"/>
+            <a:r>
+              <a:rPr sz="2000" b="0" i="0">
+                <a:solidFill>
+                  <a:srgbClr val="555960"/>
+                </a:solidFill>
+              </a:rPr>
+              <a:t>NARROWER CAUSAL BOUNDARY</a:t>
+            </a:r>
+          </a:p>
+        </p:txBody>
+      </p:sp>
+      <p:sp>
+        <p:nvSpPr>
+          <p:cNvPr id="925" name="Label"/>
+          <p:cNvSpPr txBox="1"/>
+          <p:nvPr/>
+        </p:nvSpPr>
+        <p:spPr>
+          <a:xfrm>
+            <a:off x="6949440" y="3749040"/>
+            <a:ext cx="1600200" cy="320040"/>
+          </a:xfrm>
+          <a:prstGeom prst="rect">
+            <a:avLst/>
+          </a:prstGeom>
+          <a:noFill/>
+        </p:spPr>
+        <p:txBody>
+          <a:bodyPr wrap="square" anchor="t" lIns="27432" rIns="27432" tIns="22860" bIns="22860">
+            <a:spAutoFit/>
+          </a:bodyPr>
+          <a:lstStyle/>
+          <a:p>
+            <a:pPr algn="r"/>
+            <a:r>
+              <a:rPr sz="2000" b="0" i="0">
+                <a:solidFill>
+                  <a:srgbClr val="555960"/>
+                </a:solidFill>
+              </a:rPr>
+              <a:t>BROADER</a:t>
+            </a:r>
+          </a:p>
+        </p:txBody>
+      </p:sp>
+      <p:sp>
+        <p:nvSpPr>
+          <p:cNvPr id="926" name="Label"/>
+          <p:cNvSpPr txBox="1"/>
+          <p:nvPr/>
+        </p:nvSpPr>
+        <p:spPr>
+          <a:xfrm>
+            <a:off x="548640" y="4315968"/>
+            <a:ext cx="8046720" cy="365760"/>
+          </a:xfrm>
+          <a:prstGeom prst="rect">
+            <a:avLst/>
+          </a:prstGeom>
+          <a:noFill/>
+        </p:spPr>
+        <p:txBody>
+          <a:bodyPr wrap="square" anchor="t" lIns="27432" rIns="27432" tIns="22860" bIns="22860">
+            <a:spAutoFit/>
+          </a:bodyPr>
+          <a:lstStyle/>
+          <a:p>
+            <a:pPr algn="ctr"/>
+            <a:r>
               <a:rPr sz="2000" b="1" i="0">
                 <a:solidFill>
                   <a:srgbClr val="8E6F3E"/>
                 </a:solidFill>
               </a:rPr>
-              <a:t>more complete →</a:t>
+              <a:t>more structure represented</a:t>
+            </a:r>
+          </a:p>
+        </p:txBody>
+      </p:sp>
+      <p:sp>
+        <p:nvSpPr>
+          <p:cNvPr id="927" name="Label"/>
+          <p:cNvSpPr txBox="1"/>
+          <p:nvPr/>
+        </p:nvSpPr>
+        <p:spPr>
+          <a:xfrm>
+            <a:off x="822960" y="4892040"/>
+            <a:ext cx="7498080" cy="822960"/>
+          </a:xfrm>
+          <a:prstGeom prst="rect">
+            <a:avLst/>
+          </a:prstGeom>
+          <a:noFill/>
+        </p:spPr>
+        <p:txBody>
+          <a:bodyPr wrap="square" anchor="t" lIns="27432" rIns="27432" tIns="22860" bIns="22860">
+            <a:spAutoFit/>
+          </a:bodyPr>
+          <a:lstStyle/>
+          <a:p>
+            <a:pPr algn="ctr"/>
+            <a:r>
+              <a:rPr sz="2000" b="0" i="0">
+                <a:solidFill>
+                  <a:srgbClr val="5C4826"/>
+                </a:solidFill>
+              </a:rPr>
+              <a:t>Broader models expose more relationships.</a:t>
+            </a:r>
+          </a:p>
+          <a:p>
+            <a:pPr algn="ctr"/>
+            <a:r>
+              <a:rPr sz="2000" b="0" i="0">
+                <a:solidFill>
+                  <a:srgbClr val="5C4826"/>
+                </a:solidFill>
+              </a:rPr>
+              <a:t>They also demand more evidence and more authority to act.</a:t>
             </a:r>
           </a:p>
         </p:txBody>
@@ -11392,7 +11948,7 @@
                   <a:srgbClr val="000000"/>
                 </a:solidFill>
               </a:rPr>
-              <a:t>Match the causal model to the locus of control</a:t>
+              <a:t>Match causal breadth to the decision</a:t>
             </a:r>
           </a:p>
         </p:txBody>
@@ -11723,7 +12279,7 @@
                   <a:srgbClr val="FFFFFF"/>
                 </a:solidFill>
               </a:rPr>
-              <a:t>Choose the model whose levers you actually hold.</a:t>
+              <a:t>Model far enough to reach the decisions that can change the outcome.</a:t>
             </a:r>
           </a:p>
         </p:txBody>

</xml_diff>

<commit_message>
deck 2-4 section 3: stay on the Instagram case long enough to pay off the switch
The knowledge chain becomes OBSERVATION -> EVIDENCE -> INTERPRETATION -> LESSON
(calling the observation 'failure' would beg the case's question), with the
what-happened / what-does-it-support / what-should-change beats under the
arrows and 'Evidence does not choose its own interpretation.' as the line.
Evidence-support slide closes on 'Generalization is itself an engineering
claim.'; preserve-example/lesson cards updated; case-carrying notes added to
the reflective-account and lesson-destination slides. Section 4's VW callback
question becomes 'Given everything we've learned, which judgments should never
have remained discretionary?'
</commit_message>
<xml_diff>
--- a/course/lectures/act-2-delegation-and-control/04-failure-aware-engineering/2-4-Failure-Aware-Engineering.pptx
+++ b/course/lectures/act-2-delegation-and-control/04-failure-aware-engineering/2-4-Failure-Aware-Engineering.pptx
@@ -2034,12 +2034,12 @@
           </a:p>
           <a:p>
             <a:r>
-              <a:t>- Straight out of Engineering Knowledge (Act I): an observation becomes knowledge only through analysis.</a:t>
-            </a:r>
-          </a:p>
-          <a:p>
-            <a:r>
-              <a:t>- The 2012 hardware-failure slide is the counter-example to hold up: evidence was produced, analysis happened, and the lesson served the wrong obligation.</a:t>
+              <a:t>- The chain is OBSERVATION -&gt; EVIDENCE -&gt; INTERPRETATION -&gt; LESSON. Calling the observation itself "failure" would beg the question students are meant to reason about in the Instagram case: whether and where an engineering failure occurred.</a:t>
+            </a:r>
+          </a:p>
+          <a:p>
+            <a:r>
+              <a:t>- Straight out of Engineering Knowledge (Act I): an observation becomes knowledge only through analysis. The 2012 Volkswagen hardware-failure slide is the counter-example to hold up: evidence was produced, interpretation happened, and the lesson served the wrong obligation.</a:t>
             </a:r>
           </a:p>
         </p:txBody>
@@ -2114,7 +2114,12 @@
           </a:p>
           <a:p>
             <a:r>
-              <a:t>- One failure licenses several candidate lessons of increasing breadth; the evidence supports only some of them.</a:t>
+              <a:t>- Support thins as the claim broadens: narrow / broader / sweeping.</a:t>
+            </a:r>
+          </a:p>
+          <a:p>
+            <a:r>
+              <a:t>- THE CASE (carry verbally): an observation that some users report a harmful experience does not by itself establish that Instagram causes that outcome for all teenage users, nor that a particular feature causes it, nor that a proposed intervention will improve it. Each wider claim needs more evidence than the observation provides.</a:t>
             </a:r>
           </a:p>
           <a:p>
@@ -2194,12 +2199,12 @@
           </a:p>
           <a:p>
             <a:r>
-              <a:t>- Regression test vs generalized lesson: both are legitimate; they preserve different things.</a:t>
-            </a:r>
-          </a:p>
-          <a:p>
-            <a:r>
-              <a:t>- ASK what each one catches next time, and what each one misses.</a:t>
+              <a:t>- Regression test vs generalized model or control: both legitimate; they preserve different things. ASK what each catches next time, and what each misses.</a:t>
+            </a:r>
+          </a:p>
+          <a:p>
+            <a:r>
+              <a:t>- For a socio-technical outcome like the Instagram case, "regression test" is metaphorically less direct - and that is itself interesting: some lessons cannot be encoded as an ordinary software test. Sets up SYSTEM / TEAM / ENGINEER.</a:t>
             </a:r>
           </a:p>
         </p:txBody>
@@ -2279,6 +2284,11 @@
           </a:p>
           <a:p>
             <a:r>
+              <a:t>- The reflective account is exactly what prevents "Facebook had research, therefore Facebook knew X" from collapsing evidence, interpretation, and organizational decision into one thing.</a:t>
+            </a:r>
+          </a:p>
+          <a:p>
+            <a:r>
               <a:t>- Postmortems that stop at the causal account leave the second kind of learning on the table.</a:t>
             </a:r>
           </a:p>
@@ -2439,12 +2449,12 @@
           </a:p>
           <a:p>
             <a:r>
-              <a:t>- From Engineering Knowledge: consequential knowledge can migrate into requirements, specifications, architecture, mechanisms/models, validation, or continuing checks/controls when future work should inherit the lesson.</a:t>
-            </a:r>
-          </a:p>
-          <a:p>
-            <a:r>
-              <a:t>- ASK for one lesson from the course project and where it should live.</a:t>
+              <a:t>- From Engineering Knowledge: consequential knowledge migrates into requirements, specifications, architecture, models, validation, or controls when future work should inherit the lesson.</a:t>
+            </a:r>
+          </a:p>
+          <a:p>
+            <a:r>
+              <a:t>- ASK students to nominate one plausible lesson from the Instagram case and say where it should live. Different interpretations of the evidence produce different answers - which is the point.</a:t>
             </a:r>
           </a:p>
         </p:txBody>
@@ -2754,12 +2764,12 @@
           </a:p>
           <a:p>
             <a:r>
-              <a:t>- A much better final Volkswagen discussion than "who was unethical?"</a:t>
-            </a:r>
-          </a:p>
-          <a:p>
-            <a:r>
-              <a:t>- The footer question is the discussion; give it time.</a:t>
+              <a:t>- The callback: Volkswagen has been absent for roughly ten slides; returning to it here is the payoff. A much better final discussion than "who was unethical?"</a:t>
+            </a:r>
+          </a:p>
+          <a:p>
+            <a:r>
+              <a:t>- The footer question is the discussion; give it time. "Everything we've learned" now includes causal breadth, diagnosis across decisions, what evidence supports, and where lessons live.</a:t>
             </a:r>
           </a:p>
         </p:txBody>
@@ -16725,14 +16735,48 @@
       </p:sp>
       <p:sp>
         <p:nvSpPr>
-          <p:cNvPr id="901" name="Block"/>
+          <p:cNvPr id="908" name="Label"/>
+          <p:cNvSpPr txBox="1"/>
+          <p:nvPr/>
+        </p:nvSpPr>
+        <p:spPr>
+          <a:xfrm>
+            <a:off x="548640" y="4297680"/>
+            <a:ext cx="8046720" cy="548640"/>
+          </a:xfrm>
+          <a:prstGeom prst="rect">
+            <a:avLst/>
+          </a:prstGeom>
+          <a:noFill/>
+        </p:spPr>
+        <p:txBody>
+          <a:bodyPr wrap="square" anchor="t" lIns="27432" rIns="27432" tIns="22860" bIns="22860">
+            <a:spAutoFit/>
+          </a:bodyPr>
+          <a:lstStyle/>
+          <a:p>
+            <a:pPr algn="ctr"/>
+            <a:r>
+              <a:rPr sz="2200" b="0" i="0">
+                <a:solidFill>
+                  <a:srgbClr val="5C4826"/>
+                </a:solidFill>
+              </a:rPr>
+              <a:t>Evidence does not choose its own interpretation.</a:t>
+            </a:r>
+          </a:p>
+        </p:txBody>
+      </p:sp>
+      <p:sp>
+        <p:nvSpPr>
+          <p:cNvPr id="920" name="Block"/>
           <p:cNvSpPr/>
           <p:nvPr/>
         </p:nvSpPr>
         <p:spPr>
           <a:xfrm>
-            <a:off x="548640" y="2468880"/>
-            <a:ext cx="1783080" cy="640080"/>
+            <a:off x="411480" y="2468880"/>
+            <a:ext cx="1874520" cy="640080"/>
           </a:xfrm>
           <a:prstGeom prst="rect">
             <a:avLst/>
@@ -16770,21 +16814,177 @@
                   <a:srgbClr val="FFFFFF"/>
                 </a:solidFill>
               </a:rPr>
-              <a:t>FAILURE</a:t>
+              <a:t>OBSERVATION</a:t>
+            </a:r>
+          </a:p>
+        </p:txBody>
+      </p:sp>
+      <p:sp>
+        <p:nvSpPr>
+          <p:cNvPr id="921" name="Block"/>
+          <p:cNvSpPr/>
+          <p:nvPr/>
+        </p:nvSpPr>
+        <p:spPr>
+          <a:xfrm>
+            <a:off x="2697480" y="2468880"/>
+            <a:ext cx="1554480" cy="640080"/>
+          </a:xfrm>
+          <a:prstGeom prst="rect">
+            <a:avLst/>
+          </a:prstGeom>
+          <a:solidFill>
+            <a:srgbClr val="8E6F3E"/>
+          </a:solidFill>
+          <a:ln>
+            <a:noFill/>
+          </a:ln>
+          <a:effectLst/>
+        </p:spPr>
+        <p:style>
+          <a:lnRef idx="1">
+            <a:schemeClr val="accent1"/>
+          </a:lnRef>
+          <a:fillRef idx="3">
+            <a:schemeClr val="accent1"/>
+          </a:fillRef>
+          <a:effectRef idx="2">
+            <a:schemeClr val="accent1"/>
+          </a:effectRef>
+          <a:fontRef idx="minor">
+            <a:schemeClr val="lt1"/>
+          </a:fontRef>
+        </p:style>
+        <p:txBody>
+          <a:bodyPr rtlCol="0" anchor="ctr" wrap="square" lIns="27432" rIns="27432" tIns="22860" bIns="22860"/>
+          <a:lstStyle/>
+          <a:p>
+            <a:pPr algn="ctr"/>
+            <a:r>
+              <a:rPr sz="2000" b="1" i="0">
+                <a:solidFill>
+                  <a:srgbClr val="FFFFFF"/>
+                </a:solidFill>
+              </a:rPr>
+              <a:t>EVIDENCE</a:t>
+            </a:r>
+          </a:p>
+        </p:txBody>
+      </p:sp>
+      <p:sp>
+        <p:nvSpPr>
+          <p:cNvPr id="922" name="Block"/>
+          <p:cNvSpPr/>
+          <p:nvPr/>
+        </p:nvSpPr>
+        <p:spPr>
+          <a:xfrm>
+            <a:off x="4663440" y="2468880"/>
+            <a:ext cx="2148840" cy="640080"/>
+          </a:xfrm>
+          <a:prstGeom prst="rect">
+            <a:avLst/>
+          </a:prstGeom>
+          <a:solidFill>
+            <a:srgbClr val="8E6F3E"/>
+          </a:solidFill>
+          <a:ln>
+            <a:noFill/>
+          </a:ln>
+          <a:effectLst/>
+        </p:spPr>
+        <p:style>
+          <a:lnRef idx="1">
+            <a:schemeClr val="accent1"/>
+          </a:lnRef>
+          <a:fillRef idx="3">
+            <a:schemeClr val="accent1"/>
+          </a:fillRef>
+          <a:effectRef idx="2">
+            <a:schemeClr val="accent1"/>
+          </a:effectRef>
+          <a:fontRef idx="minor">
+            <a:schemeClr val="lt1"/>
+          </a:fontRef>
+        </p:style>
+        <p:txBody>
+          <a:bodyPr rtlCol="0" anchor="ctr" wrap="square" lIns="27432" rIns="27432" tIns="22860" bIns="22860"/>
+          <a:lstStyle/>
+          <a:p>
+            <a:pPr algn="ctr"/>
+            <a:r>
+              <a:rPr sz="2000" b="1" i="0">
+                <a:solidFill>
+                  <a:srgbClr val="FFFFFF"/>
+                </a:solidFill>
+              </a:rPr>
+              <a:t>INTERPRETATION</a:t>
+            </a:r>
+          </a:p>
+        </p:txBody>
+      </p:sp>
+      <p:sp>
+        <p:nvSpPr>
+          <p:cNvPr id="923" name="Block"/>
+          <p:cNvSpPr/>
+          <p:nvPr/>
+        </p:nvSpPr>
+        <p:spPr>
+          <a:xfrm>
+            <a:off x="7223760" y="2468880"/>
+            <a:ext cx="1325880" cy="640080"/>
+          </a:xfrm>
+          <a:prstGeom prst="rect">
+            <a:avLst/>
+          </a:prstGeom>
+          <a:solidFill>
+            <a:srgbClr val="8E6F3E"/>
+          </a:solidFill>
+          <a:ln>
+            <a:noFill/>
+          </a:ln>
+          <a:effectLst/>
+        </p:spPr>
+        <p:style>
+          <a:lnRef idx="1">
+            <a:schemeClr val="accent1"/>
+          </a:lnRef>
+          <a:fillRef idx="3">
+            <a:schemeClr val="accent1"/>
+          </a:fillRef>
+          <a:effectRef idx="2">
+            <a:schemeClr val="accent1"/>
+          </a:effectRef>
+          <a:fontRef idx="minor">
+            <a:schemeClr val="lt1"/>
+          </a:fontRef>
+        </p:style>
+        <p:txBody>
+          <a:bodyPr rtlCol="0" anchor="ctr" wrap="square" lIns="27432" rIns="27432" tIns="22860" bIns="22860"/>
+          <a:lstStyle/>
+          <a:p>
+            <a:pPr algn="ctr"/>
+            <a:r>
+              <a:rPr sz="2000" b="1" i="0">
+                <a:solidFill>
+                  <a:srgbClr val="FFFFFF"/>
+                </a:solidFill>
+              </a:rPr>
+              <a:t>LESSON</a:t>
             </a:r>
           </a:p>
         </p:txBody>
       </p:sp>
       <p:cxnSp>
         <p:nvCxnSpPr>
-          <p:cNvPr id="902" name="Connector 901"/>
+          <p:cNvPr id="924" name="Connector 924"/>
           <p:cNvCxnSpPr/>
           <p:nvPr/>
         </p:nvCxnSpPr>
         <p:spPr>
           <a:xfrm>
-            <a:off x="2331720" y="2788920"/>
-            <a:ext cx="320040" cy="0"/>
+            <a:off x="2286000" y="2788920"/>
+            <a:ext cx="411480" cy="0"/>
           </a:xfrm>
           <a:prstGeom prst="line">
             <a:avLst/>
@@ -16811,68 +17011,16 @@
           </a:fontRef>
         </p:style>
       </p:cxnSp>
-      <p:sp>
-        <p:nvSpPr>
-          <p:cNvPr id="903" name="Block"/>
-          <p:cNvSpPr/>
-          <p:nvPr/>
-        </p:nvSpPr>
-        <p:spPr>
-          <a:xfrm>
-            <a:off x="2651760" y="2468880"/>
-            <a:ext cx="1783080" cy="640080"/>
-          </a:xfrm>
-          <a:prstGeom prst="rect">
-            <a:avLst/>
-          </a:prstGeom>
-          <a:solidFill>
-            <a:srgbClr val="8E6F3E"/>
-          </a:solidFill>
-          <a:ln>
-            <a:noFill/>
-          </a:ln>
-          <a:effectLst/>
-        </p:spPr>
-        <p:style>
-          <a:lnRef idx="1">
-            <a:schemeClr val="accent1"/>
-          </a:lnRef>
-          <a:fillRef idx="3">
-            <a:schemeClr val="accent1"/>
-          </a:fillRef>
-          <a:effectRef idx="2">
-            <a:schemeClr val="accent1"/>
-          </a:effectRef>
-          <a:fontRef idx="minor">
-            <a:schemeClr val="lt1"/>
-          </a:fontRef>
-        </p:style>
-        <p:txBody>
-          <a:bodyPr rtlCol="0" anchor="ctr" wrap="square" lIns="27432" rIns="27432" tIns="22860" bIns="22860"/>
-          <a:lstStyle/>
-          <a:p>
-            <a:pPr algn="ctr"/>
-            <a:r>
-              <a:rPr sz="2000" b="1" i="0">
-                <a:solidFill>
-                  <a:srgbClr val="FFFFFF"/>
-                </a:solidFill>
-              </a:rPr>
-              <a:t>EVIDENCE</a:t>
-            </a:r>
-          </a:p>
-        </p:txBody>
-      </p:sp>
       <p:cxnSp>
         <p:nvCxnSpPr>
-          <p:cNvPr id="904" name="Connector 903"/>
+          <p:cNvPr id="925" name="Connector 925"/>
           <p:cNvCxnSpPr/>
           <p:nvPr/>
         </p:nvCxnSpPr>
         <p:spPr>
           <a:xfrm>
-            <a:off x="4434840" y="2788920"/>
-            <a:ext cx="320039" cy="0"/>
+            <a:off x="4251960" y="2788920"/>
+            <a:ext cx="411480" cy="0"/>
           </a:xfrm>
           <a:prstGeom prst="line">
             <a:avLst/>
@@ -16899,68 +17047,16 @@
           </a:fontRef>
         </p:style>
       </p:cxnSp>
-      <p:sp>
-        <p:nvSpPr>
-          <p:cNvPr id="905" name="Block"/>
-          <p:cNvSpPr/>
-          <p:nvPr/>
-        </p:nvSpPr>
-        <p:spPr>
-          <a:xfrm>
-            <a:off x="4754879" y="2468880"/>
-            <a:ext cx="1783080" cy="640080"/>
-          </a:xfrm>
-          <a:prstGeom prst="rect">
-            <a:avLst/>
-          </a:prstGeom>
-          <a:solidFill>
-            <a:srgbClr val="8E6F3E"/>
-          </a:solidFill>
-          <a:ln>
-            <a:noFill/>
-          </a:ln>
-          <a:effectLst/>
-        </p:spPr>
-        <p:style>
-          <a:lnRef idx="1">
-            <a:schemeClr val="accent1"/>
-          </a:lnRef>
-          <a:fillRef idx="3">
-            <a:schemeClr val="accent1"/>
-          </a:fillRef>
-          <a:effectRef idx="2">
-            <a:schemeClr val="accent1"/>
-          </a:effectRef>
-          <a:fontRef idx="minor">
-            <a:schemeClr val="lt1"/>
-          </a:fontRef>
-        </p:style>
-        <p:txBody>
-          <a:bodyPr rtlCol="0" anchor="ctr" wrap="square" lIns="27432" rIns="27432" tIns="22860" bIns="22860"/>
-          <a:lstStyle/>
-          <a:p>
-            <a:pPr algn="ctr"/>
-            <a:r>
-              <a:rPr sz="2000" b="1" i="0">
-                <a:solidFill>
-                  <a:srgbClr val="FFFFFF"/>
-                </a:solidFill>
-              </a:rPr>
-              <a:t>ANALYSIS</a:t>
-            </a:r>
-          </a:p>
-        </p:txBody>
-      </p:sp>
       <p:cxnSp>
         <p:nvCxnSpPr>
-          <p:cNvPr id="906" name="Connector 905"/>
+          <p:cNvPr id="926" name="Connector 926"/>
           <p:cNvCxnSpPr/>
           <p:nvPr/>
         </p:nvCxnSpPr>
         <p:spPr>
           <a:xfrm>
-            <a:off x="6537959" y="2788920"/>
-            <a:ext cx="320040" cy="0"/>
+            <a:off x="6812280" y="2788920"/>
+            <a:ext cx="411480" cy="0"/>
           </a:xfrm>
           <a:prstGeom prst="line">
             <a:avLst/>
@@ -16989,66 +17085,14 @@
       </p:cxnSp>
       <p:sp>
         <p:nvSpPr>
-          <p:cNvPr id="907" name="Block"/>
-          <p:cNvSpPr/>
-          <p:nvPr/>
-        </p:nvSpPr>
-        <p:spPr>
-          <a:xfrm>
-            <a:off x="6857999" y="2468880"/>
-            <a:ext cx="1783080" cy="640080"/>
-          </a:xfrm>
-          <a:prstGeom prst="rect">
-            <a:avLst/>
-          </a:prstGeom>
-          <a:solidFill>
-            <a:srgbClr val="8E6F3E"/>
-          </a:solidFill>
-          <a:ln>
-            <a:noFill/>
-          </a:ln>
-          <a:effectLst/>
-        </p:spPr>
-        <p:style>
-          <a:lnRef idx="1">
-            <a:schemeClr val="accent1"/>
-          </a:lnRef>
-          <a:fillRef idx="3">
-            <a:schemeClr val="accent1"/>
-          </a:fillRef>
-          <a:effectRef idx="2">
-            <a:schemeClr val="accent1"/>
-          </a:effectRef>
-          <a:fontRef idx="minor">
-            <a:schemeClr val="lt1"/>
-          </a:fontRef>
-        </p:style>
-        <p:txBody>
-          <a:bodyPr rtlCol="0" anchor="ctr" wrap="square" lIns="27432" rIns="27432" tIns="22860" bIns="22860"/>
-          <a:lstStyle/>
-          <a:p>
-            <a:pPr algn="ctr"/>
-            <a:r>
-              <a:rPr sz="2000" b="1" i="0">
-                <a:solidFill>
-                  <a:srgbClr val="FFFFFF"/>
-                </a:solidFill>
-              </a:rPr>
-              <a:t>LESSON</a:t>
-            </a:r>
-          </a:p>
-        </p:txBody>
-      </p:sp>
-      <p:sp>
-        <p:nvSpPr>
-          <p:cNvPr id="908" name="Label"/>
+          <p:cNvPr id="927" name="Label"/>
           <p:cNvSpPr txBox="1"/>
           <p:nvPr/>
         </p:nvSpPr>
         <p:spPr>
           <a:xfrm>
-            <a:off x="548640" y="3657600"/>
-            <a:ext cx="8046720" cy="548640"/>
+            <a:off x="1600200" y="3246120"/>
+            <a:ext cx="1828800" cy="548640"/>
           </a:xfrm>
           <a:prstGeom prst="rect">
             <a:avLst/>
@@ -17063,12 +17107,80 @@
           <a:p>
             <a:pPr algn="ctr"/>
             <a:r>
-              <a:rPr sz="2200" b="0" i="0">
-                <a:solidFill>
-                  <a:srgbClr val="5C4826"/>
-                </a:solidFill>
-              </a:rPr>
-              <a:t>Failure produces evidence. Analyze it into a lesson.</a:t>
+              <a:rPr sz="2000" b="0" i="0">
+                <a:solidFill>
+                  <a:srgbClr val="555960"/>
+                </a:solidFill>
+              </a:rPr>
+              <a:t>what happened?</a:t>
+            </a:r>
+          </a:p>
+        </p:txBody>
+      </p:sp>
+      <p:sp>
+        <p:nvSpPr>
+          <p:cNvPr id="928" name="Label"/>
+          <p:cNvSpPr txBox="1"/>
+          <p:nvPr/>
+        </p:nvSpPr>
+        <p:spPr>
+          <a:xfrm>
+            <a:off x="3547872" y="3246120"/>
+            <a:ext cx="1828800" cy="548640"/>
+          </a:xfrm>
+          <a:prstGeom prst="rect">
+            <a:avLst/>
+          </a:prstGeom>
+          <a:noFill/>
+        </p:spPr>
+        <p:txBody>
+          <a:bodyPr wrap="square" anchor="t" lIns="27432" rIns="27432" tIns="22860" bIns="22860">
+            <a:spAutoFit/>
+          </a:bodyPr>
+          <a:lstStyle/>
+          <a:p>
+            <a:pPr algn="ctr"/>
+            <a:r>
+              <a:rPr sz="2000" b="0" i="0">
+                <a:solidFill>
+                  <a:srgbClr val="555960"/>
+                </a:solidFill>
+              </a:rPr>
+              <a:t>what does it support?</a:t>
+            </a:r>
+          </a:p>
+        </p:txBody>
+      </p:sp>
+      <p:sp>
+        <p:nvSpPr>
+          <p:cNvPr id="929" name="Label"/>
+          <p:cNvSpPr txBox="1"/>
+          <p:nvPr/>
+        </p:nvSpPr>
+        <p:spPr>
+          <a:xfrm>
+            <a:off x="6108192" y="3246120"/>
+            <a:ext cx="1828800" cy="548640"/>
+          </a:xfrm>
+          <a:prstGeom prst="rect">
+            <a:avLst/>
+          </a:prstGeom>
+          <a:noFill/>
+        </p:spPr>
+        <p:txBody>
+          <a:bodyPr wrap="square" anchor="t" lIns="27432" rIns="27432" tIns="22860" bIns="22860">
+            <a:spAutoFit/>
+          </a:bodyPr>
+          <a:lstStyle/>
+          <a:p>
+            <a:pPr algn="ctr"/>
+            <a:r>
+              <a:rPr sz="2000" b="0" i="0">
+                <a:solidFill>
+                  <a:srgbClr val="555960"/>
+                </a:solidFill>
+              </a:rPr>
+              <a:t>what should change?</a:t>
             </a:r>
           </a:p>
         </p:txBody>
@@ -17331,7 +17443,7 @@
                   <a:srgbClr val="5C4826"/>
                 </a:solidFill>
               </a:rPr>
-              <a:t>The same observation; support thins as the claim widens.</a:t>
+              <a:t>Generalization is itself an engineering claim.</a:t>
             </a:r>
           </a:p>
         </p:txBody>
@@ -17972,7 +18084,7 @@
           <a:p>
             <a:pPr algn="ctr">
               <a:spcBef>
-                <a:spcPts val="1400"/>
+                <a:spcPts val="1200"/>
               </a:spcBef>
             </a:pPr>
             <a:r>
@@ -17987,7 +18099,7 @@
           <a:p>
             <a:pPr algn="ctr">
               <a:spcBef>
-                <a:spcPts val="800"/>
+                <a:spcPts val="1200"/>
               </a:spcBef>
             </a:pPr>
             <a:r>
@@ -17996,7 +18108,7 @@
                   <a:srgbClr val="555960"/>
                 </a:solidFill>
               </a:rPr>
-              <a:t>pins this exact case so it can never silently recur</a:t>
+              <a:t>pins this exact case - it cannot silently recur</a:t>
             </a:r>
           </a:p>
         </p:txBody>
@@ -18056,7 +18168,7 @@
           <a:p>
             <a:pPr algn="ctr">
               <a:spcBef>
-                <a:spcPts val="1400"/>
+                <a:spcPts val="1200"/>
               </a:spcBef>
             </a:pPr>
             <a:r>
@@ -18065,13 +18177,13 @@
                   <a:srgbClr val="8E6F3E"/>
                 </a:solidFill>
               </a:rPr>
-              <a:t>Generalized lesson</a:t>
+              <a:t>Generalized model or control</a:t>
             </a:r>
           </a:p>
           <a:p>
             <a:pPr algn="ctr">
               <a:spcBef>
-                <a:spcPts val="800"/>
+                <a:spcPts val="1200"/>
               </a:spcBef>
             </a:pPr>
             <a:r>
@@ -18080,7 +18192,7 @@
                   <a:srgbClr val="555960"/>
                 </a:solidFill>
               </a:rPr>
-              <a:t>covers the class of cases the example revealed</a:t>
+              <a:t>covers the class of cases - the class becomes recognizable</a:t>
             </a:r>
           </a:p>
         </p:txBody>
@@ -20658,7 +20770,7 @@
                   <a:srgbClr val="FFFFFF"/>
                 </a:solidFill>
               </a:rPr>
-              <a:t>Which judgments should never have remained discretionary?</a:t>
+              <a:t>Given everything we’ve learned, which judgments should never have remained discretionary?</a:t>
             </a:r>
           </a:p>
         </p:txBody>

</xml_diff>

<commit_message>
deck 2-4 compression: merge objection + sustained-engineering slides (40 -> 39)
The brief's sanctioned saving #1: 'Engineers objected and escalated' and 'And
yet engineers kept engineering it' become one slide, 'Engineers objected - and
kept engineering it' (escalation fired; Nov 2006 'not to get caught'; not a
rogue patch; delegated to IAV; footer 'Was escalation enough?'). Slidenum
caches refreshed as the last content step; full-deck render verified; 20pt
floor and notes coverage audited across all 39 slides.
</commit_message>
<xml_diff>
--- a/course/lectures/act-2-delegation-and-control/04-failure-aware-engineering/2-4-Failure-Aware-Engineering.pptx
+++ b/course/lectures/act-2-delegation-and-control/04-failure-aware-engineering/2-4-Failure-Aware-Engineering.pptx
@@ -14,7 +14,6 @@
     <p:sldId id="294" r:id="rId45"/>
     <p:sldId id="259" r:id="rId10"/>
     <p:sldId id="260" r:id="rId11"/>
-    <p:sldId id="261" r:id="rId12"/>
     <p:sldId id="262" r:id="rId13"/>
     <p:sldId id="263" r:id="rId14"/>
     <p:sldId id="264" r:id="rId15"/>
@@ -3444,97 +3443,22 @@
           <a:lstStyle/>
           <a:p>
             <a:r>
-              <a:t>TIMING: 2 minutes</a:t>
-            </a:r>
-          </a:p>
-          <a:p>
-            <a:r>
-              <a:t>- The point: the ordinary speak-up control ACTUALLY FIRED. Objection was raised and escalated; the November 2006 decision was to continue, with the instruction recorded in substance as "not to get caught."</a:t>
-            </a:r>
-          </a:p>
-          <a:p>
-            <a:r>
-              <a:t>- Not an ethics seminar - the engineering question is what happened AFTER the human control fired.</a:t>
-            </a:r>
-          </a:p>
-        </p:txBody>
-      </p:sp>
-      <p:sp>
-        <p:nvSpPr>
-          <p:cNvPr id="4" name="Slide Number Placeholder 3"/>
-          <p:cNvSpPr>
-            <a:spLocks noGrp="1"/>
-          </p:cNvSpPr>
-          <p:nvPr>
-            <p:ph type="sldNum" idx="5" sz="quarter"/>
-          </p:nvPr>
-        </p:nvSpPr>
-        <p:spPr/>
-      </p:sp>
-    </p:spTree>
-  </p:cSld>
-  <p:clrMapOvr>
-    <a:masterClrMapping/>
-  </p:clrMapOvr>
-</p:notes>
-</file>
-
-<file path=ppt/notesSlides/notesSlide6.xml><?xml version="1.0" encoding="utf-8"?>
-<p:notes xmlns:a="http://schemas.openxmlformats.org/drawingml/2006/main" xmlns:p="http://schemas.openxmlformats.org/presentationml/2006/main" xmlns:r="http://schemas.openxmlformats.org/officeDocument/2006/relationships">
-  <p:cSld>
-    <p:spTree>
-      <p:nvGrpSpPr>
-        <p:cNvPr id="1" name=""/>
-        <p:cNvGrpSpPr/>
-        <p:nvPr/>
-      </p:nvGrpSpPr>
-      <p:grpSpPr>
-        <a:xfrm>
-          <a:off x="0" y="0"/>
-          <a:ext cx="0" cy="0"/>
-          <a:chOff x="0" y="0"/>
-          <a:chExt cx="0" cy="0"/>
-        </a:xfrm>
-      </p:grpSpPr>
-      <p:sp>
-        <p:nvSpPr>
-          <p:cNvPr id="2" name="Slide Image Placeholder 1"/>
-          <p:cNvSpPr>
-            <a:spLocks noGrp="1"/>
-          </p:cNvSpPr>
-          <p:nvPr>
-            <p:ph type="sldImg" idx="2"/>
-          </p:nvPr>
-        </p:nvSpPr>
-        <p:spPr/>
-      </p:sp>
-      <p:sp>
-        <p:nvSpPr>
-          <p:cNvPr id="3" name="Notes Placeholder 2"/>
-          <p:cNvSpPr>
-            <a:spLocks noGrp="1"/>
-          </p:cNvSpPr>
-          <p:nvPr>
-            <p:ph type="body" idx="3" sz="quarter"/>
-          </p:nvPr>
-        </p:nvSpPr>
-        <p:spPr/>
-        <p:txBody>
-          <a:bodyPr/>
-          <a:lstStyle/>
-          <a:p>
-            <a:r>
-              <a:t>TIMING: 2 minutes</a:t>
-            </a:r>
-          </a:p>
-          <a:p>
-            <a:r>
-              <a:t>- Two facts: NOT A ROGUE PATCH (calibration / integration / certification / maintenance -&gt; sustained engineering), and the work was DELEGATED too (Volkswagen -&gt; IAV -&gt; continued engineering).</a:t>
-            </a:r>
-          </a:p>
-          <a:p>
-            <a:r>
-              <a:t>- The scale question is a seed, not the headline: "one unethical programmer" becomes an increasingly implausible causal model. Do not let it dominate.</a:t>
+              <a:t>TIMING: 2-3 minutes</a:t>
+            </a:r>
+          </a:p>
+          <a:p>
+            <a:r>
+              <a:t>- The point: the ordinary speak-up control ACTUALLY FIRED - objection raised, supported, escalated - and the November 2006 decision was to continue, recorded in substance as "not to get caught."</a:t>
+            </a:r>
+          </a:p>
+          <a:p>
+            <a:r>
+              <a:t>- And the engineering system kept producing: not a rogue patch (calibration / integration / certification / maintenance -&gt; sustained engineering), and the work was delegated too (Volkswagen -&gt; IAV -&gt; continued engineering).</a:t>
+            </a:r>
+          </a:p>
+          <a:p>
+            <a:r>
+              <a:t>- Not an ethics seminar - the engineering question is what happened AFTER the human control fired. The scale question seeds the causal-model section; "one unethical programmer" becomes an increasingly implausible causal model. Do not let it dominate.</a:t>
             </a:r>
           </a:p>
         </p:txBody>
@@ -7500,7 +7424,7 @@
           <a:p>
             <a:fld id="{8CF8A65D-8523-4C39-BD83-5C787F1FA9B3}" type="slidenum">
               <a:rPr lang="en-US" smtClean="0"/>
-              <a:t>10</a:t>
+              <a:t>9</a:t>
             </a:fld>
             <a:endParaRPr lang="en-US"/>
           </a:p>
@@ -8155,7 +8079,7 @@
           <a:p>
             <a:fld id="{1CC19601-3229-4026-8A65-27C733DA7C77}" type="slidenum">
               <a:rPr lang="en-US" smtClean="0"/>
-              <a:t>11</a:t>
+              <a:t>10</a:t>
             </a:fld>
             <a:endParaRPr lang="en-US"/>
           </a:p>
@@ -8665,7 +8589,7 @@
           <a:p>
             <a:fld id="{3B223778-6764-4D81-904E-8786918EE0A1}" type="slidenum">
               <a:rPr lang="en-US" smtClean="0"/>
-              <a:t>12</a:t>
+              <a:t>11</a:t>
             </a:fld>
             <a:endParaRPr lang="en-US"/>
           </a:p>
@@ -8852,7 +8776,7 @@
           <a:p>
             <a:fld id="{00F42B8D-282B-4541-BC87-223291F13518}" type="slidenum">
               <a:rPr lang="en-US" smtClean="0"/>
-              <a:t>13</a:t>
+              <a:t>12</a:t>
             </a:fld>
             <a:endParaRPr lang="en-US"/>
           </a:p>
@@ -8988,7 +8912,7 @@
           <a:p>
             <a:fld id="{8D34505B-00B1-4572-8080-1F84ADF8E747}" type="slidenum">
               <a:rPr lang="en-US" smtClean="0"/>
-              <a:t>14</a:t>
+              <a:t>13</a:t>
             </a:fld>
             <a:endParaRPr lang="en-US"/>
           </a:p>
@@ -9397,7 +9321,7 @@
           <a:p>
             <a:fld id="{E3DB674E-A080-44A8-A874-38AE3C84A5E2}" type="slidenum">
               <a:rPr lang="en-US" smtClean="0"/>
-              <a:t>15</a:t>
+              <a:t>14</a:t>
             </a:fld>
             <a:endParaRPr lang="en-US"/>
           </a:p>
@@ -10534,7 +10458,7 @@
           <a:p>
             <a:fld id="{914DCAD9-F068-4234-801B-B81BE39514E5}" type="slidenum">
               <a:rPr lang="en-US" smtClean="0"/>
-              <a:t>16</a:t>
+              <a:t>15</a:t>
             </a:fld>
             <a:endParaRPr lang="en-US"/>
           </a:p>
@@ -10901,7 +10825,7 @@
           <a:p>
             <a:fld id="{21CAE056-AEB1-4FA5-BA70-2608DF341BC7}" type="slidenum">
               <a:rPr lang="en-US" smtClean="0"/>
-              <a:t>17</a:t>
+              <a:t>16</a:t>
             </a:fld>
             <a:endParaRPr lang="en-US"/>
           </a:p>
@@ -11494,7 +11418,7 @@
           <a:p>
             <a:fld id="{A5E8DDF8-F0A4-457E-8C49-34448B87F78F}" type="slidenum">
               <a:rPr lang="en-US" smtClean="0"/>
-              <a:t>18</a:t>
+              <a:t>17</a:t>
             </a:fld>
             <a:endParaRPr lang="en-US"/>
           </a:p>
@@ -12096,7 +12020,7 @@
           <a:p>
             <a:fld id="{A2504DDB-3E3B-4B22-928E-39EF9EC13EA2}" type="slidenum">
               <a:rPr lang="en-US" smtClean="0"/>
-              <a:t>19</a:t>
+              <a:t>18</a:t>
             </a:fld>
             <a:endParaRPr lang="en-US"/>
           </a:p>
@@ -13018,7 +12942,7 @@
           <a:p>
             <a:fld id="{D6607EED-2C17-4005-9FF9-5E7D14817CFB}" type="slidenum">
               <a:rPr lang="en-US" smtClean="0"/>
-              <a:t>20</a:t>
+              <a:t>19</a:t>
             </a:fld>
             <a:endParaRPr lang="en-US"/>
           </a:p>
@@ -13205,7 +13129,7 @@
           <a:p>
             <a:fld id="{CB54B3D1-5BA3-40A8-8017-74A0DF3C7182}" type="slidenum">
               <a:rPr lang="en-US" smtClean="0"/>
-              <a:t>21</a:t>
+              <a:t>20</a:t>
             </a:fld>
             <a:endParaRPr lang="en-US"/>
           </a:p>
@@ -13720,7 +13644,7 @@
           <a:p>
             <a:fld id="{CB54B3D1-5BA3-40A8-8017-74A0DF3C7182}" type="slidenum">
               <a:rPr lang="en-US" smtClean="0"/>
-              <a:t>22</a:t>
+              <a:t>21</a:t>
             </a:fld>
             <a:endParaRPr lang="en-US"/>
           </a:p>
@@ -14493,7 +14417,7 @@
           <a:p>
             <a:fld id="{3DC31DEB-C161-48EB-8EC4-D4D18487B0EB}" type="slidenum">
               <a:rPr lang="en-US" smtClean="0"/>
-              <a:t>23</a:t>
+              <a:t>22</a:t>
             </a:fld>
             <a:endParaRPr lang="en-US"/>
           </a:p>
@@ -15117,7 +15041,7 @@
           <a:p>
             <a:fld id="{BBD7B01D-2451-459F-B1A1-0BB2DA8CD569}" type="slidenum">
               <a:rPr lang="en-US" smtClean="0"/>
-              <a:t>24</a:t>
+              <a:t>23</a:t>
             </a:fld>
             <a:endParaRPr lang="en-US"/>
           </a:p>
@@ -15624,7 +15548,7 @@
           <a:p>
             <a:fld id="{B27BF211-A452-4B62-B65D-7ABF1FF8B2F5}" type="slidenum">
               <a:rPr lang="en-US" smtClean="0"/>
-              <a:t>25</a:t>
+              <a:t>24</a:t>
             </a:fld>
             <a:endParaRPr lang="en-US"/>
           </a:p>
@@ -16399,7 +16323,7 @@
           <a:p>
             <a:fld id="{6DD32251-42D1-4E05-B955-B2D4D97C7069}" type="slidenum">
               <a:rPr lang="en-US" smtClean="0"/>
-              <a:t>26</a:t>
+              <a:t>25</a:t>
             </a:fld>
             <a:endParaRPr lang="en-US"/>
           </a:p>
@@ -16540,7 +16464,7 @@
           <a:p>
             <a:fld id="{5CEC7D30-3F3A-40A5-AB25-FC380CDCDC59}" type="slidenum">
               <a:rPr lang="en-US" smtClean="0"/>
-              <a:t>27</a:t>
+              <a:t>26</a:t>
             </a:fld>
             <a:endParaRPr lang="en-US"/>
           </a:p>
@@ -16727,7 +16651,7 @@
           <a:p>
             <a:fld id="{9D5CC310-9C8D-49B0-9A1E-6DB1095504DF}" type="slidenum">
               <a:rPr lang="en-US" smtClean="0"/>
-              <a:t>28</a:t>
+              <a:t>27</a:t>
             </a:fld>
             <a:endParaRPr lang="en-US"/>
           </a:p>
@@ -17246,7 +17170,7 @@
           <a:p>
             <a:fld id="{5853B7DD-E055-4162-94C7-77FA73E23512}" type="slidenum">
               <a:rPr lang="en-US" smtClean="0"/>
-              <a:t>29</a:t>
+              <a:t>28</a:t>
             </a:fld>
             <a:endParaRPr lang="en-US"/>
           </a:p>
@@ -18023,7 +17947,7 @@
           <a:p>
             <a:fld id="{6A1DACA4-9A95-4C77-B245-2C307F8CACFD}" type="slidenum">
               <a:rPr lang="en-US" smtClean="0"/>
-              <a:t>30</a:t>
+              <a:t>29</a:t>
             </a:fld>
             <a:endParaRPr lang="en-US"/>
           </a:p>
@@ -18258,7 +18182,7 @@
           <a:p>
             <a:fld id="{F164AA00-212F-409D-8EDE-8F6B572B597D}" type="slidenum">
               <a:rPr lang="en-US" smtClean="0"/>
-              <a:t>31</a:t>
+              <a:t>30</a:t>
             </a:fld>
             <a:endParaRPr lang="en-US"/>
           </a:p>
@@ -18497,7 +18421,7 @@
           <a:p>
             <a:fld id="{AFA6771E-93A8-4AA7-A54D-D336B382D315}" type="slidenum">
               <a:rPr lang="en-US" smtClean="0"/>
-              <a:t>32</a:t>
+              <a:t>31</a:t>
             </a:fld>
             <a:endParaRPr lang="en-US"/>
           </a:p>
@@ -18946,7 +18870,7 @@
           <a:p>
             <a:fld id="{7288240E-6A77-4EF8-962D-68D6FAD0FBF7}" type="slidenum">
               <a:rPr lang="en-US" smtClean="0"/>
-              <a:t>33</a:t>
+              <a:t>32</a:t>
             </a:fld>
             <a:endParaRPr lang="en-US"/>
           </a:p>
@@ -19133,7 +19057,7 @@
           <a:p>
             <a:fld id="{B1FABF6A-C69A-47A3-8221-3F34D9E54C93}" type="slidenum">
               <a:rPr lang="en-US" smtClean="0"/>
-              <a:t>34</a:t>
+              <a:t>33</a:t>
             </a:fld>
             <a:endParaRPr lang="en-US"/>
           </a:p>
@@ -19676,7 +19600,7 @@
           <a:p>
             <a:fld id="{54DE72B0-FFEB-4C83-B4BD-F25961BEDFCA}" type="slidenum">
               <a:rPr lang="en-US" smtClean="0"/>
-              <a:t>35</a:t>
+              <a:t>34</a:t>
             </a:fld>
             <a:endParaRPr lang="en-US"/>
           </a:p>
@@ -20359,7 +20283,7 @@
           <a:p>
             <a:fld id="{9ABD6463-1069-4796-B206-4858CF08A11C}" type="slidenum">
               <a:rPr lang="en-US" smtClean="0"/>
-              <a:t>36</a:t>
+              <a:t>35</a:t>
             </a:fld>
             <a:endParaRPr lang="en-US"/>
           </a:p>
@@ -20836,7 +20760,7 @@
           <a:p>
             <a:fld id="{649F5B17-D92E-42C9-9606-E4DCBD101C76}" type="slidenum">
               <a:rPr lang="en-US" smtClean="0"/>
-              <a:t>37</a:t>
+              <a:t>36</a:t>
             </a:fld>
             <a:endParaRPr lang="en-US"/>
           </a:p>
@@ -21261,7 +21185,7 @@
           <a:p>
             <a:fld id="{ECC62C95-06B7-478B-9E6C-BA793986094F}" type="slidenum">
               <a:rPr lang="en-US" smtClean="0"/>
-              <a:t>38</a:t>
+              <a:t>37</a:t>
             </a:fld>
             <a:endParaRPr lang="en-US"/>
           </a:p>
@@ -21490,7 +21414,7 @@
           <a:p>
             <a:fld id="{39B9D2FE-B078-4487-9F5F-2EEF4DFC66C2}" type="slidenum">
               <a:rPr lang="en-US" smtClean="0"/>
-              <a:t>39</a:t>
+              <a:t>38</a:t>
             </a:fld>
             <a:endParaRPr lang="en-US"/>
           </a:p>
@@ -22609,7 +22533,7 @@
           <a:p>
             <a:fld id="{CB5F44A2-D062-441C-AD58-E2D5787D8459}" type="slidenum">
               <a:rPr lang="en-US" smtClean="0"/>
-              <a:t>40</a:t>
+              <a:t>39</a:t>
             </a:fld>
             <a:endParaRPr lang="en-US"/>
           </a:p>
@@ -24427,7 +24351,7 @@
                   <a:srgbClr val="000000"/>
                 </a:solidFill>
               </a:rPr>
-              <a:t>Engineers objected and escalated</a:t>
+              <a:t>Engineers objected — and kept engineering it</a:t>
             </a:r>
           </a:p>
         </p:txBody>
@@ -24463,8 +24387,8 @@
         </p:nvSpPr>
         <p:spPr>
           <a:xfrm>
-            <a:off x="411480" y="1051560"/>
-            <a:ext cx="8321040" cy="914400"/>
+            <a:off x="411480" y="1005840"/>
+            <a:ext cx="8321040" cy="960120"/>
           </a:xfrm>
           <a:prstGeom prst="rect">
             <a:avLst/>
@@ -24494,7 +24418,7 @@
           </a:fontRef>
         </p:style>
         <p:txBody>
-          <a:bodyPr rtlCol="0" anchor="t" wrap="square" lIns="27432" rIns="27432" tIns="22860" bIns="22860"/>
+          <a:bodyPr rtlCol="0" anchor="ctr" wrap="square" lIns="27432" rIns="27432" tIns="22860" bIns="22860"/>
           <a:lstStyle/>
           <a:p>
             <a:pPr algn="l"/>
@@ -24526,7 +24450,7 @@
         <p:spPr>
           <a:xfrm>
             <a:off x="411480" y="2148840"/>
-            <a:ext cx="8321040" cy="914400"/>
+            <a:ext cx="8321040" cy="1188720"/>
           </a:xfrm>
           <a:prstGeom prst="rect">
             <a:avLst/>
@@ -24556,7 +24480,7 @@
           </a:fontRef>
         </p:style>
         <p:txBody>
-          <a:bodyPr rtlCol="0" anchor="t" wrap="square" lIns="27432" rIns="27432" tIns="22860" bIns="22860"/>
+          <a:bodyPr rtlCol="0" anchor="ctr" wrap="square" lIns="27432" rIns="27432" tIns="22860" bIns="22860"/>
           <a:lstStyle/>
           <a:p>
             <a:pPr algn="l"/>
@@ -24574,7 +24498,15 @@
                   <a:srgbClr val="555960"/>
                 </a:solidFill>
               </a:rPr>
-              <a:t>The relevant supervisor was briefed on its purpose and design, and decided production should continue.</a:t>
+              <a:t>The supervisor, briefed on its purpose and design, decided production should continue; the plea agreement records the instruction, in substance, as </a:t>
+            </a:r>
+            <a:r>
+              <a:rPr sz="2000" b="1" i="0">
+                <a:solidFill>
+                  <a:srgbClr val="9A3F12"/>
+                </a:solidFill>
+              </a:rPr>
+              <a:t>“not to get caught.”</a:t>
             </a:r>
           </a:p>
         </p:txBody>
@@ -24587,8 +24519,8 @@
         </p:nvSpPr>
         <p:spPr>
           <a:xfrm>
-            <a:off x="411480" y="3246120"/>
-            <a:ext cx="8321040" cy="914400"/>
+            <a:off x="411480" y="3520440"/>
+            <a:ext cx="8321040" cy="960120"/>
           </a:xfrm>
           <a:prstGeom prst="rect">
             <a:avLst/>
@@ -24618,7 +24550,7 @@
           </a:fontRef>
         </p:style>
         <p:txBody>
-          <a:bodyPr rtlCol="0" anchor="t" wrap="square" lIns="27432" rIns="27432" tIns="22860" bIns="22860"/>
+          <a:bodyPr rtlCol="0" anchor="ctr" wrap="square" lIns="27432" rIns="27432" tIns="22860" bIns="22860"/>
           <a:lstStyle/>
           <a:p>
             <a:pPr algn="l"/>
@@ -24628,7 +24560,7 @@
                   <a:srgbClr val="5C4826"/>
                 </a:solidFill>
               </a:rPr>
-              <a:t>The plea agreement </a:t>
+              <a:t>And the engineering continued. </a:t>
             </a:r>
             <a:r>
               <a:rPr sz="2000" b="0" i="0">
@@ -24636,15 +24568,7 @@
                   <a:srgbClr val="555960"/>
                 </a:solidFill>
               </a:rPr>
-              <a:t>records the instruction, in substance, as </a:t>
-            </a:r>
-            <a:r>
-              <a:rPr sz="2000" b="1" i="0">
-                <a:solidFill>
-                  <a:srgbClr val="9A3F12"/>
-                </a:solidFill>
-              </a:rPr>
-              <a:t>“not to get caught.”</a:t>
+              <a:t>Not a rogue patch: calibration, integration, certification, maintenance — and delegated too (Volkswagen → IAV).</a:t>
             </a:r>
           </a:p>
         </p:txBody>
@@ -24657,8 +24581,8 @@
         </p:nvSpPr>
         <p:spPr>
           <a:xfrm>
-            <a:off x="411480" y="4572000"/>
-            <a:ext cx="8321040" cy="731520"/>
+            <a:off x="411480" y="4709160"/>
+            <a:ext cx="8321040" cy="502920"/>
           </a:xfrm>
           <a:prstGeom prst="rect">
             <a:avLst/>
@@ -24673,12 +24597,12 @@
           <a:p>
             <a:pPr algn="ctr"/>
             <a:r>
-              <a:rPr sz="2200" b="0" i="1">
+              <a:rPr sz="2000" b="1" i="0">
                 <a:solidFill>
                   <a:srgbClr val="8E6F3E"/>
                 </a:solidFill>
               </a:rPr>
-              <a:t>Was raising the concern the end of those engineers’ professional responsibility?</a:t>
+              <a:t>How many people does it take to sustain this in hundreds of thousands of U.S. vehicles?</a:t>
             </a:r>
           </a:p>
         </p:txBody>
@@ -24691,7 +24615,7 @@
         </p:nvSpPr>
         <p:spPr>
           <a:xfrm>
-            <a:off x="274320" y="5852159"/>
+            <a:off x="274320" y="5852160"/>
             <a:ext cx="8595360" cy="566928"/>
           </a:xfrm>
           <a:prstGeom prst="rect">
@@ -24731,231 +24655,6 @@
                 </a:solidFill>
               </a:rPr>
               <a:t>Was escalation enough?</a:t>
-            </a:r>
-          </a:p>
-        </p:txBody>
-      </p:sp>
-    </p:spTree>
-  </p:cSld>
-  <p:clrMapOvr>
-    <a:masterClrMapping/>
-  </p:clrMapOvr>
-</p:sld>
-</file>
-
-<file path=ppt/slides/slide7.xml><?xml version="1.0" encoding="utf-8"?>
-<p:sld xmlns:a="http://schemas.openxmlformats.org/drawingml/2006/main" xmlns:p="http://schemas.openxmlformats.org/presentationml/2006/main" xmlns:r="http://schemas.openxmlformats.org/officeDocument/2006/relationships">
-  <p:cSld>
-    <p:spTree>
-      <p:nvGrpSpPr>
-        <p:cNvPr id="1" name=""/>
-        <p:cNvGrpSpPr/>
-        <p:nvPr/>
-      </p:nvGrpSpPr>
-      <p:grpSpPr/>
-      <p:sp>
-        <p:nvSpPr>
-          <p:cNvPr id="3" name="Title 2"/>
-          <p:cNvSpPr>
-            <a:spLocks noGrp="1"/>
-          </p:cNvSpPr>
-          <p:nvPr>
-            <p:ph type="title"/>
-          </p:nvPr>
-        </p:nvSpPr>
-        <p:spPr/>
-        <p:txBody>
-          <a:bodyPr/>
-          <a:lstStyle/>
-          <a:p>
-            <a:r>
-              <a:rPr sz="2400" b="0" i="0">
-                <a:solidFill>
-                  <a:srgbClr val="000000"/>
-                </a:solidFill>
-              </a:rPr>
-              <a:t>And yet engineers kept engineering it</a:t>
-            </a:r>
-          </a:p>
-        </p:txBody>
-      </p:sp>
-      <p:sp>
-        <p:nvSpPr>
-          <p:cNvPr id="900" name="Slide Number Placeholder 900"/>
-          <p:cNvSpPr>
-            <a:spLocks noGrp="1"/>
-          </p:cNvSpPr>
-          <p:nvPr>
-            <p:ph type="sldNum" sz="quarter" idx="4"/>
-          </p:nvPr>
-        </p:nvSpPr>
-        <p:spPr/>
-        <p:txBody>
-          <a:bodyPr/>
-          <a:lstStyle/>
-          <a:p>
-            <a:fld id="{18B79205-D12A-40D3-8F8D-9C5E87B1B06B}" type="slidenum">
-              <a:rPr lang="en-US" smtClean="0"/>
-              <a:t>7</a:t>
-            </a:fld>
-            <a:endParaRPr lang="en-US"/>
-          </a:p>
-        </p:txBody>
-      </p:sp>
-      <p:sp>
-        <p:nvSpPr>
-          <p:cNvPr id="901" name="Card"/>
-          <p:cNvSpPr/>
-          <p:nvPr/>
-        </p:nvSpPr>
-        <p:spPr>
-          <a:xfrm>
-            <a:off x="411480" y="1143000"/>
-            <a:ext cx="8321040" cy="1325880"/>
-          </a:xfrm>
-          <a:prstGeom prst="rect">
-            <a:avLst/>
-          </a:prstGeom>
-          <a:solidFill>
-            <a:srgbClr val="F5F1E8"/>
-          </a:solidFill>
-          <a:ln w="12700">
-            <a:solidFill>
-              <a:srgbClr val="C9B991"/>
-            </a:solidFill>
-          </a:ln>
-          <a:effectLst/>
-        </p:spPr>
-        <p:style>
-          <a:lnRef idx="1">
-            <a:schemeClr val="accent1"/>
-          </a:lnRef>
-          <a:fillRef idx="3">
-            <a:schemeClr val="accent1"/>
-          </a:fillRef>
-          <a:effectRef idx="2">
-            <a:schemeClr val="accent1"/>
-          </a:effectRef>
-          <a:fontRef idx="minor">
-            <a:schemeClr val="lt1"/>
-          </a:fontRef>
-        </p:style>
-        <p:txBody>
-          <a:bodyPr rtlCol="0" anchor="t" wrap="square" lIns="27432" rIns="27432" tIns="22860" bIns="22860"/>
-          <a:lstStyle/>
-          <a:p>
-            <a:pPr algn="l"/>
-            <a:r>
-              <a:rPr sz="2000" b="1" i="0">
-                <a:solidFill>
-                  <a:srgbClr val="5C4826"/>
-                </a:solidFill>
-              </a:rPr>
-              <a:t>Not a rogue patch. </a:t>
-            </a:r>
-            <a:r>
-              <a:rPr sz="2000" b="0" i="0">
-                <a:solidFill>
-                  <a:srgbClr val="555960"/>
-                </a:solidFill>
-              </a:rPr>
-              <a:t>The defeat device required calibration, integration, certification work, and continued maintenance - sustained engineering.</a:t>
-            </a:r>
-          </a:p>
-        </p:txBody>
-      </p:sp>
-      <p:sp>
-        <p:nvSpPr>
-          <p:cNvPr id="902" name="Card"/>
-          <p:cNvSpPr/>
-          <p:nvPr/>
-        </p:nvSpPr>
-        <p:spPr>
-          <a:xfrm>
-            <a:off x="411480" y="2743200"/>
-            <a:ext cx="8321040" cy="1325880"/>
-          </a:xfrm>
-          <a:prstGeom prst="rect">
-            <a:avLst/>
-          </a:prstGeom>
-          <a:solidFill>
-            <a:srgbClr val="F5F1E8"/>
-          </a:solidFill>
-          <a:ln w="12700">
-            <a:solidFill>
-              <a:srgbClr val="C9B991"/>
-            </a:solidFill>
-          </a:ln>
-          <a:effectLst/>
-        </p:spPr>
-        <p:style>
-          <a:lnRef idx="1">
-            <a:schemeClr val="accent1"/>
-          </a:lnRef>
-          <a:fillRef idx="3">
-            <a:schemeClr val="accent1"/>
-          </a:fillRef>
-          <a:effectRef idx="2">
-            <a:schemeClr val="accent1"/>
-          </a:effectRef>
-          <a:fontRef idx="minor">
-            <a:schemeClr val="lt1"/>
-          </a:fontRef>
-        </p:style>
-        <p:txBody>
-          <a:bodyPr rtlCol="0" anchor="t" wrap="square" lIns="27432" rIns="27432" tIns="22860" bIns="22860"/>
-          <a:lstStyle/>
-          <a:p>
-            <a:pPr algn="l"/>
-            <a:r>
-              <a:rPr sz="2000" b="1" i="0">
-                <a:solidFill>
-                  <a:srgbClr val="5C4826"/>
-                </a:solidFill>
-              </a:rPr>
-              <a:t>Delegated, too. </a:t>
-            </a:r>
-            <a:r>
-              <a:rPr sz="2000" b="0" i="0">
-                <a:solidFill>
-                  <a:srgbClr val="555960"/>
-                </a:solidFill>
-              </a:rPr>
-              <a:t>Volkswagen delegated software-development and exhaust-after-treatment work to IAV, where the test-recognition work continued under a manager who knew its purpose.</a:t>
-            </a:r>
-          </a:p>
-        </p:txBody>
-      </p:sp>
-      <p:sp>
-        <p:nvSpPr>
-          <p:cNvPr id="910" name="Label"/>
-          <p:cNvSpPr txBox="1"/>
-          <p:nvPr/>
-        </p:nvSpPr>
-        <p:spPr>
-          <a:xfrm>
-            <a:off x="411480" y="4480560"/>
-            <a:ext cx="8321040" cy="548640"/>
-          </a:xfrm>
-          <a:prstGeom prst="rect">
-            <a:avLst/>
-          </a:prstGeom>
-          <a:noFill/>
-        </p:spPr>
-        <p:txBody>
-          <a:bodyPr wrap="square" anchor="t" lIns="27432" rIns="27432" tIns="22860" bIns="22860">
-            <a:spAutoFit/>
-          </a:bodyPr>
-          <a:lstStyle/>
-          <a:p>
-            <a:pPr algn="ctr"/>
-            <a:r>
-              <a:rPr sz="2000" b="1" i="0">
-                <a:solidFill>
-                  <a:srgbClr val="8E6F3E"/>
-                </a:solidFill>
-              </a:rPr>
-              <a:t>How many people does it take to sustain this in hundreds of thousands of U.S. vehicles?</a:t>
             </a:r>
           </a:p>
         </p:txBody>
@@ -25021,7 +24720,7 @@
           <a:p>
             <a:fld id="{69344503-8987-48F2-81C4-B15A70530D60}" type="slidenum">
               <a:rPr lang="en-US" smtClean="0"/>
-              <a:t>8</a:t>
+              <a:t>7</a:t>
             </a:fld>
             <a:endParaRPr lang="en-US"/>
           </a:p>
@@ -25439,7 +25138,7 @@
           <a:p>
             <a:fld id="{34DDAC39-E592-4BC0-8D18-7414C01DF0F9}" type="slidenum">
               <a:rPr lang="en-US" smtClean="0"/>
-              <a:t>9</a:t>
+              <a:t>8</a:t>
             </a:fld>
             <a:endParaRPr lang="en-US"/>
           </a:p>

</xml_diff>

<commit_message>
deck 2-4: STAMP control structure crosses organizations; slide-35 supplier notes
Slide 16: BOSCH and IAV join the STAMP diagram flanking ENGINEERING,
with supply and delegation arrows, so the control structure shows
control distributed across organizations rather than contained in
one; notes explain that a STAMP model drawn inside one company's
walls misses the control relationships that crossed them.

Slide 35: notes-only - the governance-conversion counterfactual
revisits supplier obligations: an obligation living in the
engineering environment meets a supplied capability on arrival at
the organizational boundary, answering the slide-4 question
structurally. On-slide content untouched.

39 slides; pptx_validate 0/0; slidenum caches refreshed.
</commit_message>
<xml_diff>
--- a/course/lectures/act-2-delegation-and-control/04-failure-aware-engineering/2-4-Failure-Aware-Engineering.pptx
+++ b/course/lectures/act-2-delegation-and-control/04-failure-aware-engineering/2-4-Failure-Aware-Engineering.pptx
@@ -1133,6 +1133,11 @@
           </a:p>
           <a:p>
             <a:r>
+              <a:t>- The control structure crosses company boundaries: Bosch supplies the engine-control capability into the engineering process, and Volkswagen delegated engineering work to IAV. A STAMP model drawn inside one organization's walls misses the control relationships that crossed them - and in this case, that is where much of the action was.</a:t>
+            </a:r>
+          </a:p>
+          <a:p>
+            <a:r>
               <a:t>- Present it seriously - it is a modeling discipline, not a punchline. The cost arrives on the next slide: breadth demands evidence and authority.</a:t>
             </a:r>
           </a:p>
@@ -2764,6 +2769,11 @@
           <a:p>
             <a:r>
               <a:t>- The callback: Volkswagen has been absent for roughly ten slides; returning to it here is the payoff. A much better final discussion than "who was unethical?"</a:t>
+            </a:r>
+          </a:p>
+          <a:p>
+            <a:r>
+              <a:t>- Supplier obligations, one more time: the counterfactual also changes what it means for a capability to cross an organizational boundary. If the compliance obligation lives in the engineering environment - model, independent validation, release gate - then a supplied capability (Bosch -&gt; Volkswagen) meets the obligation on arrival, instead of depending on what individuals at either company remembered, or chose, to enforce. The slide-4 question - who is responsible for how a supplied capability is used? - gets a structural answer: the environment that integrates it carries the obligation.</a:t>
             </a:r>
           </a:p>
           <a:p>
@@ -10273,6 +10283,110 @@
           </a:p>
         </p:txBody>
       </p:sp>
+      <p:sp>
+        <p:nvSpPr>
+          <p:cNvPr id="901" name="Block"/>
+          <p:cNvSpPr/>
+          <p:nvPr/>
+        </p:nvSpPr>
+        <p:spPr>
+          <a:xfrm>
+            <a:off x="6629400" y="3200400"/>
+            <a:ext cx="2011680" cy="640080"/>
+          </a:xfrm>
+          <a:prstGeom prst="rect">
+            <a:avLst/>
+          </a:prstGeom>
+          <a:solidFill>
+            <a:srgbClr val="8E6F3E"/>
+          </a:solidFill>
+          <a:ln>
+            <a:noFill/>
+          </a:ln>
+          <a:effectLst/>
+        </p:spPr>
+        <p:style>
+          <a:lnRef idx="1">
+            <a:schemeClr val="accent1"/>
+          </a:lnRef>
+          <a:fillRef idx="3">
+            <a:schemeClr val="accent1"/>
+          </a:fillRef>
+          <a:effectRef idx="2">
+            <a:schemeClr val="accent1"/>
+          </a:effectRef>
+          <a:fontRef idx="minor">
+            <a:schemeClr val="lt1"/>
+          </a:fontRef>
+        </p:style>
+        <p:txBody>
+          <a:bodyPr rtlCol="0" anchor="ctr" wrap="square" lIns="27432" rIns="27432" tIns="22860" bIns="22860"/>
+          <a:lstStyle/>
+          <a:p>
+            <a:pPr algn="ctr"/>
+            <a:r>
+              <a:rPr sz="2000" b="1" i="0">
+                <a:solidFill>
+                  <a:srgbClr val="FFFFFF"/>
+                </a:solidFill>
+              </a:rPr>
+              <a:t>IAV</a:t>
+            </a:r>
+          </a:p>
+        </p:txBody>
+      </p:sp>
+      <p:sp>
+        <p:nvSpPr>
+          <p:cNvPr id="901" name="Block"/>
+          <p:cNvSpPr/>
+          <p:nvPr/>
+        </p:nvSpPr>
+        <p:spPr>
+          <a:xfrm>
+            <a:off x="502920" y="3200400"/>
+            <a:ext cx="2011680" cy="640080"/>
+          </a:xfrm>
+          <a:prstGeom prst="rect">
+            <a:avLst/>
+          </a:prstGeom>
+          <a:solidFill>
+            <a:srgbClr val="8E6F3E"/>
+          </a:solidFill>
+          <a:ln>
+            <a:noFill/>
+          </a:ln>
+          <a:effectLst/>
+        </p:spPr>
+        <p:style>
+          <a:lnRef idx="1">
+            <a:schemeClr val="accent1"/>
+          </a:lnRef>
+          <a:fillRef idx="3">
+            <a:schemeClr val="accent1"/>
+          </a:fillRef>
+          <a:effectRef idx="2">
+            <a:schemeClr val="accent1"/>
+          </a:effectRef>
+          <a:fontRef idx="minor">
+            <a:schemeClr val="lt1"/>
+          </a:fontRef>
+        </p:style>
+        <p:txBody>
+          <a:bodyPr rtlCol="0" anchor="ctr" wrap="square" lIns="27432" rIns="27432" tIns="22860" bIns="22860"/>
+          <a:lstStyle/>
+          <a:p>
+            <a:pPr algn="ctr"/>
+            <a:r>
+              <a:rPr sz="2000" b="1" i="0">
+                <a:solidFill>
+                  <a:srgbClr val="FFFFFF"/>
+                </a:solidFill>
+              </a:rPr>
+              <a:t>BOSCH</a:t>
+            </a:r>
+          </a:p>
+        </p:txBody>
+      </p:sp>
       <p:cxnSp>
         <p:nvCxnSpPr>
           <p:cNvPr id="902" name="Connector 901"/>
@@ -10283,6 +10397,78 @@
           <a:xfrm>
             <a:off x="4023360" y="1828800"/>
             <a:ext cx="0" cy="365760"/>
+          </a:xfrm>
+          <a:prstGeom prst="line">
+            <a:avLst/>
+          </a:prstGeom>
+          <a:ln w="19050">
+            <a:solidFill>
+              <a:srgbClr val="8E6F3E"/>
+            </a:solidFill>
+            <a:tailEnd type="triangle"/>
+          </a:ln>
+        </p:spPr>
+        <p:style>
+          <a:lnRef idx="2">
+            <a:schemeClr val="accent1"/>
+          </a:lnRef>
+          <a:fillRef idx="0">
+            <a:schemeClr val="accent1"/>
+          </a:fillRef>
+          <a:effectRef idx="1">
+            <a:schemeClr val="accent1"/>
+          </a:effectRef>
+          <a:fontRef idx="minor">
+            <a:schemeClr val="tx1"/>
+          </a:fontRef>
+        </p:style>
+      </p:cxnSp>
+      <p:cxnSp>
+        <p:nvCxnSpPr>
+          <p:cNvPr id="902" name="Connector 901"/>
+          <p:cNvCxnSpPr/>
+          <p:nvPr/>
+        </p:nvCxnSpPr>
+        <p:spPr>
+          <a:xfrm>
+            <a:off x="6217920" y="3520440"/>
+            <a:ext cx="411480" cy="0"/>
+          </a:xfrm>
+          <a:prstGeom prst="line">
+            <a:avLst/>
+          </a:prstGeom>
+          <a:ln w="19050">
+            <a:solidFill>
+              <a:srgbClr val="8E6F3E"/>
+            </a:solidFill>
+            <a:tailEnd type="triangle"/>
+          </a:ln>
+        </p:spPr>
+        <p:style>
+          <a:lnRef idx="2">
+            <a:schemeClr val="accent1"/>
+          </a:lnRef>
+          <a:fillRef idx="0">
+            <a:schemeClr val="accent1"/>
+          </a:fillRef>
+          <a:effectRef idx="1">
+            <a:schemeClr val="accent1"/>
+          </a:effectRef>
+          <a:fontRef idx="minor">
+            <a:schemeClr val="tx1"/>
+          </a:fontRef>
+        </p:style>
+      </p:cxnSp>
+      <p:cxnSp>
+        <p:nvCxnSpPr>
+          <p:cNvPr id="902" name="Connector 901"/>
+          <p:cNvCxnSpPr/>
+          <p:nvPr/>
+        </p:nvCxnSpPr>
+        <p:spPr>
+          <a:xfrm>
+            <a:off x="2514600" y="3520440"/>
+            <a:ext cx="411480" cy="0"/>
           </a:xfrm>
           <a:prstGeom prst="line">
             <a:avLst/>

</xml_diff>